<commit_message>
Rebuild Capacity & Overwhelm MHPN session to brand spec
White backgrounds only, dark blue (003366) headings, Aptos font,
no gradients/icons/illustrations. Exact slide text as provided.
Discussion prompts in light grey boxes. Footer on slides 1 and 10 only.

https://claude.ai/code/session_01JPgbNt7mh3RQgUUfUTZPLe
</commit_message>
<xml_diff>
--- a/docs/assets/files/presentations/Capacity_Overwhelm_MHPN_Session.pptx
+++ b/docs/assets/files/presentations/Capacity_Overwhelm_MHPN_Session.pptx
@@ -1658,7 +1658,7 @@
     <p:bg>
       <p:bgPr>
         <a:solidFill>
-          <a:srgbClr val="1B3664"/>
+          <a:srgbClr val="FFFFFF"/>
         </a:solidFill>
       </p:bgPr>
     </p:bg>
@@ -1684,8 +1684,8 @@
         </p:nvSpPr>
         <p:spPr>
           <a:xfrm>
-            <a:off x="457200" y="1645920"/>
-            <a:ext cx="8229600" cy="1097280"/>
+            <a:off x="548640" y="1280160"/>
+            <a:ext cx="8046720" cy="1280160"/>
           </a:xfrm>
           <a:prstGeom prst="rect">
             <a:avLst/>
@@ -1698,20 +1698,43 @@
           <a:lstStyle/>
           <a:p>
             <a:pPr algn="ctr" indent="0" marL="0">
-              <a:buNone/>
-            </a:pPr>
-            <a:r>
-              <a:rPr lang="en-US" sz="3600" b="1" dirty="0">
-                <a:solidFill>
-                  <a:srgbClr val="FFFFFF"/>
-                </a:solidFill>
-                <a:latin typeface="Inter" pitchFamily="34" charset="0"/>
-                <a:ea typeface="Inter" pitchFamily="34" charset="-122"/>
-                <a:cs typeface="Inter" pitchFamily="34" charset="-120"/>
-              </a:rPr>
-              <a:t>Understanding Capacity and Overwhelm in Neurodivergence</a:t>
-            </a:r>
-            <a:endParaRPr lang="en-US" sz="3600" dirty="0"/>
+              <a:lnSpc>
+                <a:spcPct val="115000"/>
+              </a:lnSpc>
+              <a:buNone/>
+            </a:pPr>
+            <a:r>
+              <a:rPr lang="en-US" sz="3200" b="1" dirty="0">
+                <a:solidFill>
+                  <a:srgbClr val="003366"/>
+                </a:solidFill>
+                <a:latin typeface="Aptos" pitchFamily="34" charset="0"/>
+                <a:ea typeface="Aptos" pitchFamily="34" charset="-122"/>
+                <a:cs typeface="Aptos" pitchFamily="34" charset="-120"/>
+              </a:rPr>
+              <a:t>Understanding Capacity and</a:t>
+            </a:r>
+            <a:endParaRPr lang="en-US" sz="3200" dirty="0"/>
+          </a:p>
+          <a:p>
+            <a:pPr algn="ctr" indent="0" marL="0">
+              <a:lnSpc>
+                <a:spcPct val="115000"/>
+              </a:lnSpc>
+              <a:buNone/>
+            </a:pPr>
+            <a:r>
+              <a:rPr lang="en-US" sz="3200" b="1" dirty="0">
+                <a:solidFill>
+                  <a:srgbClr val="003366"/>
+                </a:solidFill>
+                <a:latin typeface="Aptos" pitchFamily="34" charset="0"/>
+                <a:ea typeface="Aptos" pitchFamily="34" charset="-122"/>
+                <a:cs typeface="Aptos" pitchFamily="34" charset="-120"/>
+              </a:rPr>
+              <a:t>Overwhelm in Neurodivergence</a:t>
+            </a:r>
+            <a:endParaRPr lang="en-US" sz="3200" dirty="0"/>
           </a:p>
         </p:txBody>
       </p:sp>
@@ -1723,8 +1746,8 @@
         </p:nvSpPr>
         <p:spPr>
           <a:xfrm>
-            <a:off x="457200" y="2926080"/>
-            <a:ext cx="8229600" cy="731520"/>
+            <a:off x="548640" y="2743200"/>
+            <a:ext cx="8046720" cy="731520"/>
           </a:xfrm>
           <a:prstGeom prst="rect">
             <a:avLst/>
@@ -1737,37 +1760,43 @@
           <a:lstStyle/>
           <a:p>
             <a:pPr algn="ctr" indent="0" marL="0">
-              <a:buNone/>
-            </a:pPr>
-            <a:r>
-              <a:rPr lang="en-US" sz="1800" dirty="0">
-                <a:solidFill>
-                  <a:srgbClr val="5684C4"/>
-                </a:solidFill>
-                <a:latin typeface="Montserrat" pitchFamily="34" charset="0"/>
-                <a:ea typeface="Montserrat" pitchFamily="34" charset="-122"/>
-                <a:cs typeface="Montserrat" pitchFamily="34" charset="-120"/>
+              <a:lnSpc>
+                <a:spcPct val="130000"/>
+              </a:lnSpc>
+              <a:buNone/>
+            </a:pPr>
+            <a:r>
+              <a:rPr lang="en-US" sz="1600" dirty="0">
+                <a:solidFill>
+                  <a:srgbClr val="333333"/>
+                </a:solidFill>
+                <a:latin typeface="Aptos" pitchFamily="34" charset="0"/>
+                <a:ea typeface="Aptos" pitchFamily="34" charset="-122"/>
+                <a:cs typeface="Aptos" pitchFamily="34" charset="-120"/>
               </a:rPr>
               <a:t>NSW Neurodiversity-Affirming Network</a:t>
             </a:r>
-            <a:endParaRPr lang="en-US" sz="1800" dirty="0"/>
+            <a:endParaRPr lang="en-US" sz="1600" dirty="0"/>
           </a:p>
           <a:p>
             <a:pPr algn="ctr" indent="0" marL="0">
-              <a:buNone/>
-            </a:pPr>
-            <a:r>
-              <a:rPr lang="en-US" sz="1800" dirty="0">
-                <a:solidFill>
-                  <a:srgbClr val="5684C4"/>
-                </a:solidFill>
-                <a:latin typeface="Montserrat" pitchFamily="34" charset="0"/>
-                <a:ea typeface="Montserrat" pitchFamily="34" charset="-122"/>
-                <a:cs typeface="Montserrat" pitchFamily="34" charset="-120"/>
-              </a:rPr>
-              <a:t>Peer Learning Session</a:t>
-            </a:r>
-            <a:endParaRPr lang="en-US" sz="1800" dirty="0"/>
+              <a:lnSpc>
+                <a:spcPct val="130000"/>
+              </a:lnSpc>
+              <a:buNone/>
+            </a:pPr>
+            <a:r>
+              <a:rPr lang="en-US" sz="1600" dirty="0">
+                <a:solidFill>
+                  <a:srgbClr val="333333"/>
+                </a:solidFill>
+                <a:latin typeface="Aptos" pitchFamily="34" charset="0"/>
+                <a:ea typeface="Aptos" pitchFamily="34" charset="-122"/>
+                <a:cs typeface="Aptos" pitchFamily="34" charset="-120"/>
+              </a:rPr>
+              <a:t>Peer learning session</a:t>
+            </a:r>
+            <a:endParaRPr lang="en-US" sz="1600" dirty="0"/>
           </a:p>
         </p:txBody>
       </p:sp>
@@ -1779,8 +1808,8 @@
         </p:nvSpPr>
         <p:spPr>
           <a:xfrm>
-            <a:off x="457200" y="4754880"/>
-            <a:ext cx="8229600" cy="274320"/>
+            <a:off x="548640" y="4434840"/>
+            <a:ext cx="8046720" cy="502920"/>
           </a:xfrm>
           <a:prstGeom prst="rect">
             <a:avLst/>
@@ -1793,18 +1822,41 @@
           <a:lstStyle/>
           <a:p>
             <a:pPr algn="ctr" indent="0" marL="0">
+              <a:lnSpc>
+                <a:spcPct val="120000"/>
+              </a:lnSpc>
               <a:buNone/>
             </a:pPr>
             <a:r>
               <a:rPr lang="en-US" sz="900" dirty="0">
                 <a:solidFill>
-                  <a:srgbClr val="DDDDDD"/>
-                </a:solidFill>
-                <a:latin typeface="Montserrat" pitchFamily="34" charset="0"/>
-                <a:ea typeface="Montserrat" pitchFamily="34" charset="-122"/>
-                <a:cs typeface="Montserrat" pitchFamily="34" charset="-120"/>
-              </a:rPr>
-              <a:t>Strengths-Based Coaching and Counselling | www.coach4u.com.au | cath@coach4u.com.au | 0402 313 337</a:t>
+                  <a:srgbClr val="999999"/>
+                </a:solidFill>
+                <a:latin typeface="Aptos" pitchFamily="34" charset="0"/>
+                <a:ea typeface="Aptos" pitchFamily="34" charset="-122"/>
+                <a:cs typeface="Aptos" pitchFamily="34" charset="-120"/>
+              </a:rPr>
+              <a:t>Cath Baker</a:t>
+            </a:r>
+            <a:endParaRPr lang="en-US" sz="900" dirty="0"/>
+          </a:p>
+          <a:p>
+            <a:pPr algn="ctr" indent="0" marL="0">
+              <a:lnSpc>
+                <a:spcPct val="120000"/>
+              </a:lnSpc>
+              <a:buNone/>
+            </a:pPr>
+            <a:r>
+              <a:rPr lang="en-US" sz="900" dirty="0">
+                <a:solidFill>
+                  <a:srgbClr val="999999"/>
+                </a:solidFill>
+                <a:latin typeface="Aptos" pitchFamily="34" charset="0"/>
+                <a:ea typeface="Aptos" pitchFamily="34" charset="-122"/>
+                <a:cs typeface="Aptos" pitchFamily="34" charset="-120"/>
+              </a:rPr>
+              <a:t>Coach4U – Strengths-Based Coaching and Counselling</a:t>
             </a:r>
             <a:endParaRPr lang="en-US" sz="900" dirty="0"/>
           </a:p>
@@ -1824,7 +1876,7 @@
     <p:bg>
       <p:bgPr>
         <a:solidFill>
-          <a:srgbClr val="1B3664"/>
+          <a:srgbClr val="FFFFFF"/>
         </a:solidFill>
       </p:bgPr>
     </p:bg>
@@ -1850,8 +1902,8 @@
         </p:nvSpPr>
         <p:spPr>
           <a:xfrm>
-            <a:off x="457200" y="1371600"/>
-            <a:ext cx="8229600" cy="731520"/>
+            <a:off x="548640" y="365760"/>
+            <a:ext cx="8046720" cy="457200"/>
           </a:xfrm>
           <a:prstGeom prst="rect">
             <a:avLst/>
@@ -1863,21 +1915,21 @@
           <a:bodyPr wrap="square" rtlCol="0" anchor="ctr"/>
           <a:lstStyle/>
           <a:p>
-            <a:pPr algn="ctr" indent="0" marL="0">
-              <a:buNone/>
-            </a:pPr>
-            <a:r>
-              <a:rPr lang="en-US" sz="3600" b="1" dirty="0">
-                <a:solidFill>
-                  <a:srgbClr val="FFFFFF"/>
-                </a:solidFill>
-                <a:latin typeface="Inter" pitchFamily="34" charset="0"/>
-                <a:ea typeface="Inter" pitchFamily="34" charset="-122"/>
-                <a:cs typeface="Inter" pitchFamily="34" charset="-120"/>
-              </a:rPr>
-              <a:t>Closing Reflections</a:t>
-            </a:r>
-            <a:endParaRPr lang="en-US" sz="3600" dirty="0"/>
+            <a:pPr indent="0" marL="0">
+              <a:buNone/>
+            </a:pPr>
+            <a:r>
+              <a:rPr lang="en-US" sz="2400" b="1" dirty="0">
+                <a:solidFill>
+                  <a:srgbClr val="003366"/>
+                </a:solidFill>
+                <a:latin typeface="Aptos" pitchFamily="34" charset="0"/>
+                <a:ea typeface="Aptos" pitchFamily="34" charset="-122"/>
+                <a:cs typeface="Aptos" pitchFamily="34" charset="-120"/>
+              </a:rPr>
+              <a:t>Closing reflections</a:t>
+            </a:r>
+            <a:endParaRPr lang="en-US" sz="2400" dirty="0"/>
           </a:p>
         </p:txBody>
       </p:sp>
@@ -1889,8 +1941,8 @@
         </p:nvSpPr>
         <p:spPr>
           <a:xfrm>
-            <a:off x="457200" y="2286000"/>
-            <a:ext cx="8229600" cy="2011680"/>
+            <a:off x="548640" y="1005840"/>
+            <a:ext cx="8046720" cy="2560320"/>
           </a:xfrm>
           <a:prstGeom prst="rect">
             <a:avLst/>
@@ -1899,80 +1951,117 @@
           <a:ln/>
         </p:spPr>
         <p:txBody>
-          <a:bodyPr wrap="square" rtlCol="0" anchor="ctr"/>
-          <a:lstStyle/>
-          <a:p>
-            <a:pPr algn="ctr" indent="0" marL="0">
-              <a:buNone/>
-            </a:pPr>
-            <a:r>
-              <a:rPr lang="en-US" sz="1800" dirty="0">
-                <a:solidFill>
-                  <a:srgbClr val="5684C4"/>
-                </a:solidFill>
-                <a:latin typeface="Montserrat" pitchFamily="34" charset="0"/>
-                <a:ea typeface="Montserrat" pitchFamily="34" charset="-122"/>
-                <a:cs typeface="Montserrat" pitchFamily="34" charset="-120"/>
-              </a:rPr>
-              <a:t>One insight you are taking into practice this week
+          <a:bodyPr wrap="square" rtlCol="0" anchor="t"/>
+          <a:lstStyle/>
+          <a:p>
+            <a:pPr indent="0" marL="0">
+              <a:lnSpc>
+                <a:spcPct val="140000"/>
+              </a:lnSpc>
+              <a:buNone/>
+            </a:pPr>
+            <a:r>
+              <a:rPr lang="en-US" sz="1300" b="1" dirty="0">
+                <a:solidFill>
+                  <a:srgbClr val="333333"/>
+                </a:solidFill>
+                <a:latin typeface="Aptos" pitchFamily="34" charset="0"/>
+                <a:ea typeface="Aptos" pitchFamily="34" charset="-122"/>
+                <a:cs typeface="Aptos" pitchFamily="34" charset="-120"/>
+              </a:rPr>
+              <a:t>One insight you are taking into practice this week.
 </a:t>
             </a:r>
-            <a:endParaRPr lang="en-US" sz="1800" dirty="0"/>
-          </a:p>
-          <a:p>
-            <a:pPr algn="ctr" indent="0" marL="0">
-              <a:buNone/>
-            </a:pPr>
-            <a:r>
-              <a:rPr lang="en-US" sz="1600" dirty="0">
-                <a:solidFill>
-                  <a:srgbClr val="FFFFFF"/>
-                </a:solidFill>
-                <a:latin typeface="Montserrat" pitchFamily="34" charset="0"/>
-                <a:ea typeface="Montserrat" pitchFamily="34" charset="-122"/>
-                <a:cs typeface="Montserrat" pitchFamily="34" charset="-120"/>
-              </a:rPr>
-              <a:t>Key themes from the room:
+            <a:pPr indent="0" marL="0">
+              <a:lnSpc>
+                <a:spcPct val="140000"/>
+              </a:lnSpc>
+              <a:buNone/>
+            </a:pPr>
+            <a:r>
+              <a:rPr lang="en-US" sz="1300" b="1" dirty="0">
+                <a:solidFill>
+                  <a:srgbClr val="333333"/>
+                </a:solidFill>
+                <a:latin typeface="Aptos" pitchFamily="34" charset="0"/>
+                <a:ea typeface="Aptos" pitchFamily="34" charset="-122"/>
+                <a:cs typeface="Aptos" pitchFamily="34" charset="-120"/>
+              </a:rPr>
+              <a:t>Key themes:
 </a:t>
             </a:r>
-            <a:endParaRPr lang="en-US" sz="1800" dirty="0"/>
-          </a:p>
-          <a:p>
-            <a:pPr algn="ctr" marL="342900" indent="-342900">
-              <a:buSzPct val="100000"/>
-              <a:buChar char="•"/>
-            </a:pPr>
-            <a:r>
-              <a:rPr lang="en-US" sz="1400" dirty="0">
-                <a:solidFill>
-                  <a:srgbClr val="DDDDDD"/>
-                </a:solidFill>
-                <a:latin typeface="Montserrat" pitchFamily="34" charset="0"/>
-                <a:ea typeface="Montserrat" pitchFamily="34" charset="-122"/>
-                <a:cs typeface="Montserrat" pitchFamily="34" charset="-120"/>
-              </a:rPr>
-              <a:t>Recognising when someone has moved beyond capacity
+            <a:pPr indent="0" marL="0">
+              <a:lnSpc>
+                <a:spcPct val="140000"/>
+              </a:lnSpc>
+              <a:buNone/>
+            </a:pPr>
+            <a:r>
+              <a:rPr lang="en-US" sz="1300" dirty="0">
+                <a:solidFill>
+                  <a:srgbClr val="333333"/>
+                </a:solidFill>
+                <a:latin typeface="Aptos" pitchFamily="34" charset="0"/>
+                <a:ea typeface="Aptos" pitchFamily="34" charset="-122"/>
+                <a:cs typeface="Aptos" pitchFamily="34" charset="-120"/>
+              </a:rPr>
+              <a:t>Recognising when someone has moved beyond capacity.
 </a:t>
             </a:r>
-            <a:endParaRPr lang="en-US" sz="1800" dirty="0"/>
-          </a:p>
-          <a:p>
-            <a:pPr algn="ctr" marL="342900" indent="-342900">
-              <a:buSzPct val="100000"/>
-              <a:buChar char="•"/>
-            </a:pPr>
-            <a:r>
-              <a:rPr lang="en-US" sz="1400" dirty="0">
-                <a:solidFill>
-                  <a:srgbClr val="DDDDDD"/>
-                </a:solidFill>
-                <a:latin typeface="Montserrat" pitchFamily="34" charset="0"/>
-                <a:ea typeface="Montserrat" pitchFamily="34" charset="-122"/>
-                <a:cs typeface="Montserrat" pitchFamily="34" charset="-120"/>
-              </a:rPr>
-              <a:t>Responding in ways that support regulation and safety</a:t>
-            </a:r>
-            <a:endParaRPr lang="en-US" sz="1800" dirty="0"/>
+            <a:pPr indent="0" marL="0">
+              <a:lnSpc>
+                <a:spcPct val="140000"/>
+              </a:lnSpc>
+              <a:buNone/>
+            </a:pPr>
+            <a:r>
+              <a:rPr lang="en-US" sz="1300" dirty="0">
+                <a:solidFill>
+                  <a:srgbClr val="333333"/>
+                </a:solidFill>
+                <a:latin typeface="Aptos" pitchFamily="34" charset="0"/>
+                <a:ea typeface="Aptos" pitchFamily="34" charset="-122"/>
+                <a:cs typeface="Aptos" pitchFamily="34" charset="-120"/>
+              </a:rPr>
+              <a:t>Responding in ways that support regulation and safety.
+</a:t>
+            </a:r>
+            <a:pPr indent="0" marL="0">
+              <a:lnSpc>
+                <a:spcPct val="140000"/>
+              </a:lnSpc>
+              <a:buNone/>
+            </a:pPr>
+            <a:r>
+              <a:rPr lang="en-US" sz="1300" dirty="0">
+                <a:solidFill>
+                  <a:srgbClr val="333333"/>
+                </a:solidFill>
+                <a:latin typeface="Aptos" pitchFamily="34" charset="0"/>
+                <a:ea typeface="Aptos" pitchFamily="34" charset="-122"/>
+                <a:cs typeface="Aptos" pitchFamily="34" charset="-120"/>
+              </a:rPr>
+              <a:t>Anchoring without restriction.
+</a:t>
+            </a:r>
+            <a:pPr indent="0" marL="0">
+              <a:lnSpc>
+                <a:spcPct val="140000"/>
+              </a:lnSpc>
+              <a:buNone/>
+            </a:pPr>
+            <a:r>
+              <a:rPr lang="en-US" sz="1300" dirty="0">
+                <a:solidFill>
+                  <a:srgbClr val="333333"/>
+                </a:solidFill>
+                <a:latin typeface="Aptos" pitchFamily="34" charset="0"/>
+                <a:ea typeface="Aptos" pitchFamily="34" charset="-122"/>
+                <a:cs typeface="Aptos" pitchFamily="34" charset="-120"/>
+              </a:rPr>
+              <a:t>Progress without perfection.</a:t>
+            </a:r>
+            <a:endParaRPr lang="en-US" sz="1300" dirty="0"/>
           </a:p>
         </p:txBody>
       </p:sp>
@@ -1984,8 +2073,8 @@
         </p:nvSpPr>
         <p:spPr>
           <a:xfrm>
-            <a:off x="457200" y="4754880"/>
-            <a:ext cx="8229600" cy="274320"/>
+            <a:off x="548640" y="4434840"/>
+            <a:ext cx="8046720" cy="502920"/>
           </a:xfrm>
           <a:prstGeom prst="rect">
             <a:avLst/>
@@ -1998,18 +2087,41 @@
           <a:lstStyle/>
           <a:p>
             <a:pPr algn="ctr" indent="0" marL="0">
+              <a:lnSpc>
+                <a:spcPct val="120000"/>
+              </a:lnSpc>
               <a:buNone/>
             </a:pPr>
             <a:r>
               <a:rPr lang="en-US" sz="900" dirty="0">
                 <a:solidFill>
-                  <a:srgbClr val="DDDDDD"/>
-                </a:solidFill>
-                <a:latin typeface="Montserrat" pitchFamily="34" charset="0"/>
-                <a:ea typeface="Montserrat" pitchFamily="34" charset="-122"/>
-                <a:cs typeface="Montserrat" pitchFamily="34" charset="-120"/>
-              </a:rPr>
-              <a:t>Strengths-Based Coaching and Counselling | www.coach4u.com.au | cath@coach4u.com.au | 0402 313 337</a:t>
+                  <a:srgbClr val="999999"/>
+                </a:solidFill>
+                <a:latin typeface="Aptos" pitchFamily="34" charset="0"/>
+                <a:ea typeface="Aptos" pitchFamily="34" charset="-122"/>
+                <a:cs typeface="Aptos" pitchFamily="34" charset="-120"/>
+              </a:rPr>
+              <a:t>Cath Baker</a:t>
+            </a:r>
+            <a:endParaRPr lang="en-US" sz="900" dirty="0"/>
+          </a:p>
+          <a:p>
+            <a:pPr algn="ctr" indent="0" marL="0">
+              <a:lnSpc>
+                <a:spcPct val="120000"/>
+              </a:lnSpc>
+              <a:buNone/>
+            </a:pPr>
+            <a:r>
+              <a:rPr lang="en-US" sz="900" dirty="0">
+                <a:solidFill>
+                  <a:srgbClr val="999999"/>
+                </a:solidFill>
+                <a:latin typeface="Aptos" pitchFamily="34" charset="0"/>
+                <a:ea typeface="Aptos" pitchFamily="34" charset="-122"/>
+                <a:cs typeface="Aptos" pitchFamily="34" charset="-120"/>
+              </a:rPr>
+              <a:t>Coach4U – Strengths-Based Coaching and Counselling</a:t>
             </a:r>
             <a:endParaRPr lang="en-US" sz="900" dirty="0"/>
           </a:p>
@@ -2055,8 +2167,8 @@
         </p:nvSpPr>
         <p:spPr>
           <a:xfrm>
-            <a:off x="457200" y="365760"/>
-            <a:ext cx="8229600" cy="548640"/>
+            <a:off x="548640" y="365760"/>
+            <a:ext cx="8046720" cy="457200"/>
           </a:xfrm>
           <a:prstGeom prst="rect">
             <a:avLst/>
@@ -2065,24 +2177,24 @@
           <a:ln/>
         </p:spPr>
         <p:txBody>
-          <a:bodyPr wrap="square" lIns="0" tIns="0" rIns="0" bIns="0" rtlCol="0" anchor="ctr"/>
-          <a:lstStyle/>
-          <a:p>
-            <a:pPr algn="l" indent="0" marL="0">
-              <a:buNone/>
-            </a:pPr>
-            <a:r>
-              <a:rPr lang="en-US" sz="3200" b="1" dirty="0">
-                <a:solidFill>
-                  <a:srgbClr val="1B3664"/>
-                </a:solidFill>
-                <a:latin typeface="Inter" pitchFamily="34" charset="0"/>
-                <a:ea typeface="Inter" pitchFamily="34" charset="-122"/>
-                <a:cs typeface="Inter" pitchFamily="34" charset="-120"/>
-              </a:rPr>
-              <a:t>What We Mean by Capacity and Overwhelm</a:t>
-            </a:r>
-            <a:endParaRPr lang="en-US" sz="3200" dirty="0"/>
+          <a:bodyPr wrap="square" rtlCol="0" anchor="ctr"/>
+          <a:lstStyle/>
+          <a:p>
+            <a:pPr indent="0" marL="0">
+              <a:buNone/>
+            </a:pPr>
+            <a:r>
+              <a:rPr lang="en-US" sz="2400" b="1" dirty="0">
+                <a:solidFill>
+                  <a:srgbClr val="003366"/>
+                </a:solidFill>
+                <a:latin typeface="Aptos" pitchFamily="34" charset="0"/>
+                <a:ea typeface="Aptos" pitchFamily="34" charset="-122"/>
+                <a:cs typeface="Aptos" pitchFamily="34" charset="-120"/>
+              </a:rPr>
+              <a:t>What we mean by capacity and overwhelm</a:t>
+            </a:r>
+            <a:endParaRPr lang="en-US" sz="2400" dirty="0"/>
           </a:p>
         </p:txBody>
       </p:sp>
@@ -2094,8 +2206,8 @@
         </p:nvSpPr>
         <p:spPr>
           <a:xfrm>
-            <a:off x="457200" y="1097280"/>
-            <a:ext cx="8229600" cy="3474720"/>
+            <a:off x="548640" y="1005840"/>
+            <a:ext cx="8046720" cy="2286000"/>
           </a:xfrm>
           <a:prstGeom prst="rect">
             <a:avLst/>
@@ -2104,127 +2216,157 @@
           <a:ln/>
         </p:spPr>
         <p:txBody>
-          <a:bodyPr wrap="square" rtlCol="0" anchor="ctr"/>
-          <a:lstStyle/>
-          <a:p>
-            <a:pPr indent="0" marL="0">
-              <a:buNone/>
-            </a:pPr>
-            <a:r>
-              <a:rPr lang="en-US" sz="1600" dirty="0">
-                <a:solidFill>
-                  <a:srgbClr val="2D2D2D"/>
-                </a:solidFill>
-                <a:latin typeface="Montserrat" pitchFamily="34" charset="0"/>
-                <a:ea typeface="Montserrat" pitchFamily="34" charset="-122"/>
-                <a:cs typeface="Montserrat" pitchFamily="34" charset="-120"/>
-              </a:rPr>
-              <a:t>Capacity as a fluctuating state
+          <a:bodyPr wrap="square" rtlCol="0" anchor="t"/>
+          <a:lstStyle/>
+          <a:p>
+            <a:pPr indent="0" marL="0">
+              <a:lnSpc>
+                <a:spcPct val="135000"/>
+              </a:lnSpc>
+              <a:buNone/>
+            </a:pPr>
+            <a:r>
+              <a:rPr lang="en-US" sz="1300" b="1" dirty="0">
+                <a:solidFill>
+                  <a:srgbClr val="333333"/>
+                </a:solidFill>
+                <a:latin typeface="Aptos" pitchFamily="34" charset="0"/>
+                <a:ea typeface="Aptos" pitchFamily="34" charset="-122"/>
+                <a:cs typeface="Aptos" pitchFamily="34" charset="-120"/>
+              </a:rPr>
+              <a:t>Capacity is a fluctuating state, not a fixed trait.
 </a:t>
             </a:r>
-            <a:endParaRPr lang="en-US" sz="1600" dirty="0"/>
-          </a:p>
-          <a:p>
-            <a:pPr indent="0" marL="0">
-              <a:buNone/>
-            </a:pPr>
-            <a:r>
-              <a:rPr lang="en-US" sz="1400" dirty="0">
-                <a:solidFill>
-                  <a:srgbClr val="2D2D2D"/>
-                </a:solidFill>
-                <a:latin typeface="Montserrat" pitchFamily="34" charset="0"/>
-                <a:ea typeface="Montserrat" pitchFamily="34" charset="-122"/>
-                <a:cs typeface="Montserrat" pitchFamily="34" charset="-120"/>
-              </a:rPr>
-              <a:t>Context-dependent, not a fixed trait. Available energy and resources shift based on environment, support, sensory load, and cumulative demand.
+            <a:pPr indent="0" marL="0">
+              <a:lnSpc>
+                <a:spcPct val="135000"/>
+              </a:lnSpc>
+              <a:buNone/>
+            </a:pPr>
+            <a:r>
+              <a:rPr lang="en-US" sz="1300" dirty="0">
+                <a:solidFill>
+                  <a:srgbClr val="333333"/>
+                </a:solidFill>
+                <a:latin typeface="Aptos" pitchFamily="34" charset="0"/>
+                <a:ea typeface="Aptos" pitchFamily="34" charset="-122"/>
+                <a:cs typeface="Aptos" pitchFamily="34" charset="-120"/>
+              </a:rPr>
+              <a:t>It shifts with environment, support, sensory load, and cumulative demand.
 </a:t>
             </a:r>
-            <a:endParaRPr lang="en-US" sz="1600" dirty="0"/>
-          </a:p>
-          <a:p>
-            <a:pPr indent="0" marL="0">
-              <a:buNone/>
-            </a:pPr>
-            <a:r>
-              <a:rPr lang="en-US" sz="1600" dirty="0">
-                <a:solidFill>
-                  <a:srgbClr val="2D2D2D"/>
-                </a:solidFill>
-                <a:latin typeface="Montserrat" pitchFamily="34" charset="0"/>
-                <a:ea typeface="Montserrat" pitchFamily="34" charset="-122"/>
-                <a:cs typeface="Montserrat" pitchFamily="34" charset="-120"/>
-              </a:rPr>
-              <a:t>Overwhelm as the tipping point
+            <a:pPr indent="0" marL="0">
+              <a:lnSpc>
+                <a:spcPct val="135000"/>
+              </a:lnSpc>
+              <a:buNone/>
+            </a:pPr>
+            <a:r>
+              <a:rPr lang="en-US" sz="1300" b="1" dirty="0">
+                <a:solidFill>
+                  <a:srgbClr val="333333"/>
+                </a:solidFill>
+                <a:latin typeface="Aptos" pitchFamily="34" charset="0"/>
+                <a:ea typeface="Aptos" pitchFamily="34" charset="-122"/>
+                <a:cs typeface="Aptos" pitchFamily="34" charset="-120"/>
+              </a:rPr>
+              <a:t>Overwhelm is the tipping point.
 </a:t>
             </a:r>
-            <a:endParaRPr lang="en-US" sz="1600" dirty="0"/>
-          </a:p>
-          <a:p>
-            <a:pPr indent="0" marL="0">
-              <a:buNone/>
-            </a:pPr>
-            <a:r>
-              <a:rPr lang="en-US" sz="1400" dirty="0">
-                <a:solidFill>
-                  <a:srgbClr val="2D2D2D"/>
-                </a:solidFill>
-                <a:latin typeface="Montserrat" pitchFamily="34" charset="0"/>
-                <a:ea typeface="Montserrat" pitchFamily="34" charset="-122"/>
-                <a:cs typeface="Montserrat" pitchFamily="34" charset="-120"/>
-              </a:rPr>
-              <a:t>The point where demand exceeds available capacity. Compensation strategies collapse, regulation becomes harder, and functioning shifts.
+            <a:pPr indent="0" marL="0">
+              <a:lnSpc>
+                <a:spcPct val="135000"/>
+              </a:lnSpc>
+              <a:buNone/>
+            </a:pPr>
+            <a:r>
+              <a:rPr lang="en-US" sz="1300" dirty="0">
+                <a:solidFill>
+                  <a:srgbClr val="333333"/>
+                </a:solidFill>
+                <a:latin typeface="Aptos" pitchFamily="34" charset="0"/>
+                <a:ea typeface="Aptos" pitchFamily="34" charset="-122"/>
+                <a:cs typeface="Aptos" pitchFamily="34" charset="-120"/>
+              </a:rPr>
+              <a:t>It is where demand exceeds available capacity and functioning shifts.
 </a:t>
             </a:r>
-            <a:endParaRPr lang="en-US" sz="1600" dirty="0"/>
-          </a:p>
-          <a:p>
-            <a:pPr indent="0" marL="0">
-              <a:buNone/>
-            </a:pPr>
-            <a:r>
-              <a:rPr lang="en-US" sz="1600" dirty="0">
-                <a:solidFill>
-                  <a:srgbClr val="2D2D2D"/>
-                </a:solidFill>
-                <a:latin typeface="Montserrat" pitchFamily="34" charset="0"/>
-                <a:ea typeface="Montserrat" pitchFamily="34" charset="-122"/>
-                <a:cs typeface="Montserrat" pitchFamily="34" charset="-120"/>
-              </a:rPr>
-              <a:t>Discussion prompt
+            <a:pPr indent="0" marL="0">
+              <a:lnSpc>
+                <a:spcPct val="135000"/>
+              </a:lnSpc>
+              <a:buNone/>
+            </a:pPr>
+            <a:r>
+              <a:rPr lang="en-US" sz="1300" b="1" dirty="0">
+                <a:solidFill>
+                  <a:srgbClr val="333333"/>
+                </a:solidFill>
+                <a:latin typeface="Aptos" pitchFamily="34" charset="0"/>
+                <a:ea typeface="Aptos" pitchFamily="34" charset="-122"/>
+                <a:cs typeface="Aptos" pitchFamily="34" charset="-120"/>
+              </a:rPr>
+              <a:t>You are not expected to solve overwhelm.
 </a:t>
             </a:r>
-            <a:endParaRPr lang="en-US" sz="1600" dirty="0"/>
-          </a:p>
-          <a:p>
-            <a:pPr indent="0" marL="0">
-              <a:buNone/>
-            </a:pPr>
-            <a:r>
-              <a:rPr lang="en-US" sz="1400" i="1" dirty="0">
-                <a:solidFill>
-                  <a:srgbClr val="2D2D2D"/>
-                </a:solidFill>
-                <a:latin typeface="Montserrat" pitchFamily="34" charset="0"/>
-                <a:ea typeface="Montserrat" pitchFamily="34" charset="-122"/>
-                <a:cs typeface="Montserrat" pitchFamily="34" charset="-120"/>
-              </a:rPr>
-              <a:t>What are the early signs someone has moved beyond functional capacity, not just the obvious crash?</a:t>
-            </a:r>
-            <a:endParaRPr lang="en-US" sz="1600" dirty="0"/>
-          </a:p>
-        </p:txBody>
-      </p:sp>
-      <p:sp>
-        <p:nvSpPr>
-          <p:cNvPr id="4" name="Text 2"/>
+            <a:pPr indent="0" marL="0">
+              <a:lnSpc>
+                <a:spcPct val="135000"/>
+              </a:lnSpc>
+              <a:buNone/>
+            </a:pPr>
+            <a:r>
+              <a:rPr lang="en-US" sz="1300" dirty="0">
+                <a:solidFill>
+                  <a:srgbClr val="333333"/>
+                </a:solidFill>
+                <a:latin typeface="Aptos" pitchFamily="34" charset="0"/>
+                <a:ea typeface="Aptos" pitchFamily="34" charset="-122"/>
+                <a:cs typeface="Aptos" pitchFamily="34" charset="-120"/>
+              </a:rPr>
+              <a:t>The work is recognising it and responding safely.</a:t>
+            </a:r>
+            <a:endParaRPr lang="en-US" sz="1300" dirty="0"/>
+          </a:p>
+        </p:txBody>
+      </p:sp>
+      <p:sp>
+        <p:nvSpPr>
+          <p:cNvPr id="4" name="Shape 2"/>
           <p:cNvSpPr/>
           <p:nvPr/>
         </p:nvSpPr>
         <p:spPr>
           <a:xfrm>
-            <a:off x="457200" y="4754880"/>
-            <a:ext cx="8229600" cy="274320"/>
+            <a:off x="548640" y="3520440"/>
+            <a:ext cx="8046720" cy="685800"/>
+          </a:xfrm>
+          <a:prstGeom prst="rect">
+            <a:avLst>
+              <a:gd name="adj" fmla="val 6667"/>
+            </a:avLst>
+          </a:prstGeom>
+          <a:solidFill>
+            <a:srgbClr val="F5F5F5"/>
+          </a:solidFill>
+          <a:ln w="12700">
+            <a:solidFill>
+              <a:srgbClr val="F5F5F5"/>
+            </a:solidFill>
+            <a:prstDash val="solid"/>
+          </a:ln>
+        </p:spPr>
+      </p:sp>
+      <p:sp>
+        <p:nvSpPr>
+          <p:cNvPr id="5" name="Text 3"/>
+          <p:cNvSpPr/>
+          <p:nvPr/>
+        </p:nvSpPr>
+        <p:spPr>
+          <a:xfrm>
+            <a:off x="731520" y="3611880"/>
+            <a:ext cx="7680960" cy="502920"/>
           </a:xfrm>
           <a:prstGeom prst="rect">
             <a:avLst/>
@@ -2233,24 +2375,45 @@
           <a:ln/>
         </p:spPr>
         <p:txBody>
-          <a:bodyPr wrap="square" rtlCol="0" anchor="ctr"/>
-          <a:lstStyle/>
-          <a:p>
-            <a:pPr algn="ctr" indent="0" marL="0">
-              <a:buNone/>
-            </a:pPr>
-            <a:r>
-              <a:rPr lang="en-US" sz="900" dirty="0">
-                <a:solidFill>
-                  <a:srgbClr val="2D2D2D"/>
-                </a:solidFill>
-                <a:latin typeface="Montserrat" pitchFamily="34" charset="0"/>
-                <a:ea typeface="Montserrat" pitchFamily="34" charset="-122"/>
-                <a:cs typeface="Montserrat" pitchFamily="34" charset="-120"/>
-              </a:rPr>
-              <a:t>Strengths-Based Coaching and Counselling | www.coach4u.com.au | cath@coach4u.com.au | 0402 313 337</a:t>
-            </a:r>
-            <a:endParaRPr lang="en-US" sz="900" dirty="0"/>
+          <a:bodyPr wrap="square" rtlCol="0" anchor="t"/>
+          <a:lstStyle/>
+          <a:p>
+            <a:pPr indent="0" marL="0">
+              <a:lnSpc>
+                <a:spcPct val="130000"/>
+              </a:lnSpc>
+              <a:buNone/>
+            </a:pPr>
+            <a:r>
+              <a:rPr lang="en-US" sz="1100" b="1" dirty="0">
+                <a:solidFill>
+                  <a:srgbClr val="003366"/>
+                </a:solidFill>
+                <a:latin typeface="Aptos" pitchFamily="34" charset="0"/>
+                <a:ea typeface="Aptos" pitchFamily="34" charset="-122"/>
+                <a:cs typeface="Aptos" pitchFamily="34" charset="-120"/>
+              </a:rPr>
+              <a:t>Discussion prompt:
+</a:t>
+            </a:r>
+            <a:pPr indent="0" marL="0">
+              <a:lnSpc>
+                <a:spcPct val="130000"/>
+              </a:lnSpc>
+              <a:buNone/>
+            </a:pPr>
+            <a:r>
+              <a:rPr lang="en-US" sz="1100" i="1" dirty="0">
+                <a:solidFill>
+                  <a:srgbClr val="333333"/>
+                </a:solidFill>
+                <a:latin typeface="Aptos" pitchFamily="34" charset="0"/>
+                <a:ea typeface="Aptos" pitchFamily="34" charset="-122"/>
+                <a:cs typeface="Aptos" pitchFamily="34" charset="-120"/>
+              </a:rPr>
+              <a:t>What are the early signs someone has moved beyond functional capacity, not just the obvious crash?</a:t>
+            </a:r>
+            <a:endParaRPr lang="en-US" sz="1100" dirty="0"/>
           </a:p>
         </p:txBody>
       </p:sp>
@@ -2294,8 +2457,8 @@
         </p:nvSpPr>
         <p:spPr>
           <a:xfrm>
-            <a:off x="457200" y="365760"/>
-            <a:ext cx="8229600" cy="548640"/>
+            <a:off x="548640" y="365760"/>
+            <a:ext cx="8046720" cy="457200"/>
           </a:xfrm>
           <a:prstGeom prst="rect">
             <a:avLst/>
@@ -2304,24 +2467,24 @@
           <a:ln/>
         </p:spPr>
         <p:txBody>
-          <a:bodyPr wrap="square" lIns="0" tIns="0" rIns="0" bIns="0" rtlCol="0" anchor="ctr"/>
-          <a:lstStyle/>
-          <a:p>
-            <a:pPr algn="l" indent="0" marL="0">
-              <a:buNone/>
-            </a:pPr>
-            <a:r>
-              <a:rPr lang="en-US" sz="3200" b="1" dirty="0">
-                <a:solidFill>
-                  <a:srgbClr val="1B3664"/>
-                </a:solidFill>
-                <a:latin typeface="Inter" pitchFamily="34" charset="0"/>
-                <a:ea typeface="Inter" pitchFamily="34" charset="-122"/>
-                <a:cs typeface="Inter" pitchFamily="34" charset="-120"/>
-              </a:rPr>
-              <a:t>Neurodivergent Lens: Why Overwhelm is Often a Baseline Experience</a:t>
-            </a:r>
-            <a:endParaRPr lang="en-US" sz="3200" dirty="0"/>
+          <a:bodyPr wrap="square" rtlCol="0" anchor="ctr"/>
+          <a:lstStyle/>
+          <a:p>
+            <a:pPr indent="0" marL="0">
+              <a:buNone/>
+            </a:pPr>
+            <a:r>
+              <a:rPr lang="en-US" sz="2400" b="1" dirty="0">
+                <a:solidFill>
+                  <a:srgbClr val="003366"/>
+                </a:solidFill>
+                <a:latin typeface="Aptos" pitchFamily="34" charset="0"/>
+                <a:ea typeface="Aptos" pitchFamily="34" charset="-122"/>
+                <a:cs typeface="Aptos" pitchFamily="34" charset="-120"/>
+              </a:rPr>
+              <a:t>Neurodivergent lens: why overwhelm can become baseline</a:t>
+            </a:r>
+            <a:endParaRPr lang="en-US" sz="2400" dirty="0"/>
           </a:p>
         </p:txBody>
       </p:sp>
@@ -2333,8 +2496,8 @@
         </p:nvSpPr>
         <p:spPr>
           <a:xfrm>
-            <a:off x="457200" y="1280160"/>
-            <a:ext cx="8229600" cy="3291840"/>
+            <a:off x="548640" y="1005840"/>
+            <a:ext cx="8046720" cy="2286000"/>
           </a:xfrm>
           <a:prstGeom prst="rect">
             <a:avLst/>
@@ -2343,127 +2506,157 @@
           <a:ln/>
         </p:spPr>
         <p:txBody>
-          <a:bodyPr wrap="square" rtlCol="0" anchor="ctr"/>
-          <a:lstStyle/>
-          <a:p>
-            <a:pPr indent="0" marL="0">
-              <a:buNone/>
-            </a:pPr>
-            <a:r>
-              <a:rPr lang="en-US" sz="1600" dirty="0">
-                <a:solidFill>
-                  <a:srgbClr val="2D2D2D"/>
-                </a:solidFill>
-                <a:latin typeface="Montserrat" pitchFamily="34" charset="0"/>
-                <a:ea typeface="Montserrat" pitchFamily="34" charset="-122"/>
-                <a:cs typeface="Montserrat" pitchFamily="34" charset="-120"/>
-              </a:rPr>
-              <a:t>This is a neurodivergence-focused conversation
+          <a:bodyPr wrap="square" rtlCol="0" anchor="t"/>
+          <a:lstStyle/>
+          <a:p>
+            <a:pPr indent="0" marL="0">
+              <a:lnSpc>
+                <a:spcPct val="135000"/>
+              </a:lnSpc>
+              <a:buNone/>
+            </a:pPr>
+            <a:r>
+              <a:rPr lang="en-US" sz="1300" b="1" dirty="0">
+                <a:solidFill>
+                  <a:srgbClr val="333333"/>
+                </a:solidFill>
+                <a:latin typeface="Aptos" pitchFamily="34" charset="0"/>
+                <a:ea typeface="Aptos" pitchFamily="34" charset="-122"/>
+                <a:cs typeface="Aptos" pitchFamily="34" charset="-120"/>
+              </a:rPr>
+              <a:t>Capacity costs are different for neurodivergent people.
 </a:t>
             </a:r>
-            <a:endParaRPr lang="en-US" sz="1600" dirty="0"/>
-          </a:p>
-          <a:p>
-            <a:pPr indent="0" marL="0">
-              <a:buNone/>
-            </a:pPr>
-            <a:r>
-              <a:rPr lang="en-US" sz="1400" dirty="0">
-                <a:solidFill>
-                  <a:srgbClr val="2D2D2D"/>
-                </a:solidFill>
-                <a:latin typeface="Montserrat" pitchFamily="34" charset="0"/>
-                <a:ea typeface="Montserrat" pitchFamily="34" charset="-122"/>
-                <a:cs typeface="Montserrat" pitchFamily="34" charset="-120"/>
-              </a:rPr>
-              <a:t>Capacity costs are different for neurodivergent people. Masking, sensory processing, executive function demands, and social navigation all consume energy in ways that are often invisible to others.
+            <a:pPr indent="0" marL="0">
+              <a:lnSpc>
+                <a:spcPct val="135000"/>
+              </a:lnSpc>
+              <a:buNone/>
+            </a:pPr>
+            <a:r>
+              <a:rPr lang="en-US" sz="1300" dirty="0">
+                <a:solidFill>
+                  <a:srgbClr val="333333"/>
+                </a:solidFill>
+                <a:latin typeface="Aptos" pitchFamily="34" charset="0"/>
+                <a:ea typeface="Aptos" pitchFamily="34" charset="-122"/>
+                <a:cs typeface="Aptos" pitchFamily="34" charset="-120"/>
+              </a:rPr>
+              <a:t>Masking, sensory processing, executive function demands, and social navigation consume energy.
 </a:t>
             </a:r>
-            <a:endParaRPr lang="en-US" sz="1600" dirty="0"/>
-          </a:p>
-          <a:p>
-            <a:pPr indent="0" marL="0">
-              <a:buNone/>
-            </a:pPr>
-            <a:r>
-              <a:rPr lang="en-US" sz="1600" dirty="0">
-                <a:solidFill>
-                  <a:srgbClr val="2D2D2D"/>
-                </a:solidFill>
-                <a:latin typeface="Montserrat" pitchFamily="34" charset="0"/>
-                <a:ea typeface="Montserrat" pitchFamily="34" charset="-122"/>
-                <a:cs typeface="Montserrat" pitchFamily="34" charset="-120"/>
-              </a:rPr>
-              <a:t>Lived reality includes variability and cumulative load
+            <a:pPr indent="0" marL="0">
+              <a:lnSpc>
+                <a:spcPct val="135000"/>
+              </a:lnSpc>
+              <a:buNone/>
+            </a:pPr>
+            <a:r>
+              <a:rPr lang="en-US" sz="1300" b="1" dirty="0">
+                <a:solidFill>
+                  <a:srgbClr val="333333"/>
+                </a:solidFill>
+                <a:latin typeface="Aptos" pitchFamily="34" charset="0"/>
+                <a:ea typeface="Aptos" pitchFamily="34" charset="-122"/>
+                <a:cs typeface="Aptos" pitchFamily="34" charset="-120"/>
+              </a:rPr>
+              <a:t>Variability is part of the lived reality.
 </a:t>
             </a:r>
-            <a:endParaRPr lang="en-US" sz="1600" dirty="0"/>
-          </a:p>
-          <a:p>
-            <a:pPr indent="0" marL="0">
-              <a:buNone/>
-            </a:pPr>
-            <a:r>
-              <a:rPr lang="en-US" sz="1400" dirty="0">
-                <a:solidFill>
-                  <a:srgbClr val="2D2D2D"/>
-                </a:solidFill>
-                <a:latin typeface="Montserrat" pitchFamily="34" charset="0"/>
-                <a:ea typeface="Montserrat" pitchFamily="34" charset="-122"/>
-                <a:cs typeface="Montserrat" pitchFamily="34" charset="-120"/>
-              </a:rPr>
-              <a:t>What feels manageable one day may be impossible the next. Small stressors accumulate. Recovering capacity takes longer than depleting it.
+            <a:pPr indent="0" marL="0">
+              <a:lnSpc>
+                <a:spcPct val="135000"/>
+              </a:lnSpc>
+              <a:buNone/>
+            </a:pPr>
+            <a:r>
+              <a:rPr lang="en-US" sz="1300" dirty="0">
+                <a:solidFill>
+                  <a:srgbClr val="333333"/>
+                </a:solidFill>
+                <a:latin typeface="Aptos" pitchFamily="34" charset="0"/>
+                <a:ea typeface="Aptos" pitchFamily="34" charset="-122"/>
+                <a:cs typeface="Aptos" pitchFamily="34" charset="-120"/>
+              </a:rPr>
+              <a:t>What feels manageable one day may be impossible the next.
 </a:t>
             </a:r>
-            <a:endParaRPr lang="en-US" sz="1600" dirty="0"/>
-          </a:p>
-          <a:p>
-            <a:pPr indent="0" marL="0">
-              <a:buNone/>
-            </a:pPr>
-            <a:r>
-              <a:rPr lang="en-US" sz="1600" dirty="0">
-                <a:solidFill>
-                  <a:srgbClr val="2D2D2D"/>
-                </a:solidFill>
-                <a:latin typeface="Montserrat" pitchFamily="34" charset="0"/>
-                <a:ea typeface="Montserrat" pitchFamily="34" charset="-122"/>
-                <a:cs typeface="Montserrat" pitchFamily="34" charset="-120"/>
-              </a:rPr>
-              <a:t>Discussion prompt
+            <a:pPr indent="0" marL="0">
+              <a:lnSpc>
+                <a:spcPct val="135000"/>
+              </a:lnSpc>
+              <a:buNone/>
+            </a:pPr>
+            <a:r>
+              <a:rPr lang="en-US" sz="1300" b="1" dirty="0">
+                <a:solidFill>
+                  <a:srgbClr val="333333"/>
+                </a:solidFill>
+                <a:latin typeface="Aptos" pitchFamily="34" charset="0"/>
+                <a:ea typeface="Aptos" pitchFamily="34" charset="-122"/>
+                <a:cs typeface="Aptos" pitchFamily="34" charset="-120"/>
+              </a:rPr>
+              <a:t>Cumulative load builds quietly.
 </a:t>
             </a:r>
-            <a:endParaRPr lang="en-US" sz="1600" dirty="0"/>
-          </a:p>
-          <a:p>
-            <a:pPr indent="0" marL="0">
-              <a:buNone/>
-            </a:pPr>
-            <a:r>
-              <a:rPr lang="en-US" sz="1400" i="1" dirty="0">
-                <a:solidFill>
-                  <a:srgbClr val="2D2D2D"/>
-                </a:solidFill>
-                <a:latin typeface="Montserrat" pitchFamily="34" charset="0"/>
-                <a:ea typeface="Montserrat" pitchFamily="34" charset="-122"/>
-                <a:cs typeface="Montserrat" pitchFamily="34" charset="-120"/>
-              </a:rPr>
-              <a:t>How does overwhelm present differently across the neurodivergent clients you work with?</a:t>
-            </a:r>
-            <a:endParaRPr lang="en-US" sz="1600" dirty="0"/>
-          </a:p>
-        </p:txBody>
-      </p:sp>
-      <p:sp>
-        <p:nvSpPr>
-          <p:cNvPr id="4" name="Text 2"/>
+            <a:pPr indent="0" marL="0">
+              <a:lnSpc>
+                <a:spcPct val="135000"/>
+              </a:lnSpc>
+              <a:buNone/>
+            </a:pPr>
+            <a:r>
+              <a:rPr lang="en-US" sz="1300" dirty="0">
+                <a:solidFill>
+                  <a:srgbClr val="333333"/>
+                </a:solidFill>
+                <a:latin typeface="Aptos" pitchFamily="34" charset="0"/>
+                <a:ea typeface="Aptos" pitchFamily="34" charset="-122"/>
+                <a:cs typeface="Aptos" pitchFamily="34" charset="-120"/>
+              </a:rPr>
+              <a:t>Recovery often takes longer than depletion.</a:t>
+            </a:r>
+            <a:endParaRPr lang="en-US" sz="1300" dirty="0"/>
+          </a:p>
+        </p:txBody>
+      </p:sp>
+      <p:sp>
+        <p:nvSpPr>
+          <p:cNvPr id="4" name="Shape 2"/>
           <p:cNvSpPr/>
           <p:nvPr/>
         </p:nvSpPr>
         <p:spPr>
           <a:xfrm>
-            <a:off x="457200" y="4754880"/>
-            <a:ext cx="8229600" cy="274320"/>
+            <a:off x="548640" y="3520440"/>
+            <a:ext cx="8046720" cy="640080"/>
+          </a:xfrm>
+          <a:prstGeom prst="rect">
+            <a:avLst>
+              <a:gd name="adj" fmla="val 7143"/>
+            </a:avLst>
+          </a:prstGeom>
+          <a:solidFill>
+            <a:srgbClr val="F5F5F5"/>
+          </a:solidFill>
+          <a:ln w="12700">
+            <a:solidFill>
+              <a:srgbClr val="F5F5F5"/>
+            </a:solidFill>
+            <a:prstDash val="solid"/>
+          </a:ln>
+        </p:spPr>
+      </p:sp>
+      <p:sp>
+        <p:nvSpPr>
+          <p:cNvPr id="5" name="Text 3"/>
+          <p:cNvSpPr/>
+          <p:nvPr/>
+        </p:nvSpPr>
+        <p:spPr>
+          <a:xfrm>
+            <a:off x="731520" y="3611880"/>
+            <a:ext cx="7680960" cy="457200"/>
           </a:xfrm>
           <a:prstGeom prst="rect">
             <a:avLst/>
@@ -2472,24 +2665,45 @@
           <a:ln/>
         </p:spPr>
         <p:txBody>
-          <a:bodyPr wrap="square" rtlCol="0" anchor="ctr"/>
-          <a:lstStyle/>
-          <a:p>
-            <a:pPr algn="ctr" indent="0" marL="0">
-              <a:buNone/>
-            </a:pPr>
-            <a:r>
-              <a:rPr lang="en-US" sz="900" dirty="0">
-                <a:solidFill>
-                  <a:srgbClr val="2D2D2D"/>
-                </a:solidFill>
-                <a:latin typeface="Montserrat" pitchFamily="34" charset="0"/>
-                <a:ea typeface="Montserrat" pitchFamily="34" charset="-122"/>
-                <a:cs typeface="Montserrat" pitchFamily="34" charset="-120"/>
-              </a:rPr>
-              <a:t>Strengths-Based Coaching and Counselling | www.coach4u.com.au | cath@coach4u.com.au | 0402 313 337</a:t>
-            </a:r>
-            <a:endParaRPr lang="en-US" sz="900" dirty="0"/>
+          <a:bodyPr wrap="square" rtlCol="0" anchor="t"/>
+          <a:lstStyle/>
+          <a:p>
+            <a:pPr indent="0" marL="0">
+              <a:lnSpc>
+                <a:spcPct val="130000"/>
+              </a:lnSpc>
+              <a:buNone/>
+            </a:pPr>
+            <a:r>
+              <a:rPr lang="en-US" sz="1100" b="1" dirty="0">
+                <a:solidFill>
+                  <a:srgbClr val="003366"/>
+                </a:solidFill>
+                <a:latin typeface="Aptos" pitchFamily="34" charset="0"/>
+                <a:ea typeface="Aptos" pitchFamily="34" charset="-122"/>
+                <a:cs typeface="Aptos" pitchFamily="34" charset="-120"/>
+              </a:rPr>
+              <a:t>Discussion prompt:
+</a:t>
+            </a:r>
+            <a:pPr indent="0" marL="0">
+              <a:lnSpc>
+                <a:spcPct val="130000"/>
+              </a:lnSpc>
+              <a:buNone/>
+            </a:pPr>
+            <a:r>
+              <a:rPr lang="en-US" sz="1100" i="1" dirty="0">
+                <a:solidFill>
+                  <a:srgbClr val="333333"/>
+                </a:solidFill>
+                <a:latin typeface="Aptos" pitchFamily="34" charset="0"/>
+                <a:ea typeface="Aptos" pitchFamily="34" charset="-122"/>
+                <a:cs typeface="Aptos" pitchFamily="34" charset="-120"/>
+              </a:rPr>
+              <a:t>How does overwhelm present differently across the neurodivergent clients you work with?</a:t>
+            </a:r>
+            <a:endParaRPr lang="en-US" sz="1100" dirty="0"/>
           </a:p>
         </p:txBody>
       </p:sp>
@@ -2533,8 +2747,8 @@
         </p:nvSpPr>
         <p:spPr>
           <a:xfrm>
-            <a:off x="457200" y="365760"/>
-            <a:ext cx="8229600" cy="548640"/>
+            <a:off x="548640" y="365760"/>
+            <a:ext cx="8046720" cy="457200"/>
           </a:xfrm>
           <a:prstGeom prst="rect">
             <a:avLst/>
@@ -2543,24 +2757,24 @@
           <a:ln/>
         </p:spPr>
         <p:txBody>
-          <a:bodyPr wrap="square" lIns="0" tIns="0" rIns="0" bIns="0" rtlCol="0" anchor="ctr"/>
-          <a:lstStyle/>
-          <a:p>
-            <a:pPr algn="l" indent="0" marL="0">
-              <a:buNone/>
-            </a:pPr>
-            <a:r>
-              <a:rPr lang="en-US" sz="3200" b="1" dirty="0">
-                <a:solidFill>
-                  <a:srgbClr val="1B3664"/>
-                </a:solidFill>
-                <a:latin typeface="Inter" pitchFamily="34" charset="0"/>
-                <a:ea typeface="Inter" pitchFamily="34" charset="-122"/>
-                <a:cs typeface="Inter" pitchFamily="34" charset="-120"/>
-              </a:rPr>
-              <a:t>The Gap: Why Tools Often Fail in Real Life</a:t>
-            </a:r>
-            <a:endParaRPr lang="en-US" sz="3200" dirty="0"/>
+          <a:bodyPr wrap="square" rtlCol="0" anchor="ctr"/>
+          <a:lstStyle/>
+          <a:p>
+            <a:pPr indent="0" marL="0">
+              <a:buNone/>
+            </a:pPr>
+            <a:r>
+              <a:rPr lang="en-US" sz="2400" b="1" dirty="0">
+                <a:solidFill>
+                  <a:srgbClr val="003366"/>
+                </a:solidFill>
+                <a:latin typeface="Aptos" pitchFamily="34" charset="0"/>
+                <a:ea typeface="Aptos" pitchFamily="34" charset="-122"/>
+                <a:cs typeface="Aptos" pitchFamily="34" charset="-120"/>
+              </a:rPr>
+              <a:t>The gap: why tools often fail under load</a:t>
+            </a:r>
+            <a:endParaRPr lang="en-US" sz="2400" dirty="0"/>
           </a:p>
         </p:txBody>
       </p:sp>
@@ -2572,8 +2786,8 @@
         </p:nvSpPr>
         <p:spPr>
           <a:xfrm>
-            <a:off x="457200" y="1097280"/>
-            <a:ext cx="8229600" cy="3474720"/>
+            <a:off x="548640" y="1005840"/>
+            <a:ext cx="8046720" cy="2560320"/>
           </a:xfrm>
           <a:prstGeom prst="rect">
             <a:avLst/>
@@ -2582,127 +2796,193 @@
           <a:ln/>
         </p:spPr>
         <p:txBody>
-          <a:bodyPr wrap="square" rtlCol="0" anchor="ctr"/>
-          <a:lstStyle/>
-          <a:p>
-            <a:pPr indent="0" marL="0">
-              <a:buNone/>
-            </a:pPr>
-            <a:r>
-              <a:rPr lang="en-US" sz="1600" dirty="0">
-                <a:solidFill>
-                  <a:srgbClr val="2D2D2D"/>
-                </a:solidFill>
-                <a:latin typeface="Montserrat" pitchFamily="34" charset="0"/>
-                <a:ea typeface="Montserrat" pitchFamily="34" charset="-122"/>
-                <a:cs typeface="Montserrat" pitchFamily="34" charset="-120"/>
-              </a:rPr>
-              <a:t>Lots of advice, often generic
+          <a:bodyPr wrap="square" rtlCol="0" anchor="t"/>
+          <a:lstStyle/>
+          <a:p>
+            <a:pPr indent="0" marL="0">
+              <a:lnSpc>
+                <a:spcPct val="130000"/>
+              </a:lnSpc>
+              <a:buNone/>
+            </a:pPr>
+            <a:r>
+              <a:rPr lang="en-US" sz="1300" b="1" dirty="0">
+                <a:solidFill>
+                  <a:srgbClr val="333333"/>
+                </a:solidFill>
+                <a:latin typeface="Aptos" pitchFamily="34" charset="0"/>
+                <a:ea typeface="Aptos" pitchFamily="34" charset="-122"/>
+                <a:cs typeface="Aptos" pitchFamily="34" charset="-120"/>
+              </a:rPr>
+              <a:t>There is a lot of advice.
 </a:t>
             </a:r>
-            <a:endParaRPr lang="en-US" sz="1600" dirty="0"/>
-          </a:p>
-          <a:p>
-            <a:pPr indent="0" marL="0">
-              <a:buNone/>
-            </a:pPr>
-            <a:r>
-              <a:rPr lang="en-US" sz="1400" dirty="0">
-                <a:solidFill>
-                  <a:srgbClr val="2D2D2D"/>
-                </a:solidFill>
-                <a:latin typeface="Montserrat" pitchFamily="34" charset="0"/>
-                <a:ea typeface="Montserrat" pitchFamily="34" charset="-122"/>
-                <a:cs typeface="Montserrat" pitchFamily="34" charset="-120"/>
-              </a:rPr>
-              <a:t>Standard coping strategies are rarely matched to neurodivergent capacity, strengths, or the real pressures people face in their families and workplaces.
+            <a:pPr indent="0" marL="0">
+              <a:lnSpc>
+                <a:spcPct val="130000"/>
+              </a:lnSpc>
+              <a:buNone/>
+            </a:pPr>
+            <a:r>
+              <a:rPr lang="en-US" sz="1300" dirty="0">
+                <a:solidFill>
+                  <a:srgbClr val="333333"/>
+                </a:solidFill>
+                <a:latin typeface="Aptos" pitchFamily="34" charset="0"/>
+                <a:ea typeface="Aptos" pitchFamily="34" charset="-122"/>
+                <a:cs typeface="Aptos" pitchFamily="34" charset="-120"/>
+              </a:rPr>
+              <a:t>Much of it does not translate to real capacity, strengths, and family pressure.
 </a:t>
             </a:r>
-            <a:endParaRPr lang="en-US" sz="1600" dirty="0"/>
-          </a:p>
-          <a:p>
-            <a:pPr indent="0" marL="0">
-              <a:buNone/>
-            </a:pPr>
-            <a:r>
-              <a:rPr lang="en-US" sz="1600" dirty="0">
-                <a:solidFill>
-                  <a:srgbClr val="2D2D2D"/>
-                </a:solidFill>
-                <a:latin typeface="Montserrat" pitchFamily="34" charset="0"/>
-                <a:ea typeface="Montserrat" pitchFamily="34" charset="-122"/>
-                <a:cs typeface="Montserrat" pitchFamily="34" charset="-120"/>
-              </a:rPr>
-              <a:t>The goals tension
+            <a:pPr indent="0" marL="0">
+              <a:lnSpc>
+                <a:spcPct val="130000"/>
+              </a:lnSpc>
+              <a:buNone/>
+            </a:pPr>
+            <a:r>
+              <a:rPr lang="en-US" sz="1300" b="1" dirty="0">
+                <a:solidFill>
+                  <a:srgbClr val="333333"/>
+                </a:solidFill>
+                <a:latin typeface="Aptos" pitchFamily="34" charset="0"/>
+                <a:ea typeface="Aptos" pitchFamily="34" charset="-122"/>
+                <a:cs typeface="Aptos" pitchFamily="34" charset="-120"/>
+              </a:rPr>
+              <a:t>Quick fixes often work briefly.
 </a:t>
             </a:r>
-            <a:endParaRPr lang="en-US" sz="1600" dirty="0"/>
-          </a:p>
-          <a:p>
-            <a:pPr indent="0" marL="0">
-              <a:buNone/>
-            </a:pPr>
-            <a:r>
-              <a:rPr lang="en-US" sz="1400" dirty="0">
-                <a:solidFill>
-                  <a:srgbClr val="2D2D2D"/>
-                </a:solidFill>
-                <a:latin typeface="Montserrat" pitchFamily="34" charset="0"/>
-                <a:ea typeface="Montserrat" pitchFamily="34" charset="-122"/>
-                <a:cs typeface="Montserrat" pitchFamily="34" charset="-120"/>
-              </a:rPr>
-              <a:t>Motivated people can still resist goals when they feel restrictive or externally imposed. Yet without some anchoring, it is hard to notice progress or direction.
+            <a:pPr indent="0" marL="0">
+              <a:lnSpc>
+                <a:spcPct val="130000"/>
+              </a:lnSpc>
+              <a:buNone/>
+            </a:pPr>
+            <a:r>
+              <a:rPr lang="en-US" sz="1300" dirty="0">
+                <a:solidFill>
+                  <a:srgbClr val="333333"/>
+                </a:solidFill>
+                <a:latin typeface="Aptos" pitchFamily="34" charset="0"/>
+                <a:ea typeface="Aptos" pitchFamily="34" charset="-122"/>
+                <a:cs typeface="Aptos" pitchFamily="34" charset="-120"/>
+              </a:rPr>
+              <a:t>When capacity drops, they collapse and reinforce a sense of failure.
 </a:t>
             </a:r>
-            <a:endParaRPr lang="en-US" sz="1600" dirty="0"/>
-          </a:p>
-          <a:p>
-            <a:pPr indent="0" marL="0">
-              <a:buNone/>
-            </a:pPr>
-            <a:r>
-              <a:rPr lang="en-US" sz="1600" dirty="0">
-                <a:solidFill>
-                  <a:srgbClr val="2D2D2D"/>
-                </a:solidFill>
-                <a:latin typeface="Montserrat" pitchFamily="34" charset="0"/>
-                <a:ea typeface="Montserrat" pitchFamily="34" charset="-122"/>
-                <a:cs typeface="Montserrat" pitchFamily="34" charset="-120"/>
-              </a:rPr>
-              <a:t>Why a weekly container can help
+            <a:pPr indent="0" marL="0">
+              <a:lnSpc>
+                <a:spcPct val="130000"/>
+              </a:lnSpc>
+              <a:buNone/>
+            </a:pPr>
+            <a:r>
+              <a:rPr lang="en-US" sz="1300" b="1" dirty="0">
+                <a:solidFill>
+                  <a:srgbClr val="333333"/>
+                </a:solidFill>
+                <a:latin typeface="Aptos" pitchFamily="34" charset="0"/>
+                <a:ea typeface="Aptos" pitchFamily="34" charset="-122"/>
+                <a:cs typeface="Aptos" pitchFamily="34" charset="-120"/>
+              </a:rPr>
+              <a:t>Many people are motivated and capable.
 </a:t>
             </a:r>
-            <a:endParaRPr lang="en-US" sz="1600" dirty="0"/>
-          </a:p>
-          <a:p>
-            <a:pPr indent="0" marL="0">
-              <a:buNone/>
-            </a:pPr>
-            <a:r>
-              <a:rPr lang="en-US" sz="1400" dirty="0">
-                <a:solidFill>
-                  <a:srgbClr val="2D2D2D"/>
-                </a:solidFill>
-                <a:latin typeface="Montserrat" pitchFamily="34" charset="0"/>
-                <a:ea typeface="Montserrat" pitchFamily="34" charset="-122"/>
-                <a:cs typeface="Montserrat" pitchFamily="34" charset="-120"/>
-              </a:rPr>
-              <a:t>A regular check-in creates visibility without pressure. It supports noticing patterns, tracking what is working, and adjusting in real time.</a:t>
-            </a:r>
-            <a:endParaRPr lang="en-US" sz="1600" dirty="0"/>
-          </a:p>
-        </p:txBody>
-      </p:sp>
-      <p:sp>
-        <p:nvSpPr>
-          <p:cNvPr id="4" name="Text 2"/>
+            <a:pPr indent="0" marL="0">
+              <a:lnSpc>
+                <a:spcPct val="130000"/>
+              </a:lnSpc>
+              <a:buNone/>
+            </a:pPr>
+            <a:r>
+              <a:rPr lang="en-US" sz="1300" dirty="0">
+                <a:solidFill>
+                  <a:srgbClr val="333333"/>
+                </a:solidFill>
+                <a:latin typeface="Aptos" pitchFamily="34" charset="0"/>
+                <a:ea typeface="Aptos" pitchFamily="34" charset="-122"/>
+                <a:cs typeface="Aptos" pitchFamily="34" charset="-120"/>
+              </a:rPr>
+              <a:t>They can still resist goals when those goals feel restrictive.
+</a:t>
+            </a:r>
+            <a:pPr indent="0" marL="0">
+              <a:lnSpc>
+                <a:spcPct val="130000"/>
+              </a:lnSpc>
+              <a:buNone/>
+            </a:pPr>
+            <a:r>
+              <a:rPr lang="en-US" sz="1300" b="1" dirty="0">
+                <a:solidFill>
+                  <a:srgbClr val="333333"/>
+                </a:solidFill>
+                <a:latin typeface="Aptos" pitchFamily="34" charset="0"/>
+                <a:ea typeface="Aptos" pitchFamily="34" charset="-122"/>
+                <a:cs typeface="Aptos" pitchFamily="34" charset="-120"/>
+              </a:rPr>
+              <a:t>People still need anchoring.
+</a:t>
+            </a:r>
+            <a:pPr indent="0" marL="0">
+              <a:lnSpc>
+                <a:spcPct val="130000"/>
+              </a:lnSpc>
+              <a:buNone/>
+            </a:pPr>
+            <a:r>
+              <a:rPr lang="en-US" sz="1300" dirty="0">
+                <a:solidFill>
+                  <a:srgbClr val="333333"/>
+                </a:solidFill>
+                <a:latin typeface="Aptos" pitchFamily="34" charset="0"/>
+                <a:ea typeface="Aptos" pitchFamily="34" charset="-122"/>
+                <a:cs typeface="Aptos" pitchFamily="34" charset="-120"/>
+              </a:rPr>
+              <a:t>A small number of steady points the nervous system can rely on week to week.</a:t>
+            </a:r>
+            <a:endParaRPr lang="en-US" sz="1300" dirty="0"/>
+          </a:p>
+        </p:txBody>
+      </p:sp>
+      <p:sp>
+        <p:nvSpPr>
+          <p:cNvPr id="4" name="Shape 2"/>
           <p:cNvSpPr/>
           <p:nvPr/>
         </p:nvSpPr>
         <p:spPr>
           <a:xfrm>
-            <a:off x="457200" y="4754880"/>
-            <a:ext cx="8229600" cy="274320"/>
+            <a:off x="548640" y="3749040"/>
+            <a:ext cx="8046720" cy="548640"/>
+          </a:xfrm>
+          <a:prstGeom prst="rect">
+            <a:avLst>
+              <a:gd name="adj" fmla="val 8333"/>
+            </a:avLst>
+          </a:prstGeom>
+          <a:solidFill>
+            <a:srgbClr val="F5F5F5"/>
+          </a:solidFill>
+          <a:ln w="12700">
+            <a:solidFill>
+              <a:srgbClr val="F5F5F5"/>
+            </a:solidFill>
+            <a:prstDash val="solid"/>
+          </a:ln>
+        </p:spPr>
+      </p:sp>
+      <p:sp>
+        <p:nvSpPr>
+          <p:cNvPr id="5" name="Text 3"/>
+          <p:cNvSpPr/>
+          <p:nvPr/>
+        </p:nvSpPr>
+        <p:spPr>
+          <a:xfrm>
+            <a:off x="731520" y="3840480"/>
+            <a:ext cx="7680960" cy="365760"/>
           </a:xfrm>
           <a:prstGeom prst="rect">
             <a:avLst/>
@@ -2711,24 +2991,45 @@
           <a:ln/>
         </p:spPr>
         <p:txBody>
-          <a:bodyPr wrap="square" rtlCol="0" anchor="ctr"/>
-          <a:lstStyle/>
-          <a:p>
-            <a:pPr algn="ctr" indent="0" marL="0">
-              <a:buNone/>
-            </a:pPr>
-            <a:r>
-              <a:rPr lang="en-US" sz="900" dirty="0">
-                <a:solidFill>
-                  <a:srgbClr val="2D2D2D"/>
-                </a:solidFill>
-                <a:latin typeface="Montserrat" pitchFamily="34" charset="0"/>
-                <a:ea typeface="Montserrat" pitchFamily="34" charset="-122"/>
-                <a:cs typeface="Montserrat" pitchFamily="34" charset="-120"/>
-              </a:rPr>
-              <a:t>Strengths-Based Coaching and Counselling | www.coach4u.com.au | cath@coach4u.com.au | 0402 313 337</a:t>
-            </a:r>
-            <a:endParaRPr lang="en-US" sz="900" dirty="0"/>
+          <a:bodyPr wrap="square" rtlCol="0" anchor="t"/>
+          <a:lstStyle/>
+          <a:p>
+            <a:pPr indent="0" marL="0">
+              <a:lnSpc>
+                <a:spcPct val="130000"/>
+              </a:lnSpc>
+              <a:buNone/>
+            </a:pPr>
+            <a:r>
+              <a:rPr lang="en-US" sz="1100" b="1" dirty="0">
+                <a:solidFill>
+                  <a:srgbClr val="003366"/>
+                </a:solidFill>
+                <a:latin typeface="Aptos" pitchFamily="34" charset="0"/>
+                <a:ea typeface="Aptos" pitchFamily="34" charset="-122"/>
+                <a:cs typeface="Aptos" pitchFamily="34" charset="-120"/>
+              </a:rPr>
+              <a:t>Discussion prompt:
+</a:t>
+            </a:r>
+            <a:pPr indent="0" marL="0">
+              <a:lnSpc>
+                <a:spcPct val="130000"/>
+              </a:lnSpc>
+              <a:buNone/>
+            </a:pPr>
+            <a:r>
+              <a:rPr lang="en-US" sz="1100" i="1" dirty="0">
+                <a:solidFill>
+                  <a:srgbClr val="333333"/>
+                </a:solidFill>
+                <a:latin typeface="Aptos" pitchFamily="34" charset="0"/>
+                <a:ea typeface="Aptos" pitchFamily="34" charset="-122"/>
+                <a:cs typeface="Aptos" pitchFamily="34" charset="-120"/>
+              </a:rPr>
+              <a:t>What works briefly for clients, then collapses when capacity drops?</a:t>
+            </a:r>
+            <a:endParaRPr lang="en-US" sz="1100" dirty="0"/>
           </a:p>
         </p:txBody>
       </p:sp>
@@ -2772,8 +3073,8 @@
         </p:nvSpPr>
         <p:spPr>
           <a:xfrm>
-            <a:off x="457200" y="365760"/>
-            <a:ext cx="8229600" cy="548640"/>
+            <a:off x="548640" y="365760"/>
+            <a:ext cx="8046720" cy="457200"/>
           </a:xfrm>
           <a:prstGeom prst="rect">
             <a:avLst/>
@@ -2782,24 +3083,24 @@
           <a:ln/>
         </p:spPr>
         <p:txBody>
-          <a:bodyPr wrap="square" lIns="0" tIns="0" rIns="0" bIns="0" rtlCol="0" anchor="ctr"/>
-          <a:lstStyle/>
-          <a:p>
-            <a:pPr algn="l" indent="0" marL="0">
-              <a:buNone/>
-            </a:pPr>
-            <a:r>
-              <a:rPr lang="en-US" sz="3200" b="1" dirty="0">
-                <a:solidFill>
-                  <a:srgbClr val="1B3664"/>
-                </a:solidFill>
-                <a:latin typeface="Inter" pitchFamily="34" charset="0"/>
-                <a:ea typeface="Inter" pitchFamily="34" charset="-122"/>
-                <a:cs typeface="Inter" pitchFamily="34" charset="-120"/>
-              </a:rPr>
-              <a:t>Introducing SAFE as a Response Framework</a:t>
-            </a:r>
-            <a:endParaRPr lang="en-US" sz="3200" dirty="0"/>
+          <a:bodyPr wrap="square" rtlCol="0" anchor="ctr"/>
+          <a:lstStyle/>
+          <a:p>
+            <a:pPr indent="0" marL="0">
+              <a:buNone/>
+            </a:pPr>
+            <a:r>
+              <a:rPr lang="en-US" sz="2400" b="1" dirty="0">
+                <a:solidFill>
+                  <a:srgbClr val="003366"/>
+                </a:solidFill>
+                <a:latin typeface="Aptos" pitchFamily="34" charset="0"/>
+                <a:ea typeface="Aptos" pitchFamily="34" charset="-122"/>
+                <a:cs typeface="Aptos" pitchFamily="34" charset="-120"/>
+              </a:rPr>
+              <a:t>Introducing SAFE as a response framework</a:t>
+            </a:r>
+            <a:endParaRPr lang="en-US" sz="2400" dirty="0"/>
           </a:p>
         </p:txBody>
       </p:sp>
@@ -2811,8 +3112,8 @@
         </p:nvSpPr>
         <p:spPr>
           <a:xfrm>
-            <a:off x="457200" y="1097280"/>
-            <a:ext cx="8229600" cy="2743200"/>
+            <a:off x="548640" y="1005840"/>
+            <a:ext cx="8046720" cy="2011680"/>
           </a:xfrm>
           <a:prstGeom prst="rect">
             <a:avLst/>
@@ -2821,91 +3122,141 @@
           <a:ln/>
         </p:spPr>
         <p:txBody>
-          <a:bodyPr wrap="square" rtlCol="0" anchor="ctr"/>
-          <a:lstStyle/>
-          <a:p>
-            <a:pPr indent="0" marL="0">
-              <a:buNone/>
-            </a:pPr>
-            <a:r>
-              <a:rPr lang="en-US" sz="1600" dirty="0">
-                <a:solidFill>
-                  <a:srgbClr val="2D2D2D"/>
-                </a:solidFill>
-                <a:latin typeface="Montserrat" pitchFamily="34" charset="0"/>
-                <a:ea typeface="Montserrat" pitchFamily="34" charset="-122"/>
-                <a:cs typeface="Montserrat" pitchFamily="34" charset="-120"/>
-              </a:rPr>
-              <a:t>SAFE is how I organise my response when capacity is under pressure
+          <a:bodyPr wrap="square" rtlCol="0" anchor="t"/>
+          <a:lstStyle/>
+          <a:p>
+            <a:pPr indent="0" marL="0">
+              <a:lnSpc>
+                <a:spcPct val="135000"/>
+              </a:lnSpc>
+              <a:buNone/>
+            </a:pPr>
+            <a:r>
+              <a:rPr lang="en-US" sz="1300" dirty="0">
+                <a:solidFill>
+                  <a:srgbClr val="333333"/>
+                </a:solidFill>
+                <a:latin typeface="Aptos" pitchFamily="34" charset="0"/>
+                <a:ea typeface="Aptos" pitchFamily="34" charset="-122"/>
+                <a:cs typeface="Aptos" pitchFamily="34" charset="-120"/>
+              </a:rPr>
+              <a:t>SAFE is how I organise my response when capacity is under pressure.
 </a:t>
             </a:r>
-            <a:endParaRPr lang="en-US" sz="1600" dirty="0"/>
-          </a:p>
-          <a:p>
-            <a:pPr indent="0" marL="0">
-              <a:buNone/>
-            </a:pPr>
-            <a:r>
-              <a:rPr lang="en-US" sz="1400" dirty="0">
-                <a:solidFill>
-                  <a:srgbClr val="2D2D2D"/>
-                </a:solidFill>
-                <a:latin typeface="Montserrat" pitchFamily="34" charset="0"/>
-                <a:ea typeface="Montserrat" pitchFamily="34" charset="-122"/>
-                <a:cs typeface="Montserrat" pitchFamily="34" charset="-120"/>
-              </a:rPr>
-              <a:t>It is not a diagnostic model and not something I am asking you to adopt. Think of it as one way to structure observations and interventions.
+            <a:pPr indent="0" marL="0">
+              <a:lnSpc>
+                <a:spcPct val="135000"/>
+              </a:lnSpc>
+              <a:buNone/>
+            </a:pPr>
+            <a:r>
+              <a:rPr lang="en-US" sz="1300" dirty="0">
+                <a:solidFill>
+                  <a:srgbClr val="333333"/>
+                </a:solidFill>
+                <a:latin typeface="Aptos" pitchFamily="34" charset="0"/>
+                <a:ea typeface="Aptos" pitchFamily="34" charset="-122"/>
+                <a:cs typeface="Aptos" pitchFamily="34" charset="-120"/>
+              </a:rPr>
+              <a:t>It is not a diagnostic model.
 </a:t>
             </a:r>
-            <a:endParaRPr lang="en-US" sz="1600" dirty="0"/>
-          </a:p>
-          <a:p>
-            <a:pPr indent="0" marL="0">
-              <a:buNone/>
-            </a:pPr>
-            <a:r>
-              <a:rPr lang="en-US" sz="1600" dirty="0">
-                <a:solidFill>
-                  <a:srgbClr val="2D2D2D"/>
-                </a:solidFill>
-                <a:latin typeface="Montserrat" pitchFamily="34" charset="0"/>
-                <a:ea typeface="Montserrat" pitchFamily="34" charset="-122"/>
-                <a:cs typeface="Montserrat" pitchFamily="34" charset="-120"/>
-              </a:rPr>
-              <a:t>What to watch for in the video
+            <a:pPr indent="0" marL="0">
+              <a:lnSpc>
+                <a:spcPct val="135000"/>
+              </a:lnSpc>
+              <a:buNone/>
+            </a:pPr>
+            <a:r>
+              <a:rPr lang="en-US" sz="1300" dirty="0">
+                <a:solidFill>
+                  <a:srgbClr val="333333"/>
+                </a:solidFill>
+                <a:latin typeface="Aptos" pitchFamily="34" charset="0"/>
+                <a:ea typeface="Aptos" pitchFamily="34" charset="-122"/>
+                <a:cs typeface="Aptos" pitchFamily="34" charset="-120"/>
+              </a:rPr>
+              <a:t>It is not something I am asking you to adopt.
 </a:t>
             </a:r>
-            <a:endParaRPr lang="en-US" sz="1600" dirty="0"/>
-          </a:p>
-          <a:p>
-            <a:pPr indent="0" marL="0">
-              <a:buNone/>
-            </a:pPr>
-            <a:r>
-              <a:rPr lang="en-US" sz="1400" i="1" dirty="0">
-                <a:solidFill>
-                  <a:srgbClr val="2D2D2D"/>
-                </a:solidFill>
-                <a:latin typeface="Montserrat" pitchFamily="34" charset="0"/>
-                <a:ea typeface="Montserrat" pitchFamily="34" charset="-122"/>
-                <a:cs typeface="Montserrat" pitchFamily="34" charset="-120"/>
-              </a:rPr>
-              <a:t>Notice what feels useful, what might need care in how it is introduced, and what language would make it more neurodivergence-affirming.</a:t>
-            </a:r>
-            <a:endParaRPr lang="en-US" sz="1600" dirty="0"/>
-          </a:p>
-        </p:txBody>
-      </p:sp>
-      <p:sp>
-        <p:nvSpPr>
-          <p:cNvPr id="4" name="Text 2"/>
+            <a:pPr indent="0" marL="0">
+              <a:lnSpc>
+                <a:spcPct val="135000"/>
+              </a:lnSpc>
+              <a:buNone/>
+            </a:pPr>
+            <a:r>
+              <a:rPr lang="en-US" sz="1300" dirty="0">
+                <a:solidFill>
+                  <a:srgbClr val="333333"/>
+                </a:solidFill>
+                <a:latin typeface="Aptos" pitchFamily="34" charset="0"/>
+                <a:ea typeface="Aptos" pitchFamily="34" charset="-122"/>
+                <a:cs typeface="Aptos" pitchFamily="34" charset="-120"/>
+              </a:rPr>
+              <a:t>It is one way to provide structure without restriction</a:t>
+            </a:r>
+            <a:endParaRPr lang="en-US" sz="1300" dirty="0"/>
+          </a:p>
+          <a:p>
+            <a:pPr indent="0" marL="0">
+              <a:lnSpc>
+                <a:spcPct val="135000"/>
+              </a:lnSpc>
+              <a:buNone/>
+            </a:pPr>
+            <a:r>
+              <a:rPr lang="en-US" sz="1300" dirty="0">
+                <a:solidFill>
+                  <a:srgbClr val="333333"/>
+                </a:solidFill>
+                <a:latin typeface="Aptos" pitchFamily="34" charset="0"/>
+                <a:ea typeface="Aptos" pitchFamily="34" charset="-122"/>
+                <a:cs typeface="Aptos" pitchFamily="34" charset="-120"/>
+              </a:rPr>
+              <a:t>and anchoring without pressure.</a:t>
+            </a:r>
+            <a:endParaRPr lang="en-US" sz="1300" dirty="0"/>
+          </a:p>
+        </p:txBody>
+      </p:sp>
+      <p:sp>
+        <p:nvSpPr>
+          <p:cNvPr id="4" name="Shape 2"/>
           <p:cNvSpPr/>
           <p:nvPr/>
         </p:nvSpPr>
         <p:spPr>
           <a:xfrm>
-            <a:off x="457200" y="4754880"/>
-            <a:ext cx="8229600" cy="274320"/>
+            <a:off x="548640" y="3246120"/>
+            <a:ext cx="8046720" cy="685800"/>
+          </a:xfrm>
+          <a:prstGeom prst="rect">
+            <a:avLst>
+              <a:gd name="adj" fmla="val 6667"/>
+            </a:avLst>
+          </a:prstGeom>
+          <a:solidFill>
+            <a:srgbClr val="F5F5F5"/>
+          </a:solidFill>
+          <a:ln w="12700">
+            <a:solidFill>
+              <a:srgbClr val="F5F5F5"/>
+            </a:solidFill>
+            <a:prstDash val="solid"/>
+          </a:ln>
+        </p:spPr>
+      </p:sp>
+      <p:sp>
+        <p:nvSpPr>
+          <p:cNvPr id="5" name="Text 3"/>
+          <p:cNvSpPr/>
+          <p:nvPr/>
+        </p:nvSpPr>
+        <p:spPr>
+          <a:xfrm>
+            <a:off x="731520" y="3337560"/>
+            <a:ext cx="7680960" cy="502920"/>
           </a:xfrm>
           <a:prstGeom prst="rect">
             <a:avLst/>
@@ -2914,24 +3265,45 @@
           <a:ln/>
         </p:spPr>
         <p:txBody>
-          <a:bodyPr wrap="square" rtlCol="0" anchor="ctr"/>
-          <a:lstStyle/>
-          <a:p>
-            <a:pPr algn="ctr" indent="0" marL="0">
-              <a:buNone/>
-            </a:pPr>
-            <a:r>
-              <a:rPr lang="en-US" sz="900" dirty="0">
-                <a:solidFill>
-                  <a:srgbClr val="2D2D2D"/>
-                </a:solidFill>
-                <a:latin typeface="Montserrat" pitchFamily="34" charset="0"/>
-                <a:ea typeface="Montserrat" pitchFamily="34" charset="-122"/>
-                <a:cs typeface="Montserrat" pitchFamily="34" charset="-120"/>
-              </a:rPr>
-              <a:t>Strengths-Based Coaching and Counselling | www.coach4u.com.au | cath@coach4u.com.au | 0402 313 337</a:t>
-            </a:r>
-            <a:endParaRPr lang="en-US" sz="900" dirty="0"/>
+          <a:bodyPr wrap="square" rtlCol="0" anchor="t"/>
+          <a:lstStyle/>
+          <a:p>
+            <a:pPr indent="0" marL="0">
+              <a:lnSpc>
+                <a:spcPct val="130000"/>
+              </a:lnSpc>
+              <a:buNone/>
+            </a:pPr>
+            <a:r>
+              <a:rPr lang="en-US" sz="1100" b="1" dirty="0">
+                <a:solidFill>
+                  <a:srgbClr val="003366"/>
+                </a:solidFill>
+                <a:latin typeface="Aptos" pitchFamily="34" charset="0"/>
+                <a:ea typeface="Aptos" pitchFamily="34" charset="-122"/>
+                <a:cs typeface="Aptos" pitchFamily="34" charset="-120"/>
+              </a:rPr>
+              <a:t>Reflection before the video:
+</a:t>
+            </a:r>
+            <a:pPr indent="0" marL="0">
+              <a:lnSpc>
+                <a:spcPct val="130000"/>
+              </a:lnSpc>
+              <a:buNone/>
+            </a:pPr>
+            <a:r>
+              <a:rPr lang="en-US" sz="1100" i="1" dirty="0">
+                <a:solidFill>
+                  <a:srgbClr val="333333"/>
+                </a:solidFill>
+                <a:latin typeface="Aptos" pitchFamily="34" charset="0"/>
+                <a:ea typeface="Aptos" pitchFamily="34" charset="-122"/>
+                <a:cs typeface="Aptos" pitchFamily="34" charset="-120"/>
+              </a:rPr>
+              <a:t>What feels useful, what needs care, and what language would make it more neurodivergence-affirming?</a:t>
+            </a:r>
+            <a:endParaRPr lang="en-US" sz="1100" dirty="0"/>
           </a:p>
         </p:txBody>
       </p:sp>
@@ -2949,7 +3321,7 @@
     <p:bg>
       <p:bgPr>
         <a:solidFill>
-          <a:srgbClr val="1B3664"/>
+          <a:srgbClr val="FFFFFF"/>
         </a:solidFill>
       </p:bgPr>
     </p:bg>
@@ -2975,8 +3347,8 @@
         </p:nvSpPr>
         <p:spPr>
           <a:xfrm>
-            <a:off x="457200" y="2103120"/>
-            <a:ext cx="8229600" cy="731520"/>
+            <a:off x="548640" y="365760"/>
+            <a:ext cx="8046720" cy="457200"/>
           </a:xfrm>
           <a:prstGeom prst="rect">
             <a:avLst/>
@@ -2988,21 +3360,21 @@
           <a:bodyPr wrap="square" rtlCol="0" anchor="ctr"/>
           <a:lstStyle/>
           <a:p>
-            <a:pPr algn="ctr" indent="0" marL="0">
-              <a:buNone/>
-            </a:pPr>
-            <a:r>
-              <a:rPr lang="en-US" sz="4400" b="1" dirty="0">
-                <a:solidFill>
-                  <a:srgbClr val="FFFFFF"/>
-                </a:solidFill>
-                <a:latin typeface="Inter" pitchFamily="34" charset="0"/>
-                <a:ea typeface="Inter" pitchFamily="34" charset="-122"/>
-                <a:cs typeface="Inter" pitchFamily="34" charset="-120"/>
-              </a:rPr>
-              <a:t>SAFE Video</a:t>
-            </a:r>
-            <a:endParaRPr lang="en-US" sz="4400" dirty="0"/>
+            <a:pPr indent="0" marL="0">
+              <a:buNone/>
+            </a:pPr>
+            <a:r>
+              <a:rPr lang="en-US" sz="2400" b="1" dirty="0">
+                <a:solidFill>
+                  <a:srgbClr val="003366"/>
+                </a:solidFill>
+                <a:latin typeface="Aptos" pitchFamily="34" charset="0"/>
+                <a:ea typeface="Aptos" pitchFamily="34" charset="-122"/>
+                <a:cs typeface="Aptos" pitchFamily="34" charset="-120"/>
+              </a:rPr>
+              <a:t>SAFE video</a:t>
+            </a:r>
+            <a:endParaRPr lang="en-US" sz="2400" dirty="0"/>
           </a:p>
         </p:txBody>
       </p:sp>
@@ -3014,8 +3386,8 @@
         </p:nvSpPr>
         <p:spPr>
           <a:xfrm>
-            <a:off x="457200" y="2926080"/>
-            <a:ext cx="8229600" cy="457200"/>
+            <a:off x="548640" y="1463040"/>
+            <a:ext cx="8046720" cy="365760"/>
           </a:xfrm>
           <a:prstGeom prst="rect">
             <a:avLst/>
@@ -3027,21 +3399,108 @@
           <a:bodyPr wrap="square" rtlCol="0" anchor="ctr"/>
           <a:lstStyle/>
           <a:p>
-            <a:pPr algn="ctr" indent="0" marL="0">
-              <a:buNone/>
-            </a:pPr>
-            <a:r>
-              <a:rPr lang="en-US" sz="1800" i="1" dirty="0">
-                <a:solidFill>
-                  <a:srgbClr val="5684C4"/>
-                </a:solidFill>
-                <a:latin typeface="Montserrat" pitchFamily="34" charset="0"/>
-                <a:ea typeface="Montserrat" pitchFamily="34" charset="-122"/>
-                <a:cs typeface="Montserrat" pitchFamily="34" charset="-120"/>
-              </a:rPr>
-              <a:t>[Play video here]</a:t>
-            </a:r>
-            <a:endParaRPr lang="en-US" sz="1800" dirty="0"/>
+            <a:pPr indent="0" marL="0">
+              <a:buNone/>
+            </a:pPr>
+            <a:r>
+              <a:rPr lang="en-US" sz="1300" dirty="0">
+                <a:solidFill>
+                  <a:srgbClr val="333333"/>
+                </a:solidFill>
+                <a:latin typeface="Aptos" pitchFamily="34" charset="0"/>
+                <a:ea typeface="Aptos" pitchFamily="34" charset="-122"/>
+                <a:cs typeface="Aptos" pitchFamily="34" charset="-120"/>
+              </a:rPr>
+              <a:t>Play the client video.</a:t>
+            </a:r>
+            <a:endParaRPr lang="en-US" sz="1300" dirty="0"/>
+          </a:p>
+        </p:txBody>
+      </p:sp>
+      <p:sp>
+        <p:nvSpPr>
+          <p:cNvPr id="4" name="Shape 2"/>
+          <p:cNvSpPr/>
+          <p:nvPr/>
+        </p:nvSpPr>
+        <p:spPr>
+          <a:xfrm>
+            <a:off x="548640" y="2377440"/>
+            <a:ext cx="8046720" cy="640080"/>
+          </a:xfrm>
+          <a:prstGeom prst="rect">
+            <a:avLst>
+              <a:gd name="adj" fmla="val 7143"/>
+            </a:avLst>
+          </a:prstGeom>
+          <a:solidFill>
+            <a:srgbClr val="F5F5F5"/>
+          </a:solidFill>
+          <a:ln w="12700">
+            <a:solidFill>
+              <a:srgbClr val="F5F5F5"/>
+            </a:solidFill>
+            <a:prstDash val="solid"/>
+          </a:ln>
+        </p:spPr>
+      </p:sp>
+      <p:sp>
+        <p:nvSpPr>
+          <p:cNvPr id="5" name="Text 3"/>
+          <p:cNvSpPr/>
+          <p:nvPr/>
+        </p:nvSpPr>
+        <p:spPr>
+          <a:xfrm>
+            <a:off x="731520" y="2468880"/>
+            <a:ext cx="7680960" cy="457200"/>
+          </a:xfrm>
+          <a:prstGeom prst="rect">
+            <a:avLst/>
+          </a:prstGeom>
+          <a:noFill/>
+          <a:ln/>
+        </p:spPr>
+        <p:txBody>
+          <a:bodyPr wrap="square" rtlCol="0" anchor="t"/>
+          <a:lstStyle/>
+          <a:p>
+            <a:pPr indent="0" marL="0">
+              <a:lnSpc>
+                <a:spcPct val="130000"/>
+              </a:lnSpc>
+              <a:buNone/>
+            </a:pPr>
+            <a:r>
+              <a:rPr lang="en-US" sz="1100" b="1" dirty="0">
+                <a:solidFill>
+                  <a:srgbClr val="003366"/>
+                </a:solidFill>
+                <a:latin typeface="Aptos" pitchFamily="34" charset="0"/>
+                <a:ea typeface="Aptos" pitchFamily="34" charset="-122"/>
+                <a:cs typeface="Aptos" pitchFamily="34" charset="-120"/>
+              </a:rPr>
+              <a:t>Reflection question:
+</a:t>
+            </a:r>
+            <a:pPr indent="0" marL="0">
+              <a:lnSpc>
+                <a:spcPct val="130000"/>
+              </a:lnSpc>
+              <a:buNone/>
+            </a:pPr>
+            <a:r>
+              <a:rPr lang="en-US" sz="1100" i="1" dirty="0">
+                <a:solidFill>
+                  <a:srgbClr val="333333"/>
+                </a:solidFill>
+                <a:latin typeface="Aptos" pitchFamily="34" charset="0"/>
+                <a:ea typeface="Aptos" pitchFamily="34" charset="-122"/>
+                <a:cs typeface="Aptos" pitchFamily="34" charset="-120"/>
+              </a:rPr>
+              <a:t>What part of this would help a client feel more oriented this week?</a:t>
+            </a:r>
+            <a:endParaRPr lang="en-US" sz="1100" dirty="0"/>
           </a:p>
         </p:txBody>
       </p:sp>
@@ -3085,8 +3544,8 @@
         </p:nvSpPr>
         <p:spPr>
           <a:xfrm>
-            <a:off x="457200" y="365760"/>
-            <a:ext cx="8229600" cy="548640"/>
+            <a:off x="548640" y="365760"/>
+            <a:ext cx="8046720" cy="457200"/>
           </a:xfrm>
           <a:prstGeom prst="rect">
             <a:avLst/>
@@ -3095,24 +3554,24 @@
           <a:ln/>
         </p:spPr>
         <p:txBody>
-          <a:bodyPr wrap="square" lIns="0" tIns="0" rIns="0" bIns="0" rtlCol="0" anchor="ctr"/>
-          <a:lstStyle/>
-          <a:p>
-            <a:pPr algn="l" indent="0" marL="0">
-              <a:buNone/>
-            </a:pPr>
-            <a:r>
-              <a:rPr lang="en-US" sz="3200" b="1" dirty="0">
-                <a:solidFill>
-                  <a:srgbClr val="1B3664"/>
-                </a:solidFill>
-                <a:latin typeface="Inter" pitchFamily="34" charset="0"/>
-                <a:ea typeface="Inter" pitchFamily="34" charset="-122"/>
-                <a:cs typeface="Inter" pitchFamily="34" charset="-120"/>
-              </a:rPr>
-              <a:t>Discussion: What Lands, What Does Not, What is Useful</a:t>
-            </a:r>
-            <a:endParaRPr lang="en-US" sz="3200" dirty="0"/>
+          <a:bodyPr wrap="square" rtlCol="0" anchor="ctr"/>
+          <a:lstStyle/>
+          <a:p>
+            <a:pPr indent="0" marL="0">
+              <a:buNone/>
+            </a:pPr>
+            <a:r>
+              <a:rPr lang="en-US" sz="2400" b="1" dirty="0">
+                <a:solidFill>
+                  <a:srgbClr val="003366"/>
+                </a:solidFill>
+                <a:latin typeface="Aptos" pitchFamily="34" charset="0"/>
+                <a:ea typeface="Aptos" pitchFamily="34" charset="-122"/>
+                <a:cs typeface="Aptos" pitchFamily="34" charset="-120"/>
+              </a:rPr>
+              <a:t>Discussion after the video</a:t>
+            </a:r>
+            <a:endParaRPr lang="en-US" sz="2400" dirty="0"/>
           </a:p>
         </p:txBody>
       </p:sp>
@@ -3124,8 +3583,8 @@
         </p:nvSpPr>
         <p:spPr>
           <a:xfrm>
-            <a:off x="457200" y="1188720"/>
-            <a:ext cx="8229600" cy="3200400"/>
+            <a:off x="548640" y="1097280"/>
+            <a:ext cx="8046720" cy="2560320"/>
           </a:xfrm>
           <a:prstGeom prst="rect">
             <a:avLst/>
@@ -3134,166 +3593,81 @@
           <a:ln/>
         </p:spPr>
         <p:txBody>
-          <a:bodyPr wrap="square" rtlCol="0" anchor="ctr"/>
-          <a:lstStyle/>
-          <a:p>
-            <a:pPr marL="342900" indent="-342900">
-              <a:buSzPct val="100000"/>
-              <a:buChar char="•"/>
-            </a:pPr>
-            <a:r>
-              <a:rPr lang="en-US" sz="1600" dirty="0">
-                <a:solidFill>
-                  <a:srgbClr val="2D2D2D"/>
-                </a:solidFill>
-                <a:latin typeface="Montserrat" pitchFamily="34" charset="0"/>
-                <a:ea typeface="Montserrat" pitchFamily="34" charset="-122"/>
-                <a:cs typeface="Montserrat" pitchFamily="34" charset="-120"/>
+          <a:bodyPr wrap="square" rtlCol="0" anchor="t"/>
+          <a:lstStyle/>
+          <a:p>
+            <a:pPr indent="0" marL="0">
+              <a:lnSpc>
+                <a:spcPct val="150000"/>
+              </a:lnSpc>
+              <a:buNone/>
+            </a:pPr>
+            <a:r>
+              <a:rPr lang="en-US" sz="1300" dirty="0">
+                <a:solidFill>
+                  <a:srgbClr val="333333"/>
+                </a:solidFill>
+                <a:latin typeface="Aptos" pitchFamily="34" charset="0"/>
+                <a:ea typeface="Aptos" pitchFamily="34" charset="-122"/>
+                <a:cs typeface="Aptos" pitchFamily="34" charset="-120"/>
               </a:rPr>
               <a:t>What matched your experience in practice?
 </a:t>
             </a:r>
-            <a:endParaRPr lang="en-US" sz="1600" dirty="0"/>
-          </a:p>
-          <a:p>
-            <a:pPr indent="0" marL="0">
-              <a:buNone/>
-            </a:pPr>
-            <a:r>
-              <a:rPr lang="en-US" sz="1600" dirty="0">
-                <a:solidFill>
-                  <a:srgbClr val="000000"/>
-                </a:solidFill>
-              </a:rPr>
-              <a:t>
-</a:t>
-            </a:r>
-            <a:endParaRPr lang="en-US" sz="1600" dirty="0"/>
-          </a:p>
-          <a:p>
-            <a:pPr marL="342900" indent="-342900">
-              <a:buSzPct val="100000"/>
-              <a:buChar char="•"/>
-            </a:pPr>
-            <a:r>
-              <a:rPr lang="en-US" sz="1600" dirty="0">
-                <a:solidFill>
-                  <a:srgbClr val="2D2D2D"/>
-                </a:solidFill>
-                <a:latin typeface="Montserrat" pitchFamily="34" charset="0"/>
-                <a:ea typeface="Montserrat" pitchFamily="34" charset="-122"/>
-                <a:cs typeface="Montserrat" pitchFamily="34" charset="-120"/>
+            <a:pPr indent="0" marL="0">
+              <a:lnSpc>
+                <a:spcPct val="150000"/>
+              </a:lnSpc>
+              <a:buNone/>
+            </a:pPr>
+            <a:r>
+              <a:rPr lang="en-US" sz="1300" dirty="0">
+                <a:solidFill>
+                  <a:srgbClr val="333333"/>
+                </a:solidFill>
+                <a:latin typeface="Aptos" pitchFamily="34" charset="0"/>
+                <a:ea typeface="Aptos" pitchFamily="34" charset="-122"/>
+                <a:cs typeface="Aptos" pitchFamily="34" charset="-120"/>
               </a:rPr>
               <a:t>What felt vague or could be misused?
 </a:t>
             </a:r>
-            <a:endParaRPr lang="en-US" sz="1600" dirty="0"/>
-          </a:p>
-          <a:p>
-            <a:pPr indent="0" marL="0">
-              <a:buNone/>
-            </a:pPr>
-            <a:r>
-              <a:rPr lang="en-US" sz="1600" dirty="0">
-                <a:solidFill>
-                  <a:srgbClr val="000000"/>
-                </a:solidFill>
-              </a:rPr>
-              <a:t>
-</a:t>
-            </a:r>
-            <a:endParaRPr lang="en-US" sz="1600" dirty="0"/>
-          </a:p>
-          <a:p>
-            <a:pPr marL="342900" indent="-342900">
-              <a:buSzPct val="100000"/>
-              <a:buChar char="•"/>
-            </a:pPr>
-            <a:r>
-              <a:rPr lang="en-US" sz="1600" dirty="0">
-                <a:solidFill>
-                  <a:srgbClr val="2D2D2D"/>
-                </a:solidFill>
-                <a:latin typeface="Montserrat" pitchFamily="34" charset="0"/>
-                <a:ea typeface="Montserrat" pitchFamily="34" charset="-122"/>
-                <a:cs typeface="Montserrat" pitchFamily="34" charset="-120"/>
+            <a:pPr indent="0" marL="0">
+              <a:lnSpc>
+                <a:spcPct val="150000"/>
+              </a:lnSpc>
+              <a:buNone/>
+            </a:pPr>
+            <a:r>
+              <a:rPr lang="en-US" sz="1300" dirty="0">
+                <a:solidFill>
+                  <a:srgbClr val="333333"/>
+                </a:solidFill>
+                <a:latin typeface="Aptos" pitchFamily="34" charset="0"/>
+                <a:ea typeface="Aptos" pitchFamily="34" charset="-122"/>
+                <a:cs typeface="Aptos" pitchFamily="34" charset="-120"/>
               </a:rPr>
               <a:t>What language would make it more neurodivergence-affirming?
 </a:t>
             </a:r>
-            <a:endParaRPr lang="en-US" sz="1600" dirty="0"/>
-          </a:p>
-          <a:p>
-            <a:pPr indent="0" marL="0">
-              <a:buNone/>
-            </a:pPr>
-            <a:r>
-              <a:rPr lang="en-US" sz="1600" dirty="0">
-                <a:solidFill>
-                  <a:srgbClr val="000000"/>
-                </a:solidFill>
-              </a:rPr>
-              <a:t>
-</a:t>
-            </a:r>
-            <a:endParaRPr lang="en-US" sz="1600" dirty="0"/>
-          </a:p>
-          <a:p>
-            <a:pPr marL="342900" indent="-342900">
-              <a:buSzPct val="100000"/>
-              <a:buChar char="•"/>
-            </a:pPr>
-            <a:r>
-              <a:rPr lang="en-US" sz="1600" dirty="0">
-                <a:solidFill>
-                  <a:srgbClr val="2D2D2D"/>
-                </a:solidFill>
-                <a:latin typeface="Montserrat" pitchFamily="34" charset="0"/>
-                <a:ea typeface="Montserrat" pitchFamily="34" charset="-122"/>
-                <a:cs typeface="Montserrat" pitchFamily="34" charset="-120"/>
-              </a:rPr>
-              <a:t>What might be different across settings and disciplines?</a:t>
-            </a:r>
-            <a:endParaRPr lang="en-US" sz="1600" dirty="0"/>
-          </a:p>
-        </p:txBody>
-      </p:sp>
-      <p:sp>
-        <p:nvSpPr>
-          <p:cNvPr id="4" name="Text 2"/>
-          <p:cNvSpPr/>
-          <p:nvPr/>
-        </p:nvSpPr>
-        <p:spPr>
-          <a:xfrm>
-            <a:off x="457200" y="4754880"/>
-            <a:ext cx="8229600" cy="274320"/>
-          </a:xfrm>
-          <a:prstGeom prst="rect">
-            <a:avLst/>
-          </a:prstGeom>
-          <a:noFill/>
-          <a:ln/>
-        </p:spPr>
-        <p:txBody>
-          <a:bodyPr wrap="square" rtlCol="0" anchor="ctr"/>
-          <a:lstStyle/>
-          <a:p>
-            <a:pPr algn="ctr" indent="0" marL="0">
-              <a:buNone/>
-            </a:pPr>
-            <a:r>
-              <a:rPr lang="en-US" sz="900" dirty="0">
-                <a:solidFill>
-                  <a:srgbClr val="2D2D2D"/>
-                </a:solidFill>
-                <a:latin typeface="Montserrat" pitchFamily="34" charset="0"/>
-                <a:ea typeface="Montserrat" pitchFamily="34" charset="-122"/>
-                <a:cs typeface="Montserrat" pitchFamily="34" charset="-120"/>
-              </a:rPr>
-              <a:t>Strengths-Based Coaching and Counselling | www.coach4u.com.au | cath@coach4u.com.au | 0402 313 337</a:t>
-            </a:r>
-            <a:endParaRPr lang="en-US" sz="900" dirty="0"/>
+            <a:pPr indent="0" marL="0">
+              <a:lnSpc>
+                <a:spcPct val="150000"/>
+              </a:lnSpc>
+              <a:buNone/>
+            </a:pPr>
+            <a:r>
+              <a:rPr lang="en-US" sz="1300" dirty="0">
+                <a:solidFill>
+                  <a:srgbClr val="333333"/>
+                </a:solidFill>
+                <a:latin typeface="Aptos" pitchFamily="34" charset="0"/>
+                <a:ea typeface="Aptos" pitchFamily="34" charset="-122"/>
+                <a:cs typeface="Aptos" pitchFamily="34" charset="-120"/>
+              </a:rPr>
+              <a:t>What might differ across settings and disciplines?</a:t>
+            </a:r>
+            <a:endParaRPr lang="en-US" sz="1300" dirty="0"/>
           </a:p>
         </p:txBody>
       </p:sp>
@@ -3337,8 +3711,8 @@
         </p:nvSpPr>
         <p:spPr>
           <a:xfrm>
-            <a:off x="457200" y="365760"/>
-            <a:ext cx="8229600" cy="548640"/>
+            <a:off x="548640" y="365760"/>
+            <a:ext cx="8046720" cy="457200"/>
           </a:xfrm>
           <a:prstGeom prst="rect">
             <a:avLst/>
@@ -3347,24 +3721,24 @@
           <a:ln/>
         </p:spPr>
         <p:txBody>
-          <a:bodyPr wrap="square" lIns="0" tIns="0" rIns="0" bIns="0" rtlCol="0" anchor="ctr"/>
-          <a:lstStyle/>
-          <a:p>
-            <a:pPr algn="l" indent="0" marL="0">
-              <a:buNone/>
-            </a:pPr>
-            <a:r>
-              <a:rPr lang="en-US" sz="3200" b="1" dirty="0">
-                <a:solidFill>
-                  <a:srgbClr val="1B3664"/>
-                </a:solidFill>
-                <a:latin typeface="Inter" pitchFamily="34" charset="0"/>
-                <a:ea typeface="Inter" pitchFamily="34" charset="-122"/>
-                <a:cs typeface="Inter" pitchFamily="34" charset="-120"/>
-              </a:rPr>
-              <a:t>Making it Concrete: SAFE as Four Rooms in a House</a:t>
-            </a:r>
-            <a:endParaRPr lang="en-US" sz="3200" dirty="0"/>
+          <a:bodyPr wrap="square" rtlCol="0" anchor="ctr"/>
+          <a:lstStyle/>
+          <a:p>
+            <a:pPr indent="0" marL="0">
+              <a:buNone/>
+            </a:pPr>
+            <a:r>
+              <a:rPr lang="en-US" sz="2400" b="1" dirty="0">
+                <a:solidFill>
+                  <a:srgbClr val="003366"/>
+                </a:solidFill>
+                <a:latin typeface="Aptos" pitchFamily="34" charset="0"/>
+                <a:ea typeface="Aptos" pitchFamily="34" charset="-122"/>
+                <a:cs typeface="Aptos" pitchFamily="34" charset="-120"/>
+              </a:rPr>
+              <a:t>SAFE as four rooms in a house</a:t>
+            </a:r>
+            <a:endParaRPr lang="en-US" sz="2400" dirty="0"/>
           </a:p>
         </p:txBody>
       </p:sp>
@@ -3376,8 +3750,8 @@
         </p:nvSpPr>
         <p:spPr>
           <a:xfrm>
-            <a:off x="457200" y="1097280"/>
-            <a:ext cx="8229600" cy="3474720"/>
+            <a:off x="548640" y="1005840"/>
+            <a:ext cx="8046720" cy="1828800"/>
           </a:xfrm>
           <a:prstGeom prst="rect">
             <a:avLst/>
@@ -3386,127 +3760,121 @@
           <a:ln/>
         </p:spPr>
         <p:txBody>
-          <a:bodyPr wrap="square" rtlCol="0" anchor="ctr"/>
-          <a:lstStyle/>
-          <a:p>
-            <a:pPr indent="0" marL="0">
-              <a:buNone/>
-            </a:pPr>
-            <a:r>
-              <a:rPr lang="en-US" sz="1600" dirty="0">
-                <a:solidFill>
-                  <a:srgbClr val="2D2D2D"/>
-                </a:solidFill>
-                <a:latin typeface="Montserrat" pitchFamily="34" charset="0"/>
-                <a:ea typeface="Montserrat" pitchFamily="34" charset="-122"/>
-                <a:cs typeface="Montserrat" pitchFamily="34" charset="-120"/>
-              </a:rPr>
-              <a:t>The house metaphor
+          <a:bodyPr wrap="square" rtlCol="0" anchor="t"/>
+          <a:lstStyle/>
+          <a:p>
+            <a:pPr indent="0" marL="0">
+              <a:lnSpc>
+                <a:spcPct val="135000"/>
+              </a:lnSpc>
+              <a:buNone/>
+            </a:pPr>
+            <a:r>
+              <a:rPr lang="en-US" sz="1300" dirty="0">
+                <a:solidFill>
+                  <a:srgbClr val="333333"/>
+                </a:solidFill>
+                <a:latin typeface="Aptos" pitchFamily="34" charset="0"/>
+                <a:ea typeface="Aptos" pitchFamily="34" charset="-122"/>
+                <a:cs typeface="Aptos" pitchFamily="34" charset="-120"/>
+              </a:rPr>
+              <a:t>Think of SAFE as four rooms, not a sequence.
 </a:t>
             </a:r>
-            <a:endParaRPr lang="en-US" sz="1600" dirty="0"/>
-          </a:p>
-          <a:p>
-            <a:pPr indent="0" marL="0">
-              <a:buNone/>
-            </a:pPr>
-            <a:r>
-              <a:rPr lang="en-US" sz="1400" dirty="0">
-                <a:solidFill>
-                  <a:srgbClr val="2D2D2D"/>
-                </a:solidFill>
-                <a:latin typeface="Montserrat" pitchFamily="34" charset="0"/>
-                <a:ea typeface="Montserrat" pitchFamily="34" charset="-122"/>
-                <a:cs typeface="Montserrat" pitchFamily="34" charset="-120"/>
-              </a:rPr>
-              <a:t>Think of SAFE as four rooms, not a sequence. Sometimes one room needs attention first. Sometimes stabilising one area shifts the whole system.
+            <a:pPr indent="0" marL="0">
+              <a:lnSpc>
+                <a:spcPct val="135000"/>
+              </a:lnSpc>
+              <a:buNone/>
+            </a:pPr>
+            <a:r>
+              <a:rPr lang="en-US" sz="1300" dirty="0">
+                <a:solidFill>
+                  <a:srgbClr val="333333"/>
+                </a:solidFill>
+                <a:latin typeface="Aptos" pitchFamily="34" charset="0"/>
+                <a:ea typeface="Aptos" pitchFamily="34" charset="-122"/>
+                <a:cs typeface="Aptos" pitchFamily="34" charset="-120"/>
+              </a:rPr>
+              <a:t>There is no fixed order.
 </a:t>
             </a:r>
-            <a:endParaRPr lang="en-US" sz="1600" dirty="0"/>
-          </a:p>
-          <a:p>
-            <a:pPr indent="0" marL="0">
-              <a:buNone/>
-            </a:pPr>
-            <a:r>
-              <a:rPr lang="en-US" sz="1600" dirty="0">
-                <a:solidFill>
-                  <a:srgbClr val="2D2D2D"/>
-                </a:solidFill>
-                <a:latin typeface="Montserrat" pitchFamily="34" charset="0"/>
-                <a:ea typeface="Montserrat" pitchFamily="34" charset="-122"/>
-                <a:cs typeface="Montserrat" pitchFamily="34" charset="-120"/>
-              </a:rPr>
-              <a:t>Applied to practice
+            <a:pPr indent="0" marL="0">
+              <a:lnSpc>
+                <a:spcPct val="135000"/>
+              </a:lnSpc>
+              <a:buNone/>
+            </a:pPr>
+            <a:r>
+              <a:rPr lang="en-US" sz="1300" dirty="0">
+                <a:solidFill>
+                  <a:srgbClr val="333333"/>
+                </a:solidFill>
+                <a:latin typeface="Aptos" pitchFamily="34" charset="0"/>
+                <a:ea typeface="Aptos" pitchFamily="34" charset="-122"/>
+                <a:cs typeface="Aptos" pitchFamily="34" charset="-120"/>
+              </a:rPr>
+              <a:t>Stabilising one room can reduce load across the whole system.
 </a:t>
             </a:r>
-            <a:endParaRPr lang="en-US" sz="1600" dirty="0"/>
-          </a:p>
-          <a:p>
-            <a:pPr indent="0" marL="0">
-              <a:buNone/>
-            </a:pPr>
-            <a:r>
-              <a:rPr lang="en-US" sz="1400" dirty="0">
-                <a:solidFill>
-                  <a:srgbClr val="2D2D2D"/>
-                </a:solidFill>
-                <a:latin typeface="Montserrat" pitchFamily="34" charset="0"/>
-                <a:ea typeface="Montserrat" pitchFamily="34" charset="-122"/>
-                <a:cs typeface="Montserrat" pitchFamily="34" charset="-120"/>
-              </a:rPr>
-              <a:t>Map a de-identified vignette from your practice: which room is under strain first? What helps without adding pressure?
-</a:t>
-            </a:r>
-            <a:endParaRPr lang="en-US" sz="1600" dirty="0"/>
-          </a:p>
-          <a:p>
-            <a:pPr indent="0" marL="0">
-              <a:buNone/>
-            </a:pPr>
-            <a:r>
-              <a:rPr lang="en-US" sz="1600" dirty="0">
-                <a:solidFill>
-                  <a:srgbClr val="2D2D2D"/>
-                </a:solidFill>
-                <a:latin typeface="Montserrat" pitchFamily="34" charset="0"/>
-                <a:ea typeface="Montserrat" pitchFamily="34" charset="-122"/>
-                <a:cs typeface="Montserrat" pitchFamily="34" charset="-120"/>
-              </a:rPr>
-              <a:t>Progress without perfection
-</a:t>
-            </a:r>
-            <a:endParaRPr lang="en-US" sz="1600" dirty="0"/>
-          </a:p>
-          <a:p>
-            <a:pPr indent="0" marL="0">
-              <a:buNone/>
-            </a:pPr>
-            <a:r>
-              <a:rPr lang="en-US" sz="1400" dirty="0">
-                <a:solidFill>
-                  <a:srgbClr val="2D2D2D"/>
-                </a:solidFill>
-                <a:latin typeface="Montserrat" pitchFamily="34" charset="0"/>
-                <a:ea typeface="Montserrat" pitchFamily="34" charset="-122"/>
-                <a:cs typeface="Montserrat" pitchFamily="34" charset="-120"/>
-              </a:rPr>
-              <a:t>Some weeks, one room functioning better is a win. Expecting all four to improve at once adds pressure.</a:t>
-            </a:r>
-            <a:endParaRPr lang="en-US" sz="1600" dirty="0"/>
-          </a:p>
-        </p:txBody>
-      </p:sp>
-      <p:sp>
-        <p:nvSpPr>
-          <p:cNvPr id="4" name="Text 2"/>
+            <a:pPr indent="0" marL="0">
+              <a:lnSpc>
+                <a:spcPct val="135000"/>
+              </a:lnSpc>
+              <a:buNone/>
+            </a:pPr>
+            <a:r>
+              <a:rPr lang="en-US" sz="1300" dirty="0">
+                <a:solidFill>
+                  <a:srgbClr val="333333"/>
+                </a:solidFill>
+                <a:latin typeface="Aptos" pitchFamily="34" charset="0"/>
+                <a:ea typeface="Aptos" pitchFamily="34" charset="-122"/>
+                <a:cs typeface="Aptos" pitchFamily="34" charset="-120"/>
+              </a:rPr>
+              <a:t>Some weeks, one room functioning better is a genuine win.</a:t>
+            </a:r>
+            <a:endParaRPr lang="en-US" sz="1300" dirty="0"/>
+          </a:p>
+        </p:txBody>
+      </p:sp>
+      <p:sp>
+        <p:nvSpPr>
+          <p:cNvPr id="4" name="Shape 2"/>
           <p:cNvSpPr/>
           <p:nvPr/>
         </p:nvSpPr>
         <p:spPr>
           <a:xfrm>
-            <a:off x="457200" y="4754880"/>
-            <a:ext cx="8229600" cy="274320"/>
+            <a:off x="548640" y="3063240"/>
+            <a:ext cx="8046720" cy="777240"/>
+          </a:xfrm>
+          <a:prstGeom prst="rect">
+            <a:avLst>
+              <a:gd name="adj" fmla="val 5882"/>
+            </a:avLst>
+          </a:prstGeom>
+          <a:solidFill>
+            <a:srgbClr val="F5F5F5"/>
+          </a:solidFill>
+          <a:ln w="12700">
+            <a:solidFill>
+              <a:srgbClr val="F5F5F5"/>
+            </a:solidFill>
+            <a:prstDash val="solid"/>
+          </a:ln>
+        </p:spPr>
+      </p:sp>
+      <p:sp>
+        <p:nvSpPr>
+          <p:cNvPr id="5" name="Text 3"/>
+          <p:cNvSpPr/>
+          <p:nvPr/>
+        </p:nvSpPr>
+        <p:spPr>
+          <a:xfrm>
+            <a:off x="731520" y="3154680"/>
+            <a:ext cx="7680960" cy="594360"/>
           </a:xfrm>
           <a:prstGeom prst="rect">
             <a:avLst/>
@@ -3515,24 +3883,65 @@
           <a:ln/>
         </p:spPr>
         <p:txBody>
-          <a:bodyPr wrap="square" rtlCol="0" anchor="ctr"/>
-          <a:lstStyle/>
-          <a:p>
-            <a:pPr algn="ctr" indent="0" marL="0">
-              <a:buNone/>
-            </a:pPr>
-            <a:r>
-              <a:rPr lang="en-US" sz="900" dirty="0">
-                <a:solidFill>
-                  <a:srgbClr val="2D2D2D"/>
-                </a:solidFill>
-                <a:latin typeface="Montserrat" pitchFamily="34" charset="0"/>
-                <a:ea typeface="Montserrat" pitchFamily="34" charset="-122"/>
-                <a:cs typeface="Montserrat" pitchFamily="34" charset="-120"/>
-              </a:rPr>
-              <a:t>Strengths-Based Coaching and Counselling | www.coach4u.com.au | cath@coach4u.com.au | 0402 313 337</a:t>
-            </a:r>
-            <a:endParaRPr lang="en-US" sz="900" dirty="0"/>
+          <a:bodyPr wrap="square" rtlCol="0" anchor="t"/>
+          <a:lstStyle/>
+          <a:p>
+            <a:pPr indent="0" marL="0">
+              <a:lnSpc>
+                <a:spcPct val="130000"/>
+              </a:lnSpc>
+              <a:buNone/>
+            </a:pPr>
+            <a:r>
+              <a:rPr lang="en-US" sz="1100" b="1" dirty="0">
+                <a:solidFill>
+                  <a:srgbClr val="003366"/>
+                </a:solidFill>
+                <a:latin typeface="Aptos" pitchFamily="34" charset="0"/>
+                <a:ea typeface="Aptos" pitchFamily="34" charset="-122"/>
+                <a:cs typeface="Aptos" pitchFamily="34" charset="-120"/>
+              </a:rPr>
+              <a:t>Practice reflection:
+</a:t>
+            </a:r>
+            <a:pPr indent="0" marL="0">
+              <a:lnSpc>
+                <a:spcPct val="130000"/>
+              </a:lnSpc>
+              <a:buNone/>
+            </a:pPr>
+            <a:r>
+              <a:rPr lang="en-US" sz="1100" i="1" dirty="0">
+                <a:solidFill>
+                  <a:srgbClr val="333333"/>
+                </a:solidFill>
+                <a:latin typeface="Aptos" pitchFamily="34" charset="0"/>
+                <a:ea typeface="Aptos" pitchFamily="34" charset="-122"/>
+                <a:cs typeface="Aptos" pitchFamily="34" charset="-120"/>
+              </a:rPr>
+              <a:t>Using a de-identified vignette, which room is under strain first?</a:t>
+            </a:r>
+            <a:endParaRPr lang="en-US" sz="1100" dirty="0"/>
+          </a:p>
+          <a:p>
+            <a:pPr indent="0" marL="0">
+              <a:lnSpc>
+                <a:spcPct val="130000"/>
+              </a:lnSpc>
+              <a:buNone/>
+            </a:pPr>
+            <a:r>
+              <a:rPr lang="en-US" sz="1100" i="1" dirty="0">
+                <a:solidFill>
+                  <a:srgbClr val="333333"/>
+                </a:solidFill>
+                <a:latin typeface="Aptos" pitchFamily="34" charset="0"/>
+                <a:ea typeface="Aptos" pitchFamily="34" charset="-122"/>
+                <a:cs typeface="Aptos" pitchFamily="34" charset="-120"/>
+              </a:rPr>
+              <a:t>What helps without adding pressure?</a:t>
+            </a:r>
+            <a:endParaRPr lang="en-US" sz="1100" dirty="0"/>
           </a:p>
         </p:txBody>
       </p:sp>
@@ -3576,8 +3985,8 @@
         </p:nvSpPr>
         <p:spPr>
           <a:xfrm>
-            <a:off x="457200" y="365760"/>
-            <a:ext cx="8229600" cy="548640"/>
+            <a:off x="548640" y="365760"/>
+            <a:ext cx="8046720" cy="457200"/>
           </a:xfrm>
           <a:prstGeom prst="rect">
             <a:avLst/>
@@ -3586,24 +3995,24 @@
           <a:ln/>
         </p:spPr>
         <p:txBody>
-          <a:bodyPr wrap="square" lIns="0" tIns="0" rIns="0" bIns="0" rtlCol="0" anchor="ctr"/>
-          <a:lstStyle/>
-          <a:p>
-            <a:pPr algn="l" indent="0" marL="0">
-              <a:buNone/>
-            </a:pPr>
-            <a:r>
-              <a:rPr lang="en-US" sz="3200" b="1" dirty="0">
-                <a:solidFill>
-                  <a:srgbClr val="1B3664"/>
-                </a:solidFill>
-                <a:latin typeface="Inter" pitchFamily="34" charset="0"/>
-                <a:ea typeface="Inter" pitchFamily="34" charset="-122"/>
-                <a:cs typeface="Inter" pitchFamily="34" charset="-120"/>
-              </a:rPr>
-              <a:t>How the SAFE Tool Works</a:t>
-            </a:r>
-            <a:endParaRPr lang="en-US" sz="3200" dirty="0"/>
+          <a:bodyPr wrap="square" rtlCol="0" anchor="ctr"/>
+          <a:lstStyle/>
+          <a:p>
+            <a:pPr indent="0" marL="0">
+              <a:buNone/>
+            </a:pPr>
+            <a:r>
+              <a:rPr lang="en-US" sz="2400" b="1" dirty="0">
+                <a:solidFill>
+                  <a:srgbClr val="003366"/>
+                </a:solidFill>
+                <a:latin typeface="Aptos" pitchFamily="34" charset="0"/>
+                <a:ea typeface="Aptos" pitchFamily="34" charset="-122"/>
+                <a:cs typeface="Aptos" pitchFamily="34" charset="-120"/>
+              </a:rPr>
+              <a:t>How the SAFE tool works, in practice</a:t>
+            </a:r>
+            <a:endParaRPr lang="en-US" sz="2400" dirty="0"/>
           </a:p>
         </p:txBody>
       </p:sp>
@@ -3615,8 +4024,8 @@
         </p:nvSpPr>
         <p:spPr>
           <a:xfrm>
-            <a:off x="457200" y="1280160"/>
-            <a:ext cx="8229600" cy="3291840"/>
+            <a:off x="548640" y="1005840"/>
+            <a:ext cx="8046720" cy="3108960"/>
           </a:xfrm>
           <a:prstGeom prst="rect">
             <a:avLst/>
@@ -3625,224 +4034,191 @@
           <a:ln/>
         </p:spPr>
         <p:txBody>
-          <a:bodyPr wrap="square" rtlCol="0" anchor="ctr"/>
-          <a:lstStyle/>
-          <a:p>
-            <a:pPr indent="0" marL="0">
-              <a:buNone/>
-            </a:pPr>
-            <a:r>
-              <a:rPr lang="en-US" sz="1600" dirty="0">
-                <a:solidFill>
-                  <a:srgbClr val="2D2D2D"/>
-                </a:solidFill>
-                <a:latin typeface="Montserrat" pitchFamily="34" charset="0"/>
-                <a:ea typeface="Montserrat" pitchFamily="34" charset="-122"/>
-                <a:cs typeface="Montserrat" pitchFamily="34" charset="-120"/>
-              </a:rPr>
-              <a:t>Weekly check-in with 20 short statements
+          <a:bodyPr wrap="square" rtlCol="0" anchor="t"/>
+          <a:lstStyle/>
+          <a:p>
+            <a:pPr indent="0" marL="0">
+              <a:lnSpc>
+                <a:spcPct val="135000"/>
+              </a:lnSpc>
+              <a:buNone/>
+            </a:pPr>
+            <a:r>
+              <a:rPr lang="en-US" sz="1300" dirty="0">
+                <a:solidFill>
+                  <a:srgbClr val="333333"/>
+                </a:solidFill>
+                <a:latin typeface="Aptos" pitchFamily="34" charset="0"/>
+                <a:ea typeface="Aptos" pitchFamily="34" charset="-122"/>
+                <a:cs typeface="Aptos" pitchFamily="34" charset="-120"/>
+              </a:rPr>
+              <a:t>A weekly check-in with 20 short statements.
 </a:t>
             </a:r>
-            <a:endParaRPr lang="en-US" sz="1600" dirty="0"/>
-          </a:p>
-          <a:p>
-            <a:pPr indent="0" marL="0">
-              <a:buNone/>
-            </a:pPr>
-            <a:r>
-              <a:rPr lang="en-US" sz="1400" dirty="0">
-                <a:solidFill>
-                  <a:srgbClr val="2D2D2D"/>
-                </a:solidFill>
-                <a:latin typeface="Montserrat" pitchFamily="34" charset="0"/>
-                <a:ea typeface="Montserrat" pitchFamily="34" charset="-122"/>
-                <a:cs typeface="Montserrat" pitchFamily="34" charset="-120"/>
-              </a:rPr>
-              <a:t>Simple response scale. Framed as a reflection tool, not a test or clinical assessment.
+            <a:pPr indent="0" marL="0">
+              <a:lnSpc>
+                <a:spcPct val="135000"/>
+              </a:lnSpc>
+              <a:buNone/>
+            </a:pPr>
+            <a:r>
+              <a:rPr lang="en-US" sz="1300" dirty="0">
+                <a:solidFill>
+                  <a:srgbClr val="333333"/>
+                </a:solidFill>
+                <a:latin typeface="Aptos" pitchFamily="34" charset="0"/>
+                <a:ea typeface="Aptos" pitchFamily="34" charset="-122"/>
+                <a:cs typeface="Aptos" pitchFamily="34" charset="-120"/>
+              </a:rPr>
+              <a:t>Responses use a simple scale from never to always.
 </a:t>
             </a:r>
-            <a:endParaRPr lang="en-US" sz="1600" dirty="0"/>
-          </a:p>
-          <a:p>
-            <a:pPr indent="0" marL="0">
-              <a:buNone/>
-            </a:pPr>
-            <a:r>
-              <a:rPr lang="en-US" sz="1600" dirty="0">
-                <a:solidFill>
-                  <a:srgbClr val="2D2D2D"/>
-                </a:solidFill>
-                <a:latin typeface="Montserrat" pitchFamily="34" charset="0"/>
-                <a:ea typeface="Montserrat" pitchFamily="34" charset="-122"/>
-                <a:cs typeface="Montserrat" pitchFamily="34" charset="-120"/>
-              </a:rPr>
-              <a:t>Four domains
+            <a:pPr indent="0" marL="0">
+              <a:lnSpc>
+                <a:spcPct val="135000"/>
+              </a:lnSpc>
+              <a:buNone/>
+            </a:pPr>
+            <a:r>
+              <a:rPr lang="en-US" sz="1300" dirty="0">
+                <a:solidFill>
+                  <a:srgbClr val="333333"/>
+                </a:solidFill>
+                <a:latin typeface="Aptos" pitchFamily="34" charset="0"/>
+                <a:ea typeface="Aptos" pitchFamily="34" charset="-122"/>
+                <a:cs typeface="Aptos" pitchFamily="34" charset="-120"/>
+              </a:rPr>
+              <a:t>It is a reflection tool, not a test or clinical assessment.
 </a:t>
             </a:r>
-            <a:endParaRPr lang="en-US" sz="1600" dirty="0"/>
-          </a:p>
-          <a:p>
-            <a:pPr indent="0" marL="0">
-              <a:buNone/>
-            </a:pPr>
-            <a:r>
-              <a:rPr lang="en-US" sz="1400" dirty="0">
-                <a:solidFill>
-                  <a:srgbClr val="2D2D2D"/>
-                </a:solidFill>
-                <a:latin typeface="Montserrat" pitchFamily="34" charset="0"/>
-                <a:ea typeface="Montserrat" pitchFamily="34" charset="-122"/>
-                <a:cs typeface="Montserrat" pitchFamily="34" charset="-120"/>
-              </a:rPr>
-              <a:t>Self Awareness: Understanding patterns and protecting energy
+            <a:pPr indent="0" marL="0">
+              <a:lnSpc>
+                <a:spcPct val="135000"/>
+              </a:lnSpc>
+              <a:buNone/>
+            </a:pPr>
+            <a:r>
+              <a:rPr lang="en-US" sz="1300" b="1" dirty="0">
+                <a:solidFill>
+                  <a:srgbClr val="333333"/>
+                </a:solidFill>
+                <a:latin typeface="Aptos" pitchFamily="34" charset="0"/>
+                <a:ea typeface="Aptos" pitchFamily="34" charset="-122"/>
+                <a:cs typeface="Aptos" pitchFamily="34" charset="-120"/>
+              </a:rPr>
+              <a:t>The four domains are:
 </a:t>
             </a:r>
-            <a:endParaRPr lang="en-US" sz="1600" dirty="0"/>
-          </a:p>
-          <a:p>
-            <a:pPr indent="0" marL="0">
-              <a:buNone/>
-            </a:pPr>
-            <a:r>
-              <a:rPr lang="en-US" sz="1400" dirty="0">
-                <a:solidFill>
-                  <a:srgbClr val="2D2D2D"/>
-                </a:solidFill>
-                <a:latin typeface="Montserrat" pitchFamily="34" charset="0"/>
-                <a:ea typeface="Montserrat" pitchFamily="34" charset="-122"/>
-                <a:cs typeface="Montserrat" pitchFamily="34" charset="-120"/>
-              </a:rPr>
-              <a:t>Aim: Moving toward what matters and staying on track
+            <a:pPr indent="0" marL="0">
+              <a:lnSpc>
+                <a:spcPct val="135000"/>
+              </a:lnSpc>
+              <a:buNone/>
+            </a:pPr>
+            <a:r>
+              <a:rPr lang="en-US" sz="1300" dirty="0">
+                <a:solidFill>
+                  <a:srgbClr val="333333"/>
+                </a:solidFill>
+                <a:latin typeface="Aptos" pitchFamily="34" charset="0"/>
+                <a:ea typeface="Aptos" pitchFamily="34" charset="-122"/>
+                <a:cs typeface="Aptos" pitchFamily="34" charset="-120"/>
+              </a:rPr>
+              <a:t>Self Awareness
 </a:t>
             </a:r>
-            <a:endParaRPr lang="en-US" sz="1600" dirty="0"/>
-          </a:p>
-          <a:p>
-            <a:pPr indent="0" marL="0">
-              <a:buNone/>
-            </a:pPr>
-            <a:r>
-              <a:rPr lang="en-US" sz="1400" dirty="0">
-                <a:solidFill>
-                  <a:srgbClr val="2D2D2D"/>
-                </a:solidFill>
-                <a:latin typeface="Montserrat" pitchFamily="34" charset="0"/>
-                <a:ea typeface="Montserrat" pitchFamily="34" charset="-122"/>
-                <a:cs typeface="Montserrat" pitchFamily="34" charset="-120"/>
-              </a:rPr>
-              <a:t>Foundation: Routines and structures that keep life steady
+            <a:pPr indent="0" marL="0">
+              <a:lnSpc>
+                <a:spcPct val="135000"/>
+              </a:lnSpc>
+              <a:buNone/>
+            </a:pPr>
+            <a:r>
+              <a:rPr lang="en-US" sz="1300" dirty="0">
+                <a:solidFill>
+                  <a:srgbClr val="333333"/>
+                </a:solidFill>
+                <a:latin typeface="Aptos" pitchFamily="34" charset="0"/>
+                <a:ea typeface="Aptos" pitchFamily="34" charset="-122"/>
+                <a:cs typeface="Aptos" pitchFamily="34" charset="-120"/>
+              </a:rPr>
+              <a:t>Action
 </a:t>
             </a:r>
-            <a:endParaRPr lang="en-US" sz="1600" dirty="0"/>
-          </a:p>
-          <a:p>
-            <a:pPr indent="0" marL="0">
-              <a:buNone/>
-            </a:pPr>
-            <a:r>
-              <a:rPr lang="en-US" sz="1400" dirty="0">
-                <a:solidFill>
-                  <a:srgbClr val="2D2D2D"/>
-                </a:solidFill>
-                <a:latin typeface="Montserrat" pitchFamily="34" charset="0"/>
-                <a:ea typeface="Montserrat" pitchFamily="34" charset="-122"/>
-                <a:cs typeface="Montserrat" pitchFamily="34" charset="-120"/>
-              </a:rPr>
-              <a:t>Emotion: Recognising, pausing, and responding rather than reacting
+            <a:pPr indent="0" marL="0">
+              <a:lnSpc>
+                <a:spcPct val="135000"/>
+              </a:lnSpc>
+              <a:buNone/>
+            </a:pPr>
+            <a:r>
+              <a:rPr lang="en-US" sz="1300" dirty="0">
+                <a:solidFill>
+                  <a:srgbClr val="333333"/>
+                </a:solidFill>
+                <a:latin typeface="Aptos" pitchFamily="34" charset="0"/>
+                <a:ea typeface="Aptos" pitchFamily="34" charset="-122"/>
+                <a:cs typeface="Aptos" pitchFamily="34" charset="-120"/>
+              </a:rPr>
+              <a:t>Foundation
 </a:t>
             </a:r>
-            <a:endParaRPr lang="en-US" sz="1600" dirty="0"/>
-          </a:p>
-          <a:p>
-            <a:pPr indent="0" marL="0">
-              <a:buNone/>
-            </a:pPr>
-            <a:r>
-              <a:rPr lang="en-US" sz="1600" dirty="0">
-                <a:solidFill>
-                  <a:srgbClr val="2D2D2D"/>
-                </a:solidFill>
-                <a:latin typeface="Montserrat" pitchFamily="34" charset="0"/>
-                <a:ea typeface="Montserrat" pitchFamily="34" charset="-122"/>
-                <a:cs typeface="Montserrat" pitchFamily="34" charset="-120"/>
-              </a:rPr>
-              <a:t>Stage progression
+            <a:pPr indent="0" marL="0">
+              <a:lnSpc>
+                <a:spcPct val="135000"/>
+              </a:lnSpc>
+              <a:buNone/>
+            </a:pPr>
+            <a:r>
+              <a:rPr lang="en-US" sz="1300" dirty="0">
+                <a:solidFill>
+                  <a:srgbClr val="333333"/>
+                </a:solidFill>
+                <a:latin typeface="Aptos" pitchFamily="34" charset="0"/>
+                <a:ea typeface="Aptos" pitchFamily="34" charset="-122"/>
+                <a:cs typeface="Aptos" pitchFamily="34" charset="-120"/>
+              </a:rPr>
+              <a:t>Emotion
 </a:t>
             </a:r>
-            <a:endParaRPr lang="en-US" sz="1600" dirty="0"/>
-          </a:p>
-          <a:p>
-            <a:pPr indent="0" marL="0">
-              <a:buNone/>
-            </a:pPr>
-            <a:r>
-              <a:rPr lang="en-US" sz="1400" dirty="0">
-                <a:solidFill>
-                  <a:srgbClr val="2D2D2D"/>
-                </a:solidFill>
-                <a:latin typeface="Montserrat" pitchFamily="34" charset="0"/>
-                <a:ea typeface="Montserrat" pitchFamily="34" charset="-122"/>
-                <a:cs typeface="Montserrat" pitchFamily="34" charset="-120"/>
-              </a:rPr>
-              <a:t>Overwhelmed &gt; Stretched &gt; Stabilising &gt; In Control &gt; In Flow</a:t>
-            </a:r>
-            <a:endParaRPr lang="en-US" sz="1600" dirty="0"/>
-          </a:p>
-          <a:p>
-            <a:pPr indent="0" marL="0">
-              <a:buNone/>
-            </a:pPr>
-            <a:r>
-              <a:rPr lang="en-US" sz="1400" dirty="0">
-                <a:solidFill>
-                  <a:srgbClr val="2D2D2D"/>
-                </a:solidFill>
-                <a:latin typeface="Montserrat" pitchFamily="34" charset="0"/>
-                <a:ea typeface="Montserrat" pitchFamily="34" charset="-122"/>
-                <a:cs typeface="Montserrat" pitchFamily="34" charset="-120"/>
-              </a:rPr>
-              <a:t>Noticing movement over time, not fixing everything at once.</a:t>
-            </a:r>
-            <a:endParaRPr lang="en-US" sz="1600" dirty="0"/>
-          </a:p>
-        </p:txBody>
-      </p:sp>
-      <p:sp>
-        <p:nvSpPr>
-          <p:cNvPr id="4" name="Text 2"/>
-          <p:cNvSpPr/>
-          <p:nvPr/>
-        </p:nvSpPr>
-        <p:spPr>
-          <a:xfrm>
-            <a:off x="457200" y="4754880"/>
-            <a:ext cx="8229600" cy="274320"/>
-          </a:xfrm>
-          <a:prstGeom prst="rect">
-            <a:avLst/>
-          </a:prstGeom>
-          <a:noFill/>
-          <a:ln/>
-        </p:spPr>
-        <p:txBody>
-          <a:bodyPr wrap="square" rtlCol="0" anchor="ctr"/>
-          <a:lstStyle/>
-          <a:p>
-            <a:pPr algn="ctr" indent="0" marL="0">
-              <a:buNone/>
-            </a:pPr>
-            <a:r>
-              <a:rPr lang="en-US" sz="900" dirty="0">
-                <a:solidFill>
-                  <a:srgbClr val="2D2D2D"/>
-                </a:solidFill>
-                <a:latin typeface="Montserrat" pitchFamily="34" charset="0"/>
-                <a:ea typeface="Montserrat" pitchFamily="34" charset="-122"/>
-                <a:cs typeface="Montserrat" pitchFamily="34" charset="-120"/>
-              </a:rPr>
-              <a:t>Strengths-Based Coaching and Counselling | www.coach4u.com.au | cath@coach4u.com.au | 0402 313 337</a:t>
-            </a:r>
-            <a:endParaRPr lang="en-US" sz="900" dirty="0"/>
+            <a:pPr indent="0" marL="0">
+              <a:lnSpc>
+                <a:spcPct val="135000"/>
+              </a:lnSpc>
+              <a:buNone/>
+            </a:pPr>
+            <a:r>
+              <a:rPr lang="en-US" sz="1300" dirty="0">
+                <a:solidFill>
+                  <a:srgbClr val="333333"/>
+                </a:solidFill>
+                <a:latin typeface="Aptos" pitchFamily="34" charset="0"/>
+                <a:ea typeface="Aptos" pitchFamily="34" charset="-122"/>
+                <a:cs typeface="Aptos" pitchFamily="34" charset="-120"/>
+              </a:rPr>
+              <a:t>It also shows capacity patterns over time,</a:t>
+            </a:r>
+            <a:endParaRPr lang="en-US" sz="1300" dirty="0"/>
+          </a:p>
+          <a:p>
+            <a:pPr indent="0" marL="0">
+              <a:lnSpc>
+                <a:spcPct val="135000"/>
+              </a:lnSpc>
+              <a:buNone/>
+            </a:pPr>
+            <a:r>
+              <a:rPr lang="en-US" sz="1300" dirty="0">
+                <a:solidFill>
+                  <a:srgbClr val="333333"/>
+                </a:solidFill>
+                <a:latin typeface="Aptos" pitchFamily="34" charset="0"/>
+                <a:ea typeface="Aptos" pitchFamily="34" charset="-122"/>
+                <a:cs typeface="Aptos" pitchFamily="34" charset="-120"/>
+              </a:rPr>
+              <a:t>moving from chaos toward calm.</a:t>
+            </a:r>
+            <a:endParaRPr lang="en-US" sz="1300" dirty="0"/>
           </a:p>
         </p:txBody>
       </p:sp>

</xml_diff>

<commit_message>
Rebuild MHPN presentation with precise text positioning
Each line placed individually with exact Y coordinates.
No text arrays. Clean layout with consistent margins,
spacing, and prompt boxes. Follows brand spec exactly.

https://claude.ai/code/session_01JPgbNt7mh3RQgUUfUTZPLe
</commit_message>
<xml_diff>
--- a/docs/assets/files/presentations/Capacity_Overwhelm_MHPN_Session.pptx
+++ b/docs/assets/files/presentations/Capacity_Overwhelm_MHPN_Session.pptx
@@ -1684,132 +1684,8 @@
         </p:nvSpPr>
         <p:spPr>
           <a:xfrm>
-            <a:off x="548640" y="1280160"/>
-            <a:ext cx="8046720" cy="1280160"/>
-          </a:xfrm>
-          <a:prstGeom prst="rect">
-            <a:avLst/>
-          </a:prstGeom>
-          <a:noFill/>
-          <a:ln/>
-        </p:spPr>
-        <p:txBody>
-          <a:bodyPr wrap="square" rtlCol="0" anchor="ctr"/>
-          <a:lstStyle/>
-          <a:p>
-            <a:pPr algn="ctr" indent="0" marL="0">
-              <a:lnSpc>
-                <a:spcPct val="115000"/>
-              </a:lnSpc>
-              <a:buNone/>
-            </a:pPr>
-            <a:r>
-              <a:rPr lang="en-US" sz="3200" b="1" dirty="0">
-                <a:solidFill>
-                  <a:srgbClr val="003366"/>
-                </a:solidFill>
-                <a:latin typeface="Aptos" pitchFamily="34" charset="0"/>
-                <a:ea typeface="Aptos" pitchFamily="34" charset="-122"/>
-                <a:cs typeface="Aptos" pitchFamily="34" charset="-120"/>
-              </a:rPr>
-              <a:t>Understanding Capacity and</a:t>
-            </a:r>
-            <a:endParaRPr lang="en-US" sz="3200" dirty="0"/>
-          </a:p>
-          <a:p>
-            <a:pPr algn="ctr" indent="0" marL="0">
-              <a:lnSpc>
-                <a:spcPct val="115000"/>
-              </a:lnSpc>
-              <a:buNone/>
-            </a:pPr>
-            <a:r>
-              <a:rPr lang="en-US" sz="3200" b="1" dirty="0">
-                <a:solidFill>
-                  <a:srgbClr val="003366"/>
-                </a:solidFill>
-                <a:latin typeface="Aptos" pitchFamily="34" charset="0"/>
-                <a:ea typeface="Aptos" pitchFamily="34" charset="-122"/>
-                <a:cs typeface="Aptos" pitchFamily="34" charset="-120"/>
-              </a:rPr>
-              <a:t>Overwhelm in Neurodivergence</a:t>
-            </a:r>
-            <a:endParaRPr lang="en-US" sz="3200" dirty="0"/>
-          </a:p>
-        </p:txBody>
-      </p:sp>
-      <p:sp>
-        <p:nvSpPr>
-          <p:cNvPr id="3" name="Text 1"/>
-          <p:cNvSpPr/>
-          <p:nvPr/>
-        </p:nvSpPr>
-        <p:spPr>
-          <a:xfrm>
-            <a:off x="548640" y="2743200"/>
-            <a:ext cx="8046720" cy="731520"/>
-          </a:xfrm>
-          <a:prstGeom prst="rect">
-            <a:avLst/>
-          </a:prstGeom>
-          <a:noFill/>
-          <a:ln/>
-        </p:spPr>
-        <p:txBody>
-          <a:bodyPr wrap="square" rtlCol="0" anchor="ctr"/>
-          <a:lstStyle/>
-          <a:p>
-            <a:pPr algn="ctr" indent="0" marL="0">
-              <a:lnSpc>
-                <a:spcPct val="130000"/>
-              </a:lnSpc>
-              <a:buNone/>
-            </a:pPr>
-            <a:r>
-              <a:rPr lang="en-US" sz="1600" dirty="0">
-                <a:solidFill>
-                  <a:srgbClr val="333333"/>
-                </a:solidFill>
-                <a:latin typeface="Aptos" pitchFamily="34" charset="0"/>
-                <a:ea typeface="Aptos" pitchFamily="34" charset="-122"/>
-                <a:cs typeface="Aptos" pitchFamily="34" charset="-120"/>
-              </a:rPr>
-              <a:t>NSW Neurodiversity-Affirming Network</a:t>
-            </a:r>
-            <a:endParaRPr lang="en-US" sz="1600" dirty="0"/>
-          </a:p>
-          <a:p>
-            <a:pPr algn="ctr" indent="0" marL="0">
-              <a:lnSpc>
-                <a:spcPct val="130000"/>
-              </a:lnSpc>
-              <a:buNone/>
-            </a:pPr>
-            <a:r>
-              <a:rPr lang="en-US" sz="1600" dirty="0">
-                <a:solidFill>
-                  <a:srgbClr val="333333"/>
-                </a:solidFill>
-                <a:latin typeface="Aptos" pitchFamily="34" charset="0"/>
-                <a:ea typeface="Aptos" pitchFamily="34" charset="-122"/>
-                <a:cs typeface="Aptos" pitchFamily="34" charset="-120"/>
-              </a:rPr>
-              <a:t>Peer learning session</a:t>
-            </a:r>
-            <a:endParaRPr lang="en-US" sz="1600" dirty="0"/>
-          </a:p>
-        </p:txBody>
-      </p:sp>
-      <p:sp>
-        <p:nvSpPr>
-          <p:cNvPr id="4" name="Text 2"/>
-          <p:cNvSpPr/>
-          <p:nvPr/>
-        </p:nvSpPr>
-        <p:spPr>
-          <a:xfrm>
-            <a:off x="548640" y="4434840"/>
-            <a:ext cx="8046720" cy="502920"/>
+            <a:off x="914400" y="1371600"/>
+            <a:ext cx="7315200" cy="1005840"/>
           </a:xfrm>
           <a:prstGeom prst="rect">
             <a:avLst/>
@@ -1828,17 +1704,17 @@
               <a:buNone/>
             </a:pPr>
             <a:r>
-              <a:rPr lang="en-US" sz="900" dirty="0">
-                <a:solidFill>
-                  <a:srgbClr val="999999"/>
-                </a:solidFill>
-                <a:latin typeface="Aptos" pitchFamily="34" charset="0"/>
-                <a:ea typeface="Aptos" pitchFamily="34" charset="-122"/>
-                <a:cs typeface="Aptos" pitchFamily="34" charset="-120"/>
-              </a:rPr>
-              <a:t>Cath Baker</a:t>
-            </a:r>
-            <a:endParaRPr lang="en-US" sz="900" dirty="0"/>
+              <a:rPr lang="en-US" sz="2800" b="1" dirty="0">
+                <a:solidFill>
+                  <a:srgbClr val="003366"/>
+                </a:solidFill>
+                <a:latin typeface="Aptos" pitchFamily="34" charset="0"/>
+                <a:ea typeface="Aptos" pitchFamily="34" charset="-122"/>
+                <a:cs typeface="Aptos" pitchFamily="34" charset="-120"/>
+              </a:rPr>
+              <a:t>Understanding Capacity and</a:t>
+            </a:r>
+            <a:endParaRPr lang="en-US" sz="2800" dirty="0"/>
           </a:p>
           <a:p>
             <a:pPr algn="ctr" indent="0" marL="0">
@@ -1848,7 +1724,124 @@
               <a:buNone/>
             </a:pPr>
             <a:r>
-              <a:rPr lang="en-US" sz="900" dirty="0">
+              <a:rPr lang="en-US" sz="2800" b="1" dirty="0">
+                <a:solidFill>
+                  <a:srgbClr val="003366"/>
+                </a:solidFill>
+                <a:latin typeface="Aptos" pitchFamily="34" charset="0"/>
+                <a:ea typeface="Aptos" pitchFamily="34" charset="-122"/>
+                <a:cs typeface="Aptos" pitchFamily="34" charset="-120"/>
+              </a:rPr>
+              <a:t>Overwhelm in Neurodivergence</a:t>
+            </a:r>
+            <a:endParaRPr lang="en-US" sz="2800" dirty="0"/>
+          </a:p>
+        </p:txBody>
+      </p:sp>
+      <p:sp>
+        <p:nvSpPr>
+          <p:cNvPr id="3" name="Text 1"/>
+          <p:cNvSpPr/>
+          <p:nvPr/>
+        </p:nvSpPr>
+        <p:spPr>
+          <a:xfrm>
+            <a:off x="914400" y="2606040"/>
+            <a:ext cx="7315200" cy="320040"/>
+          </a:xfrm>
+          <a:prstGeom prst="rect">
+            <a:avLst/>
+          </a:prstGeom>
+          <a:noFill/>
+          <a:ln/>
+        </p:spPr>
+        <p:txBody>
+          <a:bodyPr wrap="square" rtlCol="0" anchor="ctr"/>
+          <a:lstStyle/>
+          <a:p>
+            <a:pPr algn="ctr" indent="0" marL="0">
+              <a:buNone/>
+            </a:pPr>
+            <a:r>
+              <a:rPr lang="en-US" sz="1400" dirty="0">
+                <a:solidFill>
+                  <a:srgbClr val="333333"/>
+                </a:solidFill>
+                <a:latin typeface="Aptos" pitchFamily="34" charset="0"/>
+                <a:ea typeface="Aptos" pitchFamily="34" charset="-122"/>
+                <a:cs typeface="Aptos" pitchFamily="34" charset="-120"/>
+              </a:rPr>
+              <a:t>NSW Neurodiversity-Affirming Network</a:t>
+            </a:r>
+            <a:endParaRPr lang="en-US" sz="1400" dirty="0"/>
+          </a:p>
+        </p:txBody>
+      </p:sp>
+      <p:sp>
+        <p:nvSpPr>
+          <p:cNvPr id="4" name="Text 2"/>
+          <p:cNvSpPr/>
+          <p:nvPr/>
+        </p:nvSpPr>
+        <p:spPr>
+          <a:xfrm>
+            <a:off x="914400" y="2926080"/>
+            <a:ext cx="7315200" cy="320040"/>
+          </a:xfrm>
+          <a:prstGeom prst="rect">
+            <a:avLst/>
+          </a:prstGeom>
+          <a:noFill/>
+          <a:ln/>
+        </p:spPr>
+        <p:txBody>
+          <a:bodyPr wrap="square" rtlCol="0" anchor="ctr"/>
+          <a:lstStyle/>
+          <a:p>
+            <a:pPr algn="ctr" indent="0" marL="0">
+              <a:buNone/>
+            </a:pPr>
+            <a:r>
+              <a:rPr lang="en-US" sz="1400" dirty="0">
+                <a:solidFill>
+                  <a:srgbClr val="333333"/>
+                </a:solidFill>
+                <a:latin typeface="Aptos" pitchFamily="34" charset="0"/>
+                <a:ea typeface="Aptos" pitchFamily="34" charset="-122"/>
+                <a:cs typeface="Aptos" pitchFamily="34" charset="-120"/>
+              </a:rPr>
+              <a:t>Peer learning session</a:t>
+            </a:r>
+            <a:endParaRPr lang="en-US" sz="1400" dirty="0"/>
+          </a:p>
+        </p:txBody>
+      </p:sp>
+      <p:sp>
+        <p:nvSpPr>
+          <p:cNvPr id="5" name="Text 3"/>
+          <p:cNvSpPr/>
+          <p:nvPr/>
+        </p:nvSpPr>
+        <p:spPr>
+          <a:xfrm>
+            <a:off x="914400" y="4297680"/>
+            <a:ext cx="7315200" cy="201168"/>
+          </a:xfrm>
+          <a:prstGeom prst="rect">
+            <a:avLst/>
+          </a:prstGeom>
+          <a:noFill/>
+          <a:ln/>
+        </p:spPr>
+        <p:txBody>
+          <a:bodyPr wrap="square" rtlCol="0" anchor="t"/>
+          <a:lstStyle/>
+          <a:p>
+            <a:pPr algn="ctr" indent="0" marL="0">
+              <a:buNone/>
+            </a:pPr>
+            <a:r>
+              <a:rPr lang="en-US" sz="850" dirty="0">
                 <a:solidFill>
                   <a:srgbClr val="999999"/>
                 </a:solidFill>
@@ -1856,9 +1849,48 @@
                 <a:ea typeface="Aptos" pitchFamily="34" charset="-122"/>
                 <a:cs typeface="Aptos" pitchFamily="34" charset="-120"/>
               </a:rPr>
+              <a:t>Cath Baker</a:t>
+            </a:r>
+            <a:endParaRPr lang="en-US" sz="850" dirty="0"/>
+          </a:p>
+        </p:txBody>
+      </p:sp>
+      <p:sp>
+        <p:nvSpPr>
+          <p:cNvPr id="6" name="Text 4"/>
+          <p:cNvSpPr/>
+          <p:nvPr/>
+        </p:nvSpPr>
+        <p:spPr>
+          <a:xfrm>
+            <a:off x="914400" y="4480560"/>
+            <a:ext cx="7315200" cy="201168"/>
+          </a:xfrm>
+          <a:prstGeom prst="rect">
+            <a:avLst/>
+          </a:prstGeom>
+          <a:noFill/>
+          <a:ln/>
+        </p:spPr>
+        <p:txBody>
+          <a:bodyPr wrap="square" rtlCol="0" anchor="t"/>
+          <a:lstStyle/>
+          <a:p>
+            <a:pPr algn="ctr" indent="0" marL="0">
+              <a:buNone/>
+            </a:pPr>
+            <a:r>
+              <a:rPr lang="en-US" sz="850" dirty="0">
+                <a:solidFill>
+                  <a:srgbClr val="999999"/>
+                </a:solidFill>
+                <a:latin typeface="Aptos" pitchFamily="34" charset="0"/>
+                <a:ea typeface="Aptos" pitchFamily="34" charset="-122"/>
+                <a:cs typeface="Aptos" pitchFamily="34" charset="-120"/>
+              </a:rPr>
               <a:t>Coach4U – Strengths-Based Coaching and Counselling</a:t>
             </a:r>
-            <a:endParaRPr lang="en-US" sz="900" dirty="0"/>
+            <a:endParaRPr lang="en-US" sz="850" dirty="0"/>
           </a:p>
         </p:txBody>
       </p:sp>
@@ -1902,24 +1934,24 @@
         </p:nvSpPr>
         <p:spPr>
           <a:xfrm>
-            <a:off x="548640" y="365760"/>
-            <a:ext cx="8046720" cy="457200"/>
-          </a:xfrm>
-          <a:prstGeom prst="rect">
-            <a:avLst/>
-          </a:prstGeom>
-          <a:noFill/>
-          <a:ln/>
-        </p:spPr>
-        <p:txBody>
-          <a:bodyPr wrap="square" rtlCol="0" anchor="ctr"/>
-          <a:lstStyle/>
-          <a:p>
-            <a:pPr indent="0" marL="0">
-              <a:buNone/>
-            </a:pPr>
-            <a:r>
-              <a:rPr lang="en-US" sz="2400" b="1" dirty="0">
+            <a:off x="914400" y="457200"/>
+            <a:ext cx="7315200" cy="411480"/>
+          </a:xfrm>
+          <a:prstGeom prst="rect">
+            <a:avLst/>
+          </a:prstGeom>
+          <a:noFill/>
+          <a:ln/>
+        </p:spPr>
+        <p:txBody>
+          <a:bodyPr wrap="square" rtlCol="0" anchor="t"/>
+          <a:lstStyle/>
+          <a:p>
+            <a:pPr indent="0" marL="0">
+              <a:buNone/>
+            </a:pPr>
+            <a:r>
+              <a:rPr lang="en-US" sz="2200" b="1" dirty="0">
                 <a:solidFill>
                   <a:srgbClr val="003366"/>
                 </a:solidFill>
@@ -1929,7 +1961,7 @@
               </a:rPr>
               <a:t>Closing reflections</a:t>
             </a:r>
-            <a:endParaRPr lang="en-US" sz="2400" dirty="0"/>
+            <a:endParaRPr lang="en-US" sz="2200" dirty="0"/>
           </a:p>
         </p:txBody>
       </p:sp>
@@ -1941,117 +1973,219 @@
         </p:nvSpPr>
         <p:spPr>
           <a:xfrm>
-            <a:off x="548640" y="1005840"/>
-            <a:ext cx="8046720" cy="2560320"/>
-          </a:xfrm>
-          <a:prstGeom prst="rect">
-            <a:avLst/>
-          </a:prstGeom>
-          <a:noFill/>
-          <a:ln/>
-        </p:spPr>
-        <p:txBody>
-          <a:bodyPr wrap="square" rtlCol="0" anchor="t"/>
-          <a:lstStyle/>
-          <a:p>
-            <a:pPr indent="0" marL="0">
-              <a:lnSpc>
-                <a:spcPct val="140000"/>
-              </a:lnSpc>
-              <a:buNone/>
-            </a:pPr>
-            <a:r>
-              <a:rPr lang="en-US" sz="1300" b="1" dirty="0">
-                <a:solidFill>
-                  <a:srgbClr val="333333"/>
-                </a:solidFill>
-                <a:latin typeface="Aptos" pitchFamily="34" charset="0"/>
-                <a:ea typeface="Aptos" pitchFamily="34" charset="-122"/>
-                <a:cs typeface="Aptos" pitchFamily="34" charset="-120"/>
-              </a:rPr>
-              <a:t>One insight you are taking into practice this week.
-</a:t>
-            </a:r>
-            <a:pPr indent="0" marL="0">
-              <a:lnSpc>
-                <a:spcPct val="140000"/>
-              </a:lnSpc>
-              <a:buNone/>
-            </a:pPr>
-            <a:r>
-              <a:rPr lang="en-US" sz="1300" b="1" dirty="0">
-                <a:solidFill>
-                  <a:srgbClr val="333333"/>
-                </a:solidFill>
-                <a:latin typeface="Aptos" pitchFamily="34" charset="0"/>
-                <a:ea typeface="Aptos" pitchFamily="34" charset="-122"/>
-                <a:cs typeface="Aptos" pitchFamily="34" charset="-120"/>
-              </a:rPr>
-              <a:t>Key themes:
-</a:t>
-            </a:r>
-            <a:pPr indent="0" marL="0">
-              <a:lnSpc>
-                <a:spcPct val="140000"/>
-              </a:lnSpc>
-              <a:buNone/>
-            </a:pPr>
-            <a:r>
-              <a:rPr lang="en-US" sz="1300" dirty="0">
-                <a:solidFill>
-                  <a:srgbClr val="333333"/>
-                </a:solidFill>
-                <a:latin typeface="Aptos" pitchFamily="34" charset="0"/>
-                <a:ea typeface="Aptos" pitchFamily="34" charset="-122"/>
-                <a:cs typeface="Aptos" pitchFamily="34" charset="-120"/>
-              </a:rPr>
-              <a:t>Recognising when someone has moved beyond capacity.
-</a:t>
-            </a:r>
-            <a:pPr indent="0" marL="0">
-              <a:lnSpc>
-                <a:spcPct val="140000"/>
-              </a:lnSpc>
-              <a:buNone/>
-            </a:pPr>
-            <a:r>
-              <a:rPr lang="en-US" sz="1300" dirty="0">
-                <a:solidFill>
-                  <a:srgbClr val="333333"/>
-                </a:solidFill>
-                <a:latin typeface="Aptos" pitchFamily="34" charset="0"/>
-                <a:ea typeface="Aptos" pitchFamily="34" charset="-122"/>
-                <a:cs typeface="Aptos" pitchFamily="34" charset="-120"/>
-              </a:rPr>
-              <a:t>Responding in ways that support regulation and safety.
-</a:t>
-            </a:r>
-            <a:pPr indent="0" marL="0">
-              <a:lnSpc>
-                <a:spcPct val="140000"/>
-              </a:lnSpc>
-              <a:buNone/>
-            </a:pPr>
-            <a:r>
-              <a:rPr lang="en-US" sz="1300" dirty="0">
-                <a:solidFill>
-                  <a:srgbClr val="333333"/>
-                </a:solidFill>
-                <a:latin typeface="Aptos" pitchFamily="34" charset="0"/>
-                <a:ea typeface="Aptos" pitchFamily="34" charset="-122"/>
-                <a:cs typeface="Aptos" pitchFamily="34" charset="-120"/>
-              </a:rPr>
-              <a:t>Anchoring without restriction.
-</a:t>
-            </a:r>
-            <a:pPr indent="0" marL="0">
-              <a:lnSpc>
-                <a:spcPct val="140000"/>
-              </a:lnSpc>
-              <a:buNone/>
-            </a:pPr>
-            <a:r>
-              <a:rPr lang="en-US" sz="1300" dirty="0">
+            <a:off x="914400" y="1188720"/>
+            <a:ext cx="7315200" cy="292608"/>
+          </a:xfrm>
+          <a:prstGeom prst="rect">
+            <a:avLst/>
+          </a:prstGeom>
+          <a:noFill/>
+          <a:ln/>
+        </p:spPr>
+        <p:txBody>
+          <a:bodyPr wrap="square" rtlCol="0" anchor="t"/>
+          <a:lstStyle/>
+          <a:p>
+            <a:pPr indent="0" marL="0">
+              <a:buNone/>
+            </a:pPr>
+            <a:r>
+              <a:rPr lang="en-US" sz="1250" b="1" dirty="0">
+                <a:solidFill>
+                  <a:srgbClr val="333333"/>
+                </a:solidFill>
+                <a:latin typeface="Aptos" pitchFamily="34" charset="0"/>
+                <a:ea typeface="Aptos" pitchFamily="34" charset="-122"/>
+                <a:cs typeface="Aptos" pitchFamily="34" charset="-120"/>
+              </a:rPr>
+              <a:t>One insight you are taking into practice this week.</a:t>
+            </a:r>
+            <a:endParaRPr lang="en-US" sz="1250" dirty="0"/>
+          </a:p>
+        </p:txBody>
+      </p:sp>
+      <p:sp>
+        <p:nvSpPr>
+          <p:cNvPr id="4" name="Text 2"/>
+          <p:cNvSpPr/>
+          <p:nvPr/>
+        </p:nvSpPr>
+        <p:spPr>
+          <a:xfrm>
+            <a:off x="914400" y="1737360"/>
+            <a:ext cx="7315200" cy="292608"/>
+          </a:xfrm>
+          <a:prstGeom prst="rect">
+            <a:avLst/>
+          </a:prstGeom>
+          <a:noFill/>
+          <a:ln/>
+        </p:spPr>
+        <p:txBody>
+          <a:bodyPr wrap="square" rtlCol="0" anchor="t"/>
+          <a:lstStyle/>
+          <a:p>
+            <a:pPr indent="0" marL="0">
+              <a:buNone/>
+            </a:pPr>
+            <a:r>
+              <a:rPr lang="en-US" sz="1250" b="1" dirty="0">
+                <a:solidFill>
+                  <a:srgbClr val="333333"/>
+                </a:solidFill>
+                <a:latin typeface="Aptos" pitchFamily="34" charset="0"/>
+                <a:ea typeface="Aptos" pitchFamily="34" charset="-122"/>
+                <a:cs typeface="Aptos" pitchFamily="34" charset="-120"/>
+              </a:rPr>
+              <a:t>Key themes:</a:t>
+            </a:r>
+            <a:endParaRPr lang="en-US" sz="1250" dirty="0"/>
+          </a:p>
+        </p:txBody>
+      </p:sp>
+      <p:sp>
+        <p:nvSpPr>
+          <p:cNvPr id="5" name="Text 3"/>
+          <p:cNvSpPr/>
+          <p:nvPr/>
+        </p:nvSpPr>
+        <p:spPr>
+          <a:xfrm>
+            <a:off x="914400" y="2029968"/>
+            <a:ext cx="7315200" cy="292608"/>
+          </a:xfrm>
+          <a:prstGeom prst="rect">
+            <a:avLst/>
+          </a:prstGeom>
+          <a:noFill/>
+          <a:ln/>
+        </p:spPr>
+        <p:txBody>
+          <a:bodyPr wrap="square" rtlCol="0" anchor="t"/>
+          <a:lstStyle/>
+          <a:p>
+            <a:pPr indent="0" marL="0">
+              <a:buNone/>
+            </a:pPr>
+            <a:r>
+              <a:rPr lang="en-US" sz="1250" dirty="0">
+                <a:solidFill>
+                  <a:srgbClr val="333333"/>
+                </a:solidFill>
+                <a:latin typeface="Aptos" pitchFamily="34" charset="0"/>
+                <a:ea typeface="Aptos" pitchFamily="34" charset="-122"/>
+                <a:cs typeface="Aptos" pitchFamily="34" charset="-120"/>
+              </a:rPr>
+              <a:t>Recognising when someone has moved beyond capacity.</a:t>
+            </a:r>
+            <a:endParaRPr lang="en-US" sz="1250" dirty="0"/>
+          </a:p>
+        </p:txBody>
+      </p:sp>
+      <p:sp>
+        <p:nvSpPr>
+          <p:cNvPr id="6" name="Text 4"/>
+          <p:cNvSpPr/>
+          <p:nvPr/>
+        </p:nvSpPr>
+        <p:spPr>
+          <a:xfrm>
+            <a:off x="914400" y="2286000"/>
+            <a:ext cx="7315200" cy="292608"/>
+          </a:xfrm>
+          <a:prstGeom prst="rect">
+            <a:avLst/>
+          </a:prstGeom>
+          <a:noFill/>
+          <a:ln/>
+        </p:spPr>
+        <p:txBody>
+          <a:bodyPr wrap="square" rtlCol="0" anchor="t"/>
+          <a:lstStyle/>
+          <a:p>
+            <a:pPr indent="0" marL="0">
+              <a:buNone/>
+            </a:pPr>
+            <a:r>
+              <a:rPr lang="en-US" sz="1250" dirty="0">
+                <a:solidFill>
+                  <a:srgbClr val="333333"/>
+                </a:solidFill>
+                <a:latin typeface="Aptos" pitchFamily="34" charset="0"/>
+                <a:ea typeface="Aptos" pitchFamily="34" charset="-122"/>
+                <a:cs typeface="Aptos" pitchFamily="34" charset="-120"/>
+              </a:rPr>
+              <a:t>Responding in ways that support regulation and safety.</a:t>
+            </a:r>
+            <a:endParaRPr lang="en-US" sz="1250" dirty="0"/>
+          </a:p>
+        </p:txBody>
+      </p:sp>
+      <p:sp>
+        <p:nvSpPr>
+          <p:cNvPr id="7" name="Text 5"/>
+          <p:cNvSpPr/>
+          <p:nvPr/>
+        </p:nvSpPr>
+        <p:spPr>
+          <a:xfrm>
+            <a:off x="914400" y="2542032"/>
+            <a:ext cx="7315200" cy="292608"/>
+          </a:xfrm>
+          <a:prstGeom prst="rect">
+            <a:avLst/>
+          </a:prstGeom>
+          <a:noFill/>
+          <a:ln/>
+        </p:spPr>
+        <p:txBody>
+          <a:bodyPr wrap="square" rtlCol="0" anchor="t"/>
+          <a:lstStyle/>
+          <a:p>
+            <a:pPr indent="0" marL="0">
+              <a:buNone/>
+            </a:pPr>
+            <a:r>
+              <a:rPr lang="en-US" sz="1250" dirty="0">
+                <a:solidFill>
+                  <a:srgbClr val="333333"/>
+                </a:solidFill>
+                <a:latin typeface="Aptos" pitchFamily="34" charset="0"/>
+                <a:ea typeface="Aptos" pitchFamily="34" charset="-122"/>
+                <a:cs typeface="Aptos" pitchFamily="34" charset="-120"/>
+              </a:rPr>
+              <a:t>Anchoring without restriction.</a:t>
+            </a:r>
+            <a:endParaRPr lang="en-US" sz="1250" dirty="0"/>
+          </a:p>
+        </p:txBody>
+      </p:sp>
+      <p:sp>
+        <p:nvSpPr>
+          <p:cNvPr id="8" name="Text 6"/>
+          <p:cNvSpPr/>
+          <p:nvPr/>
+        </p:nvSpPr>
+        <p:spPr>
+          <a:xfrm>
+            <a:off x="914400" y="2798064"/>
+            <a:ext cx="7315200" cy="292608"/>
+          </a:xfrm>
+          <a:prstGeom prst="rect">
+            <a:avLst/>
+          </a:prstGeom>
+          <a:noFill/>
+          <a:ln/>
+        </p:spPr>
+        <p:txBody>
+          <a:bodyPr wrap="square" rtlCol="0" anchor="t"/>
+          <a:lstStyle/>
+          <a:p>
+            <a:pPr indent="0" marL="0">
+              <a:buNone/>
+            </a:pPr>
+            <a:r>
+              <a:rPr lang="en-US" sz="1250" dirty="0">
                 <a:solidFill>
                   <a:srgbClr val="333333"/>
                 </a:solidFill>
@@ -2061,39 +2195,36 @@
               </a:rPr>
               <a:t>Progress without perfection.</a:t>
             </a:r>
-            <a:endParaRPr lang="en-US" sz="1300" dirty="0"/>
-          </a:p>
-        </p:txBody>
-      </p:sp>
-      <p:sp>
-        <p:nvSpPr>
-          <p:cNvPr id="4" name="Text 2"/>
-          <p:cNvSpPr/>
-          <p:nvPr/>
-        </p:nvSpPr>
-        <p:spPr>
-          <a:xfrm>
-            <a:off x="548640" y="4434840"/>
-            <a:ext cx="8046720" cy="502920"/>
-          </a:xfrm>
-          <a:prstGeom prst="rect">
-            <a:avLst/>
-          </a:prstGeom>
-          <a:noFill/>
-          <a:ln/>
-        </p:spPr>
-        <p:txBody>
-          <a:bodyPr wrap="square" rtlCol="0" anchor="ctr"/>
+            <a:endParaRPr lang="en-US" sz="1250" dirty="0"/>
+          </a:p>
+        </p:txBody>
+      </p:sp>
+      <p:sp>
+        <p:nvSpPr>
+          <p:cNvPr id="9" name="Text 7"/>
+          <p:cNvSpPr/>
+          <p:nvPr/>
+        </p:nvSpPr>
+        <p:spPr>
+          <a:xfrm>
+            <a:off x="914400" y="4297680"/>
+            <a:ext cx="7315200" cy="201168"/>
+          </a:xfrm>
+          <a:prstGeom prst="rect">
+            <a:avLst/>
+          </a:prstGeom>
+          <a:noFill/>
+          <a:ln/>
+        </p:spPr>
+        <p:txBody>
+          <a:bodyPr wrap="square" rtlCol="0" anchor="t"/>
           <a:lstStyle/>
           <a:p>
             <a:pPr algn="ctr" indent="0" marL="0">
-              <a:lnSpc>
-                <a:spcPct val="120000"/>
-              </a:lnSpc>
-              <a:buNone/>
-            </a:pPr>
-            <a:r>
-              <a:rPr lang="en-US" sz="900" dirty="0">
+              <a:buNone/>
+            </a:pPr>
+            <a:r>
+              <a:rPr lang="en-US" sz="850" dirty="0">
                 <a:solidFill>
                   <a:srgbClr val="999999"/>
                 </a:solidFill>
@@ -2103,17 +2234,36 @@
               </a:rPr>
               <a:t>Cath Baker</a:t>
             </a:r>
-            <a:endParaRPr lang="en-US" sz="900" dirty="0"/>
-          </a:p>
+            <a:endParaRPr lang="en-US" sz="850" dirty="0"/>
+          </a:p>
+        </p:txBody>
+      </p:sp>
+      <p:sp>
+        <p:nvSpPr>
+          <p:cNvPr id="10" name="Text 8"/>
+          <p:cNvSpPr/>
+          <p:nvPr/>
+        </p:nvSpPr>
+        <p:spPr>
+          <a:xfrm>
+            <a:off x="914400" y="4480560"/>
+            <a:ext cx="7315200" cy="201168"/>
+          </a:xfrm>
+          <a:prstGeom prst="rect">
+            <a:avLst/>
+          </a:prstGeom>
+          <a:noFill/>
+          <a:ln/>
+        </p:spPr>
+        <p:txBody>
+          <a:bodyPr wrap="square" rtlCol="0" anchor="t"/>
+          <a:lstStyle/>
           <a:p>
             <a:pPr algn="ctr" indent="0" marL="0">
-              <a:lnSpc>
-                <a:spcPct val="120000"/>
-              </a:lnSpc>
-              <a:buNone/>
-            </a:pPr>
-            <a:r>
-              <a:rPr lang="en-US" sz="900" dirty="0">
+              <a:buNone/>
+            </a:pPr>
+            <a:r>
+              <a:rPr lang="en-US" sz="850" dirty="0">
                 <a:solidFill>
                   <a:srgbClr val="999999"/>
                 </a:solidFill>
@@ -2123,7 +2273,7 @@
               </a:rPr>
               <a:t>Coach4U – Strengths-Based Coaching and Counselling</a:t>
             </a:r>
-            <a:endParaRPr lang="en-US" sz="900" dirty="0"/>
+            <a:endParaRPr lang="en-US" sz="850" dirty="0"/>
           </a:p>
         </p:txBody>
       </p:sp>
@@ -2167,24 +2317,24 @@
         </p:nvSpPr>
         <p:spPr>
           <a:xfrm>
-            <a:off x="548640" y="365760"/>
-            <a:ext cx="8046720" cy="457200"/>
-          </a:xfrm>
-          <a:prstGeom prst="rect">
-            <a:avLst/>
-          </a:prstGeom>
-          <a:noFill/>
-          <a:ln/>
-        </p:spPr>
-        <p:txBody>
-          <a:bodyPr wrap="square" rtlCol="0" anchor="ctr"/>
-          <a:lstStyle/>
-          <a:p>
-            <a:pPr indent="0" marL="0">
-              <a:buNone/>
-            </a:pPr>
-            <a:r>
-              <a:rPr lang="en-US" sz="2400" b="1" dirty="0">
+            <a:off x="914400" y="457200"/>
+            <a:ext cx="7315200" cy="411480"/>
+          </a:xfrm>
+          <a:prstGeom prst="rect">
+            <a:avLst/>
+          </a:prstGeom>
+          <a:noFill/>
+          <a:ln/>
+        </p:spPr>
+        <p:txBody>
+          <a:bodyPr wrap="square" rtlCol="0" anchor="t"/>
+          <a:lstStyle/>
+          <a:p>
+            <a:pPr indent="0" marL="0">
+              <a:buNone/>
+            </a:pPr>
+            <a:r>
+              <a:rPr lang="en-US" sz="2200" b="1" dirty="0">
                 <a:solidFill>
                   <a:srgbClr val="003366"/>
                 </a:solidFill>
@@ -2194,7 +2344,7 @@
               </a:rPr>
               <a:t>What we mean by capacity and overwhelm</a:t>
             </a:r>
-            <a:endParaRPr lang="en-US" sz="2400" dirty="0"/>
+            <a:endParaRPr lang="en-US" sz="2200" dirty="0"/>
           </a:p>
         </p:txBody>
       </p:sp>
@@ -2206,117 +2356,219 @@
         </p:nvSpPr>
         <p:spPr>
           <a:xfrm>
-            <a:off x="548640" y="1005840"/>
-            <a:ext cx="8046720" cy="2286000"/>
-          </a:xfrm>
-          <a:prstGeom prst="rect">
-            <a:avLst/>
-          </a:prstGeom>
-          <a:noFill/>
-          <a:ln/>
-        </p:spPr>
-        <p:txBody>
-          <a:bodyPr wrap="square" rtlCol="0" anchor="t"/>
-          <a:lstStyle/>
-          <a:p>
-            <a:pPr indent="0" marL="0">
-              <a:lnSpc>
-                <a:spcPct val="135000"/>
-              </a:lnSpc>
-              <a:buNone/>
-            </a:pPr>
-            <a:r>
-              <a:rPr lang="en-US" sz="1300" b="1" dirty="0">
-                <a:solidFill>
-                  <a:srgbClr val="333333"/>
-                </a:solidFill>
-                <a:latin typeface="Aptos" pitchFamily="34" charset="0"/>
-                <a:ea typeface="Aptos" pitchFamily="34" charset="-122"/>
-                <a:cs typeface="Aptos" pitchFamily="34" charset="-120"/>
-              </a:rPr>
-              <a:t>Capacity is a fluctuating state, not a fixed trait.
-</a:t>
-            </a:r>
-            <a:pPr indent="0" marL="0">
-              <a:lnSpc>
-                <a:spcPct val="135000"/>
-              </a:lnSpc>
-              <a:buNone/>
-            </a:pPr>
-            <a:r>
-              <a:rPr lang="en-US" sz="1300" dirty="0">
-                <a:solidFill>
-                  <a:srgbClr val="333333"/>
-                </a:solidFill>
-                <a:latin typeface="Aptos" pitchFamily="34" charset="0"/>
-                <a:ea typeface="Aptos" pitchFamily="34" charset="-122"/>
-                <a:cs typeface="Aptos" pitchFamily="34" charset="-120"/>
-              </a:rPr>
-              <a:t>It shifts with environment, support, sensory load, and cumulative demand.
-</a:t>
-            </a:r>
-            <a:pPr indent="0" marL="0">
-              <a:lnSpc>
-                <a:spcPct val="135000"/>
-              </a:lnSpc>
-              <a:buNone/>
-            </a:pPr>
-            <a:r>
-              <a:rPr lang="en-US" sz="1300" b="1" dirty="0">
-                <a:solidFill>
-                  <a:srgbClr val="333333"/>
-                </a:solidFill>
-                <a:latin typeface="Aptos" pitchFamily="34" charset="0"/>
-                <a:ea typeface="Aptos" pitchFamily="34" charset="-122"/>
-                <a:cs typeface="Aptos" pitchFamily="34" charset="-120"/>
-              </a:rPr>
-              <a:t>Overwhelm is the tipping point.
-</a:t>
-            </a:r>
-            <a:pPr indent="0" marL="0">
-              <a:lnSpc>
-                <a:spcPct val="135000"/>
-              </a:lnSpc>
-              <a:buNone/>
-            </a:pPr>
-            <a:r>
-              <a:rPr lang="en-US" sz="1300" dirty="0">
-                <a:solidFill>
-                  <a:srgbClr val="333333"/>
-                </a:solidFill>
-                <a:latin typeface="Aptos" pitchFamily="34" charset="0"/>
-                <a:ea typeface="Aptos" pitchFamily="34" charset="-122"/>
-                <a:cs typeface="Aptos" pitchFamily="34" charset="-120"/>
-              </a:rPr>
-              <a:t>It is where demand exceeds available capacity and functioning shifts.
-</a:t>
-            </a:r>
-            <a:pPr indent="0" marL="0">
-              <a:lnSpc>
-                <a:spcPct val="135000"/>
-              </a:lnSpc>
-              <a:buNone/>
-            </a:pPr>
-            <a:r>
-              <a:rPr lang="en-US" sz="1300" b="1" dirty="0">
-                <a:solidFill>
-                  <a:srgbClr val="333333"/>
-                </a:solidFill>
-                <a:latin typeface="Aptos" pitchFamily="34" charset="0"/>
-                <a:ea typeface="Aptos" pitchFamily="34" charset="-122"/>
-                <a:cs typeface="Aptos" pitchFamily="34" charset="-120"/>
-              </a:rPr>
-              <a:t>You are not expected to solve overwhelm.
-</a:t>
-            </a:r>
-            <a:pPr indent="0" marL="0">
-              <a:lnSpc>
-                <a:spcPct val="135000"/>
-              </a:lnSpc>
-              <a:buNone/>
-            </a:pPr>
-            <a:r>
-              <a:rPr lang="en-US" sz="1300" dirty="0">
+            <a:off x="914400" y="1051560"/>
+            <a:ext cx="7315200" cy="292608"/>
+          </a:xfrm>
+          <a:prstGeom prst="rect">
+            <a:avLst/>
+          </a:prstGeom>
+          <a:noFill/>
+          <a:ln/>
+        </p:spPr>
+        <p:txBody>
+          <a:bodyPr wrap="square" rtlCol="0" anchor="t"/>
+          <a:lstStyle/>
+          <a:p>
+            <a:pPr indent="0" marL="0">
+              <a:buNone/>
+            </a:pPr>
+            <a:r>
+              <a:rPr lang="en-US" sz="1250" b="1" dirty="0">
+                <a:solidFill>
+                  <a:srgbClr val="333333"/>
+                </a:solidFill>
+                <a:latin typeface="Aptos" pitchFamily="34" charset="0"/>
+                <a:ea typeface="Aptos" pitchFamily="34" charset="-122"/>
+                <a:cs typeface="Aptos" pitchFamily="34" charset="-120"/>
+              </a:rPr>
+              <a:t>Capacity is a fluctuating state, not a fixed trait.</a:t>
+            </a:r>
+            <a:endParaRPr lang="en-US" sz="1250" dirty="0"/>
+          </a:p>
+        </p:txBody>
+      </p:sp>
+      <p:sp>
+        <p:nvSpPr>
+          <p:cNvPr id="4" name="Text 2"/>
+          <p:cNvSpPr/>
+          <p:nvPr/>
+        </p:nvSpPr>
+        <p:spPr>
+          <a:xfrm>
+            <a:off x="914400" y="1344168"/>
+            <a:ext cx="7315200" cy="292608"/>
+          </a:xfrm>
+          <a:prstGeom prst="rect">
+            <a:avLst/>
+          </a:prstGeom>
+          <a:noFill/>
+          <a:ln/>
+        </p:spPr>
+        <p:txBody>
+          <a:bodyPr wrap="square" rtlCol="0" anchor="t"/>
+          <a:lstStyle/>
+          <a:p>
+            <a:pPr indent="0" marL="0">
+              <a:buNone/>
+            </a:pPr>
+            <a:r>
+              <a:rPr lang="en-US" sz="1250" dirty="0">
+                <a:solidFill>
+                  <a:srgbClr val="333333"/>
+                </a:solidFill>
+                <a:latin typeface="Aptos" pitchFamily="34" charset="0"/>
+                <a:ea typeface="Aptos" pitchFamily="34" charset="-122"/>
+                <a:cs typeface="Aptos" pitchFamily="34" charset="-120"/>
+              </a:rPr>
+              <a:t>It shifts with environment, support, sensory load, and cumulative demand.</a:t>
+            </a:r>
+            <a:endParaRPr lang="en-US" sz="1250" dirty="0"/>
+          </a:p>
+        </p:txBody>
+      </p:sp>
+      <p:sp>
+        <p:nvSpPr>
+          <p:cNvPr id="5" name="Text 3"/>
+          <p:cNvSpPr/>
+          <p:nvPr/>
+        </p:nvSpPr>
+        <p:spPr>
+          <a:xfrm>
+            <a:off x="914400" y="1783080"/>
+            <a:ext cx="7315200" cy="292608"/>
+          </a:xfrm>
+          <a:prstGeom prst="rect">
+            <a:avLst/>
+          </a:prstGeom>
+          <a:noFill/>
+          <a:ln/>
+        </p:spPr>
+        <p:txBody>
+          <a:bodyPr wrap="square" rtlCol="0" anchor="t"/>
+          <a:lstStyle/>
+          <a:p>
+            <a:pPr indent="0" marL="0">
+              <a:buNone/>
+            </a:pPr>
+            <a:r>
+              <a:rPr lang="en-US" sz="1250" b="1" dirty="0">
+                <a:solidFill>
+                  <a:srgbClr val="333333"/>
+                </a:solidFill>
+                <a:latin typeface="Aptos" pitchFamily="34" charset="0"/>
+                <a:ea typeface="Aptos" pitchFamily="34" charset="-122"/>
+                <a:cs typeface="Aptos" pitchFamily="34" charset="-120"/>
+              </a:rPr>
+              <a:t>Overwhelm is the tipping point.</a:t>
+            </a:r>
+            <a:endParaRPr lang="en-US" sz="1250" dirty="0"/>
+          </a:p>
+        </p:txBody>
+      </p:sp>
+      <p:sp>
+        <p:nvSpPr>
+          <p:cNvPr id="6" name="Text 4"/>
+          <p:cNvSpPr/>
+          <p:nvPr/>
+        </p:nvSpPr>
+        <p:spPr>
+          <a:xfrm>
+            <a:off x="914400" y="2075688"/>
+            <a:ext cx="7315200" cy="292608"/>
+          </a:xfrm>
+          <a:prstGeom prst="rect">
+            <a:avLst/>
+          </a:prstGeom>
+          <a:noFill/>
+          <a:ln/>
+        </p:spPr>
+        <p:txBody>
+          <a:bodyPr wrap="square" rtlCol="0" anchor="t"/>
+          <a:lstStyle/>
+          <a:p>
+            <a:pPr indent="0" marL="0">
+              <a:buNone/>
+            </a:pPr>
+            <a:r>
+              <a:rPr lang="en-US" sz="1250" dirty="0">
+                <a:solidFill>
+                  <a:srgbClr val="333333"/>
+                </a:solidFill>
+                <a:latin typeface="Aptos" pitchFamily="34" charset="0"/>
+                <a:ea typeface="Aptos" pitchFamily="34" charset="-122"/>
+                <a:cs typeface="Aptos" pitchFamily="34" charset="-120"/>
+              </a:rPr>
+              <a:t>It is where demand exceeds available capacity and functioning shifts.</a:t>
+            </a:r>
+            <a:endParaRPr lang="en-US" sz="1250" dirty="0"/>
+          </a:p>
+        </p:txBody>
+      </p:sp>
+      <p:sp>
+        <p:nvSpPr>
+          <p:cNvPr id="7" name="Text 5"/>
+          <p:cNvSpPr/>
+          <p:nvPr/>
+        </p:nvSpPr>
+        <p:spPr>
+          <a:xfrm>
+            <a:off x="914400" y="2514600"/>
+            <a:ext cx="7315200" cy="292608"/>
+          </a:xfrm>
+          <a:prstGeom prst="rect">
+            <a:avLst/>
+          </a:prstGeom>
+          <a:noFill/>
+          <a:ln/>
+        </p:spPr>
+        <p:txBody>
+          <a:bodyPr wrap="square" rtlCol="0" anchor="t"/>
+          <a:lstStyle/>
+          <a:p>
+            <a:pPr indent="0" marL="0">
+              <a:buNone/>
+            </a:pPr>
+            <a:r>
+              <a:rPr lang="en-US" sz="1250" b="1" dirty="0">
+                <a:solidFill>
+                  <a:srgbClr val="333333"/>
+                </a:solidFill>
+                <a:latin typeface="Aptos" pitchFamily="34" charset="0"/>
+                <a:ea typeface="Aptos" pitchFamily="34" charset="-122"/>
+                <a:cs typeface="Aptos" pitchFamily="34" charset="-120"/>
+              </a:rPr>
+              <a:t>You are not expected to solve overwhelm.</a:t>
+            </a:r>
+            <a:endParaRPr lang="en-US" sz="1250" dirty="0"/>
+          </a:p>
+        </p:txBody>
+      </p:sp>
+      <p:sp>
+        <p:nvSpPr>
+          <p:cNvPr id="8" name="Text 6"/>
+          <p:cNvSpPr/>
+          <p:nvPr/>
+        </p:nvSpPr>
+        <p:spPr>
+          <a:xfrm>
+            <a:off x="914400" y="2807208"/>
+            <a:ext cx="7315200" cy="292608"/>
+          </a:xfrm>
+          <a:prstGeom prst="rect">
+            <a:avLst/>
+          </a:prstGeom>
+          <a:noFill/>
+          <a:ln/>
+        </p:spPr>
+        <p:txBody>
+          <a:bodyPr wrap="square" rtlCol="0" anchor="t"/>
+          <a:lstStyle/>
+          <a:p>
+            <a:pPr indent="0" marL="0">
+              <a:buNone/>
+            </a:pPr>
+            <a:r>
+              <a:rPr lang="en-US" sz="1250" dirty="0">
                 <a:solidFill>
                   <a:srgbClr val="333333"/>
                 </a:solidFill>
@@ -2326,24 +2578,24 @@
               </a:rPr>
               <a:t>The work is recognising it and responding safely.</a:t>
             </a:r>
-            <a:endParaRPr lang="en-US" sz="1300" dirty="0"/>
-          </a:p>
-        </p:txBody>
-      </p:sp>
-      <p:sp>
-        <p:nvSpPr>
-          <p:cNvPr id="4" name="Shape 2"/>
-          <p:cNvSpPr/>
-          <p:nvPr/>
-        </p:nvSpPr>
-        <p:spPr>
-          <a:xfrm>
-            <a:off x="548640" y="3520440"/>
-            <a:ext cx="8046720" cy="685800"/>
+            <a:endParaRPr lang="en-US" sz="1250" dirty="0"/>
+          </a:p>
+        </p:txBody>
+      </p:sp>
+      <p:sp>
+        <p:nvSpPr>
+          <p:cNvPr id="9" name="Shape 7"/>
+          <p:cNvSpPr/>
+          <p:nvPr/>
+        </p:nvSpPr>
+        <p:spPr>
+          <a:xfrm>
+            <a:off x="914400" y="3337560"/>
+            <a:ext cx="7315200" cy="640080"/>
           </a:xfrm>
           <a:prstGeom prst="rect">
             <a:avLst>
-              <a:gd name="adj" fmla="val 6667"/>
+              <a:gd name="adj" fmla="val 5714"/>
             </a:avLst>
           </a:prstGeom>
           <a:solidFill>
@@ -2359,33 +2611,30 @@
       </p:sp>
       <p:sp>
         <p:nvSpPr>
-          <p:cNvPr id="5" name="Text 3"/>
-          <p:cNvSpPr/>
-          <p:nvPr/>
-        </p:nvSpPr>
-        <p:spPr>
-          <a:xfrm>
-            <a:off x="731520" y="3611880"/>
-            <a:ext cx="7680960" cy="502920"/>
-          </a:xfrm>
-          <a:prstGeom prst="rect">
-            <a:avLst/>
-          </a:prstGeom>
-          <a:noFill/>
-          <a:ln/>
-        </p:spPr>
-        <p:txBody>
-          <a:bodyPr wrap="square" rtlCol="0" anchor="t"/>
-          <a:lstStyle/>
-          <a:p>
-            <a:pPr indent="0" marL="0">
-              <a:lnSpc>
-                <a:spcPct val="130000"/>
-              </a:lnSpc>
-              <a:buNone/>
-            </a:pPr>
-            <a:r>
-              <a:rPr lang="en-US" sz="1100" b="1" dirty="0">
+          <p:cNvPr id="10" name="Text 8"/>
+          <p:cNvSpPr/>
+          <p:nvPr/>
+        </p:nvSpPr>
+        <p:spPr>
+          <a:xfrm>
+            <a:off x="1051560" y="3410712"/>
+            <a:ext cx="7040880" cy="182880"/>
+          </a:xfrm>
+          <a:prstGeom prst="rect">
+            <a:avLst/>
+          </a:prstGeom>
+          <a:noFill/>
+          <a:ln/>
+        </p:spPr>
+        <p:txBody>
+          <a:bodyPr wrap="square" rtlCol="0" anchor="t"/>
+          <a:lstStyle/>
+          <a:p>
+            <a:pPr indent="0" marL="0">
+              <a:buNone/>
+            </a:pPr>
+            <a:r>
+              <a:rPr lang="en-US" sz="1050" b="1" dirty="0">
                 <a:solidFill>
                   <a:srgbClr val="003366"/>
                 </a:solidFill>
@@ -2393,17 +2642,38 @@
                 <a:ea typeface="Aptos" pitchFamily="34" charset="-122"/>
                 <a:cs typeface="Aptos" pitchFamily="34" charset="-120"/>
               </a:rPr>
-              <a:t>Discussion prompt:
-</a:t>
-            </a:r>
-            <a:pPr indent="0" marL="0">
-              <a:lnSpc>
-                <a:spcPct val="130000"/>
-              </a:lnSpc>
-              <a:buNone/>
-            </a:pPr>
-            <a:r>
-              <a:rPr lang="en-US" sz="1100" i="1" dirty="0">
+              <a:t>Discussion prompt:</a:t>
+            </a:r>
+            <a:endParaRPr lang="en-US" sz="1050" dirty="0"/>
+          </a:p>
+        </p:txBody>
+      </p:sp>
+      <p:sp>
+        <p:nvSpPr>
+          <p:cNvPr id="11" name="Text 9"/>
+          <p:cNvSpPr/>
+          <p:nvPr/>
+        </p:nvSpPr>
+        <p:spPr>
+          <a:xfrm>
+            <a:off x="1051560" y="3611880"/>
+            <a:ext cx="7040880" cy="292608"/>
+          </a:xfrm>
+          <a:prstGeom prst="rect">
+            <a:avLst/>
+          </a:prstGeom>
+          <a:noFill/>
+          <a:ln/>
+        </p:spPr>
+        <p:txBody>
+          <a:bodyPr wrap="square" rtlCol="0" anchor="t"/>
+          <a:lstStyle/>
+          <a:p>
+            <a:pPr indent="0" marL="0">
+              <a:buNone/>
+            </a:pPr>
+            <a:r>
+              <a:rPr lang="en-US" sz="1050" i="1" dirty="0">
                 <a:solidFill>
                   <a:srgbClr val="333333"/>
                 </a:solidFill>
@@ -2413,7 +2683,7 @@
               </a:rPr>
               <a:t>What are the early signs someone has moved beyond functional capacity, not just the obvious crash?</a:t>
             </a:r>
-            <a:endParaRPr lang="en-US" sz="1100" dirty="0"/>
+            <a:endParaRPr lang="en-US" sz="1050" dirty="0"/>
           </a:p>
         </p:txBody>
       </p:sp>
@@ -2457,24 +2727,24 @@
         </p:nvSpPr>
         <p:spPr>
           <a:xfrm>
-            <a:off x="548640" y="365760"/>
-            <a:ext cx="8046720" cy="457200"/>
-          </a:xfrm>
-          <a:prstGeom prst="rect">
-            <a:avLst/>
-          </a:prstGeom>
-          <a:noFill/>
-          <a:ln/>
-        </p:spPr>
-        <p:txBody>
-          <a:bodyPr wrap="square" rtlCol="0" anchor="ctr"/>
-          <a:lstStyle/>
-          <a:p>
-            <a:pPr indent="0" marL="0">
-              <a:buNone/>
-            </a:pPr>
-            <a:r>
-              <a:rPr lang="en-US" sz="2400" b="1" dirty="0">
+            <a:off x="914400" y="457200"/>
+            <a:ext cx="7315200" cy="411480"/>
+          </a:xfrm>
+          <a:prstGeom prst="rect">
+            <a:avLst/>
+          </a:prstGeom>
+          <a:noFill/>
+          <a:ln/>
+        </p:spPr>
+        <p:txBody>
+          <a:bodyPr wrap="square" rtlCol="0" anchor="t"/>
+          <a:lstStyle/>
+          <a:p>
+            <a:pPr indent="0" marL="0">
+              <a:buNone/>
+            </a:pPr>
+            <a:r>
+              <a:rPr lang="en-US" sz="2200" b="1" dirty="0">
                 <a:solidFill>
                   <a:srgbClr val="003366"/>
                 </a:solidFill>
@@ -2484,7 +2754,7 @@
               </a:rPr>
               <a:t>Neurodivergent lens: why overwhelm can become baseline</a:t>
             </a:r>
-            <a:endParaRPr lang="en-US" sz="2400" dirty="0"/>
+            <a:endParaRPr lang="en-US" sz="2200" dirty="0"/>
           </a:p>
         </p:txBody>
       </p:sp>
@@ -2496,117 +2766,219 @@
         </p:nvSpPr>
         <p:spPr>
           <a:xfrm>
-            <a:off x="548640" y="1005840"/>
-            <a:ext cx="8046720" cy="2286000"/>
-          </a:xfrm>
-          <a:prstGeom prst="rect">
-            <a:avLst/>
-          </a:prstGeom>
-          <a:noFill/>
-          <a:ln/>
-        </p:spPr>
-        <p:txBody>
-          <a:bodyPr wrap="square" rtlCol="0" anchor="t"/>
-          <a:lstStyle/>
-          <a:p>
-            <a:pPr indent="0" marL="0">
-              <a:lnSpc>
-                <a:spcPct val="135000"/>
-              </a:lnSpc>
-              <a:buNone/>
-            </a:pPr>
-            <a:r>
-              <a:rPr lang="en-US" sz="1300" b="1" dirty="0">
-                <a:solidFill>
-                  <a:srgbClr val="333333"/>
-                </a:solidFill>
-                <a:latin typeface="Aptos" pitchFamily="34" charset="0"/>
-                <a:ea typeface="Aptos" pitchFamily="34" charset="-122"/>
-                <a:cs typeface="Aptos" pitchFamily="34" charset="-120"/>
-              </a:rPr>
-              <a:t>Capacity costs are different for neurodivergent people.
-</a:t>
-            </a:r>
-            <a:pPr indent="0" marL="0">
-              <a:lnSpc>
-                <a:spcPct val="135000"/>
-              </a:lnSpc>
-              <a:buNone/>
-            </a:pPr>
-            <a:r>
-              <a:rPr lang="en-US" sz="1300" dirty="0">
-                <a:solidFill>
-                  <a:srgbClr val="333333"/>
-                </a:solidFill>
-                <a:latin typeface="Aptos" pitchFamily="34" charset="0"/>
-                <a:ea typeface="Aptos" pitchFamily="34" charset="-122"/>
-                <a:cs typeface="Aptos" pitchFamily="34" charset="-120"/>
-              </a:rPr>
-              <a:t>Masking, sensory processing, executive function demands, and social navigation consume energy.
-</a:t>
-            </a:r>
-            <a:pPr indent="0" marL="0">
-              <a:lnSpc>
-                <a:spcPct val="135000"/>
-              </a:lnSpc>
-              <a:buNone/>
-            </a:pPr>
-            <a:r>
-              <a:rPr lang="en-US" sz="1300" b="1" dirty="0">
-                <a:solidFill>
-                  <a:srgbClr val="333333"/>
-                </a:solidFill>
-                <a:latin typeface="Aptos" pitchFamily="34" charset="0"/>
-                <a:ea typeface="Aptos" pitchFamily="34" charset="-122"/>
-                <a:cs typeface="Aptos" pitchFamily="34" charset="-120"/>
-              </a:rPr>
-              <a:t>Variability is part of the lived reality.
-</a:t>
-            </a:r>
-            <a:pPr indent="0" marL="0">
-              <a:lnSpc>
-                <a:spcPct val="135000"/>
-              </a:lnSpc>
-              <a:buNone/>
-            </a:pPr>
-            <a:r>
-              <a:rPr lang="en-US" sz="1300" dirty="0">
-                <a:solidFill>
-                  <a:srgbClr val="333333"/>
-                </a:solidFill>
-                <a:latin typeface="Aptos" pitchFamily="34" charset="0"/>
-                <a:ea typeface="Aptos" pitchFamily="34" charset="-122"/>
-                <a:cs typeface="Aptos" pitchFamily="34" charset="-120"/>
-              </a:rPr>
-              <a:t>What feels manageable one day may be impossible the next.
-</a:t>
-            </a:r>
-            <a:pPr indent="0" marL="0">
-              <a:lnSpc>
-                <a:spcPct val="135000"/>
-              </a:lnSpc>
-              <a:buNone/>
-            </a:pPr>
-            <a:r>
-              <a:rPr lang="en-US" sz="1300" b="1" dirty="0">
-                <a:solidFill>
-                  <a:srgbClr val="333333"/>
-                </a:solidFill>
-                <a:latin typeface="Aptos" pitchFamily="34" charset="0"/>
-                <a:ea typeface="Aptos" pitchFamily="34" charset="-122"/>
-                <a:cs typeface="Aptos" pitchFamily="34" charset="-120"/>
-              </a:rPr>
-              <a:t>Cumulative load builds quietly.
-</a:t>
-            </a:r>
-            <a:pPr indent="0" marL="0">
-              <a:lnSpc>
-                <a:spcPct val="135000"/>
-              </a:lnSpc>
-              <a:buNone/>
-            </a:pPr>
-            <a:r>
-              <a:rPr lang="en-US" sz="1300" dirty="0">
+            <a:off x="914400" y="1051560"/>
+            <a:ext cx="7315200" cy="292608"/>
+          </a:xfrm>
+          <a:prstGeom prst="rect">
+            <a:avLst/>
+          </a:prstGeom>
+          <a:noFill/>
+          <a:ln/>
+        </p:spPr>
+        <p:txBody>
+          <a:bodyPr wrap="square" rtlCol="0" anchor="t"/>
+          <a:lstStyle/>
+          <a:p>
+            <a:pPr indent="0" marL="0">
+              <a:buNone/>
+            </a:pPr>
+            <a:r>
+              <a:rPr lang="en-US" sz="1250" b="1" dirty="0">
+                <a:solidFill>
+                  <a:srgbClr val="333333"/>
+                </a:solidFill>
+                <a:latin typeface="Aptos" pitchFamily="34" charset="0"/>
+                <a:ea typeface="Aptos" pitchFamily="34" charset="-122"/>
+                <a:cs typeface="Aptos" pitchFamily="34" charset="-120"/>
+              </a:rPr>
+              <a:t>Capacity costs are different for neurodivergent people.</a:t>
+            </a:r>
+            <a:endParaRPr lang="en-US" sz="1250" dirty="0"/>
+          </a:p>
+        </p:txBody>
+      </p:sp>
+      <p:sp>
+        <p:nvSpPr>
+          <p:cNvPr id="4" name="Text 2"/>
+          <p:cNvSpPr/>
+          <p:nvPr/>
+        </p:nvSpPr>
+        <p:spPr>
+          <a:xfrm>
+            <a:off x="914400" y="1344168"/>
+            <a:ext cx="7315200" cy="292608"/>
+          </a:xfrm>
+          <a:prstGeom prst="rect">
+            <a:avLst/>
+          </a:prstGeom>
+          <a:noFill/>
+          <a:ln/>
+        </p:spPr>
+        <p:txBody>
+          <a:bodyPr wrap="square" rtlCol="0" anchor="t"/>
+          <a:lstStyle/>
+          <a:p>
+            <a:pPr indent="0" marL="0">
+              <a:buNone/>
+            </a:pPr>
+            <a:r>
+              <a:rPr lang="en-US" sz="1250" dirty="0">
+                <a:solidFill>
+                  <a:srgbClr val="333333"/>
+                </a:solidFill>
+                <a:latin typeface="Aptos" pitchFamily="34" charset="0"/>
+                <a:ea typeface="Aptos" pitchFamily="34" charset="-122"/>
+                <a:cs typeface="Aptos" pitchFamily="34" charset="-120"/>
+              </a:rPr>
+              <a:t>Masking, sensory processing, executive function demands, and social navigation consume energy.</a:t>
+            </a:r>
+            <a:endParaRPr lang="en-US" sz="1250" dirty="0"/>
+          </a:p>
+        </p:txBody>
+      </p:sp>
+      <p:sp>
+        <p:nvSpPr>
+          <p:cNvPr id="5" name="Text 3"/>
+          <p:cNvSpPr/>
+          <p:nvPr/>
+        </p:nvSpPr>
+        <p:spPr>
+          <a:xfrm>
+            <a:off x="914400" y="1783080"/>
+            <a:ext cx="7315200" cy="292608"/>
+          </a:xfrm>
+          <a:prstGeom prst="rect">
+            <a:avLst/>
+          </a:prstGeom>
+          <a:noFill/>
+          <a:ln/>
+        </p:spPr>
+        <p:txBody>
+          <a:bodyPr wrap="square" rtlCol="0" anchor="t"/>
+          <a:lstStyle/>
+          <a:p>
+            <a:pPr indent="0" marL="0">
+              <a:buNone/>
+            </a:pPr>
+            <a:r>
+              <a:rPr lang="en-US" sz="1250" b="1" dirty="0">
+                <a:solidFill>
+                  <a:srgbClr val="333333"/>
+                </a:solidFill>
+                <a:latin typeface="Aptos" pitchFamily="34" charset="0"/>
+                <a:ea typeface="Aptos" pitchFamily="34" charset="-122"/>
+                <a:cs typeface="Aptos" pitchFamily="34" charset="-120"/>
+              </a:rPr>
+              <a:t>Variability is part of the lived reality.</a:t>
+            </a:r>
+            <a:endParaRPr lang="en-US" sz="1250" dirty="0"/>
+          </a:p>
+        </p:txBody>
+      </p:sp>
+      <p:sp>
+        <p:nvSpPr>
+          <p:cNvPr id="6" name="Text 4"/>
+          <p:cNvSpPr/>
+          <p:nvPr/>
+        </p:nvSpPr>
+        <p:spPr>
+          <a:xfrm>
+            <a:off x="914400" y="2075688"/>
+            <a:ext cx="7315200" cy="292608"/>
+          </a:xfrm>
+          <a:prstGeom prst="rect">
+            <a:avLst/>
+          </a:prstGeom>
+          <a:noFill/>
+          <a:ln/>
+        </p:spPr>
+        <p:txBody>
+          <a:bodyPr wrap="square" rtlCol="0" anchor="t"/>
+          <a:lstStyle/>
+          <a:p>
+            <a:pPr indent="0" marL="0">
+              <a:buNone/>
+            </a:pPr>
+            <a:r>
+              <a:rPr lang="en-US" sz="1250" dirty="0">
+                <a:solidFill>
+                  <a:srgbClr val="333333"/>
+                </a:solidFill>
+                <a:latin typeface="Aptos" pitchFamily="34" charset="0"/>
+                <a:ea typeface="Aptos" pitchFamily="34" charset="-122"/>
+                <a:cs typeface="Aptos" pitchFamily="34" charset="-120"/>
+              </a:rPr>
+              <a:t>What feels manageable one day may be impossible the next.</a:t>
+            </a:r>
+            <a:endParaRPr lang="en-US" sz="1250" dirty="0"/>
+          </a:p>
+        </p:txBody>
+      </p:sp>
+      <p:sp>
+        <p:nvSpPr>
+          <p:cNvPr id="7" name="Text 5"/>
+          <p:cNvSpPr/>
+          <p:nvPr/>
+        </p:nvSpPr>
+        <p:spPr>
+          <a:xfrm>
+            <a:off x="914400" y="2514600"/>
+            <a:ext cx="7315200" cy="292608"/>
+          </a:xfrm>
+          <a:prstGeom prst="rect">
+            <a:avLst/>
+          </a:prstGeom>
+          <a:noFill/>
+          <a:ln/>
+        </p:spPr>
+        <p:txBody>
+          <a:bodyPr wrap="square" rtlCol="0" anchor="t"/>
+          <a:lstStyle/>
+          <a:p>
+            <a:pPr indent="0" marL="0">
+              <a:buNone/>
+            </a:pPr>
+            <a:r>
+              <a:rPr lang="en-US" sz="1250" b="1" dirty="0">
+                <a:solidFill>
+                  <a:srgbClr val="333333"/>
+                </a:solidFill>
+                <a:latin typeface="Aptos" pitchFamily="34" charset="0"/>
+                <a:ea typeface="Aptos" pitchFamily="34" charset="-122"/>
+                <a:cs typeface="Aptos" pitchFamily="34" charset="-120"/>
+              </a:rPr>
+              <a:t>Cumulative load builds quietly.</a:t>
+            </a:r>
+            <a:endParaRPr lang="en-US" sz="1250" dirty="0"/>
+          </a:p>
+        </p:txBody>
+      </p:sp>
+      <p:sp>
+        <p:nvSpPr>
+          <p:cNvPr id="8" name="Text 6"/>
+          <p:cNvSpPr/>
+          <p:nvPr/>
+        </p:nvSpPr>
+        <p:spPr>
+          <a:xfrm>
+            <a:off x="914400" y="2807208"/>
+            <a:ext cx="7315200" cy="292608"/>
+          </a:xfrm>
+          <a:prstGeom prst="rect">
+            <a:avLst/>
+          </a:prstGeom>
+          <a:noFill/>
+          <a:ln/>
+        </p:spPr>
+        <p:txBody>
+          <a:bodyPr wrap="square" rtlCol="0" anchor="t"/>
+          <a:lstStyle/>
+          <a:p>
+            <a:pPr indent="0" marL="0">
+              <a:buNone/>
+            </a:pPr>
+            <a:r>
+              <a:rPr lang="en-US" sz="1250" dirty="0">
                 <a:solidFill>
                   <a:srgbClr val="333333"/>
                 </a:solidFill>
@@ -2616,24 +2988,24 @@
               </a:rPr>
               <a:t>Recovery often takes longer than depletion.</a:t>
             </a:r>
-            <a:endParaRPr lang="en-US" sz="1300" dirty="0"/>
-          </a:p>
-        </p:txBody>
-      </p:sp>
-      <p:sp>
-        <p:nvSpPr>
-          <p:cNvPr id="4" name="Shape 2"/>
-          <p:cNvSpPr/>
-          <p:nvPr/>
-        </p:nvSpPr>
-        <p:spPr>
-          <a:xfrm>
-            <a:off x="548640" y="3520440"/>
-            <a:ext cx="8046720" cy="640080"/>
+            <a:endParaRPr lang="en-US" sz="1250" dirty="0"/>
+          </a:p>
+        </p:txBody>
+      </p:sp>
+      <p:sp>
+        <p:nvSpPr>
+          <p:cNvPr id="9" name="Shape 7"/>
+          <p:cNvSpPr/>
+          <p:nvPr/>
+        </p:nvSpPr>
+        <p:spPr>
+          <a:xfrm>
+            <a:off x="914400" y="3337560"/>
+            <a:ext cx="7315200" cy="640080"/>
           </a:xfrm>
           <a:prstGeom prst="rect">
             <a:avLst>
-              <a:gd name="adj" fmla="val 7143"/>
+              <a:gd name="adj" fmla="val 5714"/>
             </a:avLst>
           </a:prstGeom>
           <a:solidFill>
@@ -2649,33 +3021,30 @@
       </p:sp>
       <p:sp>
         <p:nvSpPr>
-          <p:cNvPr id="5" name="Text 3"/>
-          <p:cNvSpPr/>
-          <p:nvPr/>
-        </p:nvSpPr>
-        <p:spPr>
-          <a:xfrm>
-            <a:off x="731520" y="3611880"/>
-            <a:ext cx="7680960" cy="457200"/>
-          </a:xfrm>
-          <a:prstGeom prst="rect">
-            <a:avLst/>
-          </a:prstGeom>
-          <a:noFill/>
-          <a:ln/>
-        </p:spPr>
-        <p:txBody>
-          <a:bodyPr wrap="square" rtlCol="0" anchor="t"/>
-          <a:lstStyle/>
-          <a:p>
-            <a:pPr indent="0" marL="0">
-              <a:lnSpc>
-                <a:spcPct val="130000"/>
-              </a:lnSpc>
-              <a:buNone/>
-            </a:pPr>
-            <a:r>
-              <a:rPr lang="en-US" sz="1100" b="1" dirty="0">
+          <p:cNvPr id="10" name="Text 8"/>
+          <p:cNvSpPr/>
+          <p:nvPr/>
+        </p:nvSpPr>
+        <p:spPr>
+          <a:xfrm>
+            <a:off x="1051560" y="3410712"/>
+            <a:ext cx="7040880" cy="182880"/>
+          </a:xfrm>
+          <a:prstGeom prst="rect">
+            <a:avLst/>
+          </a:prstGeom>
+          <a:noFill/>
+          <a:ln/>
+        </p:spPr>
+        <p:txBody>
+          <a:bodyPr wrap="square" rtlCol="0" anchor="t"/>
+          <a:lstStyle/>
+          <a:p>
+            <a:pPr indent="0" marL="0">
+              <a:buNone/>
+            </a:pPr>
+            <a:r>
+              <a:rPr lang="en-US" sz="1050" b="1" dirty="0">
                 <a:solidFill>
                   <a:srgbClr val="003366"/>
                 </a:solidFill>
@@ -2683,17 +3052,38 @@
                 <a:ea typeface="Aptos" pitchFamily="34" charset="-122"/>
                 <a:cs typeface="Aptos" pitchFamily="34" charset="-120"/>
               </a:rPr>
-              <a:t>Discussion prompt:
-</a:t>
-            </a:r>
-            <a:pPr indent="0" marL="0">
-              <a:lnSpc>
-                <a:spcPct val="130000"/>
-              </a:lnSpc>
-              <a:buNone/>
-            </a:pPr>
-            <a:r>
-              <a:rPr lang="en-US" sz="1100" i="1" dirty="0">
+              <a:t>Discussion prompt:</a:t>
+            </a:r>
+            <a:endParaRPr lang="en-US" sz="1050" dirty="0"/>
+          </a:p>
+        </p:txBody>
+      </p:sp>
+      <p:sp>
+        <p:nvSpPr>
+          <p:cNvPr id="11" name="Text 9"/>
+          <p:cNvSpPr/>
+          <p:nvPr/>
+        </p:nvSpPr>
+        <p:spPr>
+          <a:xfrm>
+            <a:off x="1051560" y="3611880"/>
+            <a:ext cx="7040880" cy="292608"/>
+          </a:xfrm>
+          <a:prstGeom prst="rect">
+            <a:avLst/>
+          </a:prstGeom>
+          <a:noFill/>
+          <a:ln/>
+        </p:spPr>
+        <p:txBody>
+          <a:bodyPr wrap="square" rtlCol="0" anchor="t"/>
+          <a:lstStyle/>
+          <a:p>
+            <a:pPr indent="0" marL="0">
+              <a:buNone/>
+            </a:pPr>
+            <a:r>
+              <a:rPr lang="en-US" sz="1050" i="1" dirty="0">
                 <a:solidFill>
                   <a:srgbClr val="333333"/>
                 </a:solidFill>
@@ -2703,7 +3093,7 @@
               </a:rPr>
               <a:t>How does overwhelm present differently across the neurodivergent clients you work with?</a:t>
             </a:r>
-            <a:endParaRPr lang="en-US" sz="1100" dirty="0"/>
+            <a:endParaRPr lang="en-US" sz="1050" dirty="0"/>
           </a:p>
         </p:txBody>
       </p:sp>
@@ -2747,24 +3137,24 @@
         </p:nvSpPr>
         <p:spPr>
           <a:xfrm>
-            <a:off x="548640" y="365760"/>
-            <a:ext cx="8046720" cy="457200"/>
-          </a:xfrm>
-          <a:prstGeom prst="rect">
-            <a:avLst/>
-          </a:prstGeom>
-          <a:noFill/>
-          <a:ln/>
-        </p:spPr>
-        <p:txBody>
-          <a:bodyPr wrap="square" rtlCol="0" anchor="ctr"/>
-          <a:lstStyle/>
-          <a:p>
-            <a:pPr indent="0" marL="0">
-              <a:buNone/>
-            </a:pPr>
-            <a:r>
-              <a:rPr lang="en-US" sz="2400" b="1" dirty="0">
+            <a:off x="914400" y="457200"/>
+            <a:ext cx="7315200" cy="411480"/>
+          </a:xfrm>
+          <a:prstGeom prst="rect">
+            <a:avLst/>
+          </a:prstGeom>
+          <a:noFill/>
+          <a:ln/>
+        </p:spPr>
+        <p:txBody>
+          <a:bodyPr wrap="square" rtlCol="0" anchor="t"/>
+          <a:lstStyle/>
+          <a:p>
+            <a:pPr indent="0" marL="0">
+              <a:buNone/>
+            </a:pPr>
+            <a:r>
+              <a:rPr lang="en-US" sz="2200" b="1" dirty="0">
                 <a:solidFill>
                   <a:srgbClr val="003366"/>
                 </a:solidFill>
@@ -2774,7 +3164,7 @@
               </a:rPr>
               <a:t>The gap: why tools often fail under load</a:t>
             </a:r>
-            <a:endParaRPr lang="en-US" sz="2400" dirty="0"/>
+            <a:endParaRPr lang="en-US" sz="2200" dirty="0"/>
           </a:p>
         </p:txBody>
       </p:sp>
@@ -2786,153 +3176,297 @@
         </p:nvSpPr>
         <p:spPr>
           <a:xfrm>
-            <a:off x="548640" y="1005840"/>
-            <a:ext cx="8046720" cy="2560320"/>
-          </a:xfrm>
-          <a:prstGeom prst="rect">
-            <a:avLst/>
-          </a:prstGeom>
-          <a:noFill/>
-          <a:ln/>
-        </p:spPr>
-        <p:txBody>
-          <a:bodyPr wrap="square" rtlCol="0" anchor="t"/>
-          <a:lstStyle/>
-          <a:p>
-            <a:pPr indent="0" marL="0">
-              <a:lnSpc>
-                <a:spcPct val="130000"/>
-              </a:lnSpc>
-              <a:buNone/>
-            </a:pPr>
-            <a:r>
-              <a:rPr lang="en-US" sz="1300" b="1" dirty="0">
-                <a:solidFill>
-                  <a:srgbClr val="333333"/>
-                </a:solidFill>
-                <a:latin typeface="Aptos" pitchFamily="34" charset="0"/>
-                <a:ea typeface="Aptos" pitchFamily="34" charset="-122"/>
-                <a:cs typeface="Aptos" pitchFamily="34" charset="-120"/>
-              </a:rPr>
-              <a:t>There is a lot of advice.
-</a:t>
-            </a:r>
-            <a:pPr indent="0" marL="0">
-              <a:lnSpc>
-                <a:spcPct val="130000"/>
-              </a:lnSpc>
-              <a:buNone/>
-            </a:pPr>
-            <a:r>
-              <a:rPr lang="en-US" sz="1300" dirty="0">
-                <a:solidFill>
-                  <a:srgbClr val="333333"/>
-                </a:solidFill>
-                <a:latin typeface="Aptos" pitchFamily="34" charset="0"/>
-                <a:ea typeface="Aptos" pitchFamily="34" charset="-122"/>
-                <a:cs typeface="Aptos" pitchFamily="34" charset="-120"/>
-              </a:rPr>
-              <a:t>Much of it does not translate to real capacity, strengths, and family pressure.
-</a:t>
-            </a:r>
-            <a:pPr indent="0" marL="0">
-              <a:lnSpc>
-                <a:spcPct val="130000"/>
-              </a:lnSpc>
-              <a:buNone/>
-            </a:pPr>
-            <a:r>
-              <a:rPr lang="en-US" sz="1300" b="1" dirty="0">
-                <a:solidFill>
-                  <a:srgbClr val="333333"/>
-                </a:solidFill>
-                <a:latin typeface="Aptos" pitchFamily="34" charset="0"/>
-                <a:ea typeface="Aptos" pitchFamily="34" charset="-122"/>
-                <a:cs typeface="Aptos" pitchFamily="34" charset="-120"/>
-              </a:rPr>
-              <a:t>Quick fixes often work briefly.
-</a:t>
-            </a:r>
-            <a:pPr indent="0" marL="0">
-              <a:lnSpc>
-                <a:spcPct val="130000"/>
-              </a:lnSpc>
-              <a:buNone/>
-            </a:pPr>
-            <a:r>
-              <a:rPr lang="en-US" sz="1300" dirty="0">
-                <a:solidFill>
-                  <a:srgbClr val="333333"/>
-                </a:solidFill>
-                <a:latin typeface="Aptos" pitchFamily="34" charset="0"/>
-                <a:ea typeface="Aptos" pitchFamily="34" charset="-122"/>
-                <a:cs typeface="Aptos" pitchFamily="34" charset="-120"/>
-              </a:rPr>
-              <a:t>When capacity drops, they collapse and reinforce a sense of failure.
-</a:t>
-            </a:r>
-            <a:pPr indent="0" marL="0">
-              <a:lnSpc>
-                <a:spcPct val="130000"/>
-              </a:lnSpc>
-              <a:buNone/>
-            </a:pPr>
-            <a:r>
-              <a:rPr lang="en-US" sz="1300" b="1" dirty="0">
-                <a:solidFill>
-                  <a:srgbClr val="333333"/>
-                </a:solidFill>
-                <a:latin typeface="Aptos" pitchFamily="34" charset="0"/>
-                <a:ea typeface="Aptos" pitchFamily="34" charset="-122"/>
-                <a:cs typeface="Aptos" pitchFamily="34" charset="-120"/>
-              </a:rPr>
-              <a:t>Many people are motivated and capable.
-</a:t>
-            </a:r>
-            <a:pPr indent="0" marL="0">
-              <a:lnSpc>
-                <a:spcPct val="130000"/>
-              </a:lnSpc>
-              <a:buNone/>
-            </a:pPr>
-            <a:r>
-              <a:rPr lang="en-US" sz="1300" dirty="0">
-                <a:solidFill>
-                  <a:srgbClr val="333333"/>
-                </a:solidFill>
-                <a:latin typeface="Aptos" pitchFamily="34" charset="0"/>
-                <a:ea typeface="Aptos" pitchFamily="34" charset="-122"/>
-                <a:cs typeface="Aptos" pitchFamily="34" charset="-120"/>
-              </a:rPr>
-              <a:t>They can still resist goals when those goals feel restrictive.
-</a:t>
-            </a:r>
-            <a:pPr indent="0" marL="0">
-              <a:lnSpc>
-                <a:spcPct val="130000"/>
-              </a:lnSpc>
-              <a:buNone/>
-            </a:pPr>
-            <a:r>
-              <a:rPr lang="en-US" sz="1300" b="1" dirty="0">
-                <a:solidFill>
-                  <a:srgbClr val="333333"/>
-                </a:solidFill>
-                <a:latin typeface="Aptos" pitchFamily="34" charset="0"/>
-                <a:ea typeface="Aptos" pitchFamily="34" charset="-122"/>
-                <a:cs typeface="Aptos" pitchFamily="34" charset="-120"/>
-              </a:rPr>
-              <a:t>People still need anchoring.
-</a:t>
-            </a:r>
-            <a:pPr indent="0" marL="0">
-              <a:lnSpc>
-                <a:spcPct val="130000"/>
-              </a:lnSpc>
-              <a:buNone/>
-            </a:pPr>
-            <a:r>
-              <a:rPr lang="en-US" sz="1300" dirty="0">
+            <a:off x="914400" y="1051560"/>
+            <a:ext cx="7315200" cy="292608"/>
+          </a:xfrm>
+          <a:prstGeom prst="rect">
+            <a:avLst/>
+          </a:prstGeom>
+          <a:noFill/>
+          <a:ln/>
+        </p:spPr>
+        <p:txBody>
+          <a:bodyPr wrap="square" rtlCol="0" anchor="t"/>
+          <a:lstStyle/>
+          <a:p>
+            <a:pPr indent="0" marL="0">
+              <a:buNone/>
+            </a:pPr>
+            <a:r>
+              <a:rPr lang="en-US" sz="1250" b="1" dirty="0">
+                <a:solidFill>
+                  <a:srgbClr val="333333"/>
+                </a:solidFill>
+                <a:latin typeface="Aptos" pitchFamily="34" charset="0"/>
+                <a:ea typeface="Aptos" pitchFamily="34" charset="-122"/>
+                <a:cs typeface="Aptos" pitchFamily="34" charset="-120"/>
+              </a:rPr>
+              <a:t>There is a lot of advice.</a:t>
+            </a:r>
+            <a:endParaRPr lang="en-US" sz="1250" dirty="0"/>
+          </a:p>
+        </p:txBody>
+      </p:sp>
+      <p:sp>
+        <p:nvSpPr>
+          <p:cNvPr id="4" name="Text 2"/>
+          <p:cNvSpPr/>
+          <p:nvPr/>
+        </p:nvSpPr>
+        <p:spPr>
+          <a:xfrm>
+            <a:off x="914400" y="1307592"/>
+            <a:ext cx="7315200" cy="292608"/>
+          </a:xfrm>
+          <a:prstGeom prst="rect">
+            <a:avLst/>
+          </a:prstGeom>
+          <a:noFill/>
+          <a:ln/>
+        </p:spPr>
+        <p:txBody>
+          <a:bodyPr wrap="square" rtlCol="0" anchor="t"/>
+          <a:lstStyle/>
+          <a:p>
+            <a:pPr indent="0" marL="0">
+              <a:buNone/>
+            </a:pPr>
+            <a:r>
+              <a:rPr lang="en-US" sz="1250" dirty="0">
+                <a:solidFill>
+                  <a:srgbClr val="333333"/>
+                </a:solidFill>
+                <a:latin typeface="Aptos" pitchFamily="34" charset="0"/>
+                <a:ea typeface="Aptos" pitchFamily="34" charset="-122"/>
+                <a:cs typeface="Aptos" pitchFamily="34" charset="-120"/>
+              </a:rPr>
+              <a:t>Much of it does not translate to real capacity, strengths, and family pressure.</a:t>
+            </a:r>
+            <a:endParaRPr lang="en-US" sz="1250" dirty="0"/>
+          </a:p>
+        </p:txBody>
+      </p:sp>
+      <p:sp>
+        <p:nvSpPr>
+          <p:cNvPr id="5" name="Text 3"/>
+          <p:cNvSpPr/>
+          <p:nvPr/>
+        </p:nvSpPr>
+        <p:spPr>
+          <a:xfrm>
+            <a:off x="914400" y="1673352"/>
+            <a:ext cx="7315200" cy="292608"/>
+          </a:xfrm>
+          <a:prstGeom prst="rect">
+            <a:avLst/>
+          </a:prstGeom>
+          <a:noFill/>
+          <a:ln/>
+        </p:spPr>
+        <p:txBody>
+          <a:bodyPr wrap="square" rtlCol="0" anchor="t"/>
+          <a:lstStyle/>
+          <a:p>
+            <a:pPr indent="0" marL="0">
+              <a:buNone/>
+            </a:pPr>
+            <a:r>
+              <a:rPr lang="en-US" sz="1250" b="1" dirty="0">
+                <a:solidFill>
+                  <a:srgbClr val="333333"/>
+                </a:solidFill>
+                <a:latin typeface="Aptos" pitchFamily="34" charset="0"/>
+                <a:ea typeface="Aptos" pitchFamily="34" charset="-122"/>
+                <a:cs typeface="Aptos" pitchFamily="34" charset="-120"/>
+              </a:rPr>
+              <a:t>Quick fixes often work briefly.</a:t>
+            </a:r>
+            <a:endParaRPr lang="en-US" sz="1250" dirty="0"/>
+          </a:p>
+        </p:txBody>
+      </p:sp>
+      <p:sp>
+        <p:nvSpPr>
+          <p:cNvPr id="6" name="Text 4"/>
+          <p:cNvSpPr/>
+          <p:nvPr/>
+        </p:nvSpPr>
+        <p:spPr>
+          <a:xfrm>
+            <a:off x="914400" y="1929384"/>
+            <a:ext cx="7315200" cy="292608"/>
+          </a:xfrm>
+          <a:prstGeom prst="rect">
+            <a:avLst/>
+          </a:prstGeom>
+          <a:noFill/>
+          <a:ln/>
+        </p:spPr>
+        <p:txBody>
+          <a:bodyPr wrap="square" rtlCol="0" anchor="t"/>
+          <a:lstStyle/>
+          <a:p>
+            <a:pPr indent="0" marL="0">
+              <a:buNone/>
+            </a:pPr>
+            <a:r>
+              <a:rPr lang="en-US" sz="1250" dirty="0">
+                <a:solidFill>
+                  <a:srgbClr val="333333"/>
+                </a:solidFill>
+                <a:latin typeface="Aptos" pitchFamily="34" charset="0"/>
+                <a:ea typeface="Aptos" pitchFamily="34" charset="-122"/>
+                <a:cs typeface="Aptos" pitchFamily="34" charset="-120"/>
+              </a:rPr>
+              <a:t>When capacity drops, they collapse and reinforce a sense of failure.</a:t>
+            </a:r>
+            <a:endParaRPr lang="en-US" sz="1250" dirty="0"/>
+          </a:p>
+        </p:txBody>
+      </p:sp>
+      <p:sp>
+        <p:nvSpPr>
+          <p:cNvPr id="7" name="Text 5"/>
+          <p:cNvSpPr/>
+          <p:nvPr/>
+        </p:nvSpPr>
+        <p:spPr>
+          <a:xfrm>
+            <a:off x="914400" y="2295144"/>
+            <a:ext cx="7315200" cy="292608"/>
+          </a:xfrm>
+          <a:prstGeom prst="rect">
+            <a:avLst/>
+          </a:prstGeom>
+          <a:noFill/>
+          <a:ln/>
+        </p:spPr>
+        <p:txBody>
+          <a:bodyPr wrap="square" rtlCol="0" anchor="t"/>
+          <a:lstStyle/>
+          <a:p>
+            <a:pPr indent="0" marL="0">
+              <a:buNone/>
+            </a:pPr>
+            <a:r>
+              <a:rPr lang="en-US" sz="1250" b="1" dirty="0">
+                <a:solidFill>
+                  <a:srgbClr val="333333"/>
+                </a:solidFill>
+                <a:latin typeface="Aptos" pitchFamily="34" charset="0"/>
+                <a:ea typeface="Aptos" pitchFamily="34" charset="-122"/>
+                <a:cs typeface="Aptos" pitchFamily="34" charset="-120"/>
+              </a:rPr>
+              <a:t>Many people are motivated and capable.</a:t>
+            </a:r>
+            <a:endParaRPr lang="en-US" sz="1250" dirty="0"/>
+          </a:p>
+        </p:txBody>
+      </p:sp>
+      <p:sp>
+        <p:nvSpPr>
+          <p:cNvPr id="8" name="Text 6"/>
+          <p:cNvSpPr/>
+          <p:nvPr/>
+        </p:nvSpPr>
+        <p:spPr>
+          <a:xfrm>
+            <a:off x="914400" y="2551176"/>
+            <a:ext cx="7315200" cy="292608"/>
+          </a:xfrm>
+          <a:prstGeom prst="rect">
+            <a:avLst/>
+          </a:prstGeom>
+          <a:noFill/>
+          <a:ln/>
+        </p:spPr>
+        <p:txBody>
+          <a:bodyPr wrap="square" rtlCol="0" anchor="t"/>
+          <a:lstStyle/>
+          <a:p>
+            <a:pPr indent="0" marL="0">
+              <a:buNone/>
+            </a:pPr>
+            <a:r>
+              <a:rPr lang="en-US" sz="1250" dirty="0">
+                <a:solidFill>
+                  <a:srgbClr val="333333"/>
+                </a:solidFill>
+                <a:latin typeface="Aptos" pitchFamily="34" charset="0"/>
+                <a:ea typeface="Aptos" pitchFamily="34" charset="-122"/>
+                <a:cs typeface="Aptos" pitchFamily="34" charset="-120"/>
+              </a:rPr>
+              <a:t>They can still resist goals when those goals feel restrictive.</a:t>
+            </a:r>
+            <a:endParaRPr lang="en-US" sz="1250" dirty="0"/>
+          </a:p>
+        </p:txBody>
+      </p:sp>
+      <p:sp>
+        <p:nvSpPr>
+          <p:cNvPr id="9" name="Text 7"/>
+          <p:cNvSpPr/>
+          <p:nvPr/>
+        </p:nvSpPr>
+        <p:spPr>
+          <a:xfrm>
+            <a:off x="914400" y="2916936"/>
+            <a:ext cx="7315200" cy="292608"/>
+          </a:xfrm>
+          <a:prstGeom prst="rect">
+            <a:avLst/>
+          </a:prstGeom>
+          <a:noFill/>
+          <a:ln/>
+        </p:spPr>
+        <p:txBody>
+          <a:bodyPr wrap="square" rtlCol="0" anchor="t"/>
+          <a:lstStyle/>
+          <a:p>
+            <a:pPr indent="0" marL="0">
+              <a:buNone/>
+            </a:pPr>
+            <a:r>
+              <a:rPr lang="en-US" sz="1250" b="1" dirty="0">
+                <a:solidFill>
+                  <a:srgbClr val="333333"/>
+                </a:solidFill>
+                <a:latin typeface="Aptos" pitchFamily="34" charset="0"/>
+                <a:ea typeface="Aptos" pitchFamily="34" charset="-122"/>
+                <a:cs typeface="Aptos" pitchFamily="34" charset="-120"/>
+              </a:rPr>
+              <a:t>People still need anchoring.</a:t>
+            </a:r>
+            <a:endParaRPr lang="en-US" sz="1250" dirty="0"/>
+          </a:p>
+        </p:txBody>
+      </p:sp>
+      <p:sp>
+        <p:nvSpPr>
+          <p:cNvPr id="10" name="Text 8"/>
+          <p:cNvSpPr/>
+          <p:nvPr/>
+        </p:nvSpPr>
+        <p:spPr>
+          <a:xfrm>
+            <a:off x="914400" y="3172968"/>
+            <a:ext cx="7315200" cy="292608"/>
+          </a:xfrm>
+          <a:prstGeom prst="rect">
+            <a:avLst/>
+          </a:prstGeom>
+          <a:noFill/>
+          <a:ln/>
+        </p:spPr>
+        <p:txBody>
+          <a:bodyPr wrap="square" rtlCol="0" anchor="t"/>
+          <a:lstStyle/>
+          <a:p>
+            <a:pPr indent="0" marL="0">
+              <a:buNone/>
+            </a:pPr>
+            <a:r>
+              <a:rPr lang="en-US" sz="1250" dirty="0">
                 <a:solidFill>
                   <a:srgbClr val="333333"/>
                 </a:solidFill>
@@ -2942,24 +3476,24 @@
               </a:rPr>
               <a:t>A small number of steady points the nervous system can rely on week to week.</a:t>
             </a:r>
-            <a:endParaRPr lang="en-US" sz="1300" dirty="0"/>
-          </a:p>
-        </p:txBody>
-      </p:sp>
-      <p:sp>
-        <p:nvSpPr>
-          <p:cNvPr id="4" name="Shape 2"/>
-          <p:cNvSpPr/>
-          <p:nvPr/>
-        </p:nvSpPr>
-        <p:spPr>
-          <a:xfrm>
-            <a:off x="548640" y="3749040"/>
-            <a:ext cx="8046720" cy="548640"/>
+            <a:endParaRPr lang="en-US" sz="1250" dirty="0"/>
+          </a:p>
+        </p:txBody>
+      </p:sp>
+      <p:sp>
+        <p:nvSpPr>
+          <p:cNvPr id="11" name="Shape 9"/>
+          <p:cNvSpPr/>
+          <p:nvPr/>
+        </p:nvSpPr>
+        <p:spPr>
+          <a:xfrm>
+            <a:off x="914400" y="3611880"/>
+            <a:ext cx="7315200" cy="640080"/>
           </a:xfrm>
           <a:prstGeom prst="rect">
             <a:avLst>
-              <a:gd name="adj" fmla="val 8333"/>
+              <a:gd name="adj" fmla="val 5714"/>
             </a:avLst>
           </a:prstGeom>
           <a:solidFill>
@@ -2975,33 +3509,30 @@
       </p:sp>
       <p:sp>
         <p:nvSpPr>
-          <p:cNvPr id="5" name="Text 3"/>
-          <p:cNvSpPr/>
-          <p:nvPr/>
-        </p:nvSpPr>
-        <p:spPr>
-          <a:xfrm>
-            <a:off x="731520" y="3840480"/>
-            <a:ext cx="7680960" cy="365760"/>
-          </a:xfrm>
-          <a:prstGeom prst="rect">
-            <a:avLst/>
-          </a:prstGeom>
-          <a:noFill/>
-          <a:ln/>
-        </p:spPr>
-        <p:txBody>
-          <a:bodyPr wrap="square" rtlCol="0" anchor="t"/>
-          <a:lstStyle/>
-          <a:p>
-            <a:pPr indent="0" marL="0">
-              <a:lnSpc>
-                <a:spcPct val="130000"/>
-              </a:lnSpc>
-              <a:buNone/>
-            </a:pPr>
-            <a:r>
-              <a:rPr lang="en-US" sz="1100" b="1" dirty="0">
+          <p:cNvPr id="12" name="Text 10"/>
+          <p:cNvSpPr/>
+          <p:nvPr/>
+        </p:nvSpPr>
+        <p:spPr>
+          <a:xfrm>
+            <a:off x="1051560" y="3685032"/>
+            <a:ext cx="7040880" cy="182880"/>
+          </a:xfrm>
+          <a:prstGeom prst="rect">
+            <a:avLst/>
+          </a:prstGeom>
+          <a:noFill/>
+          <a:ln/>
+        </p:spPr>
+        <p:txBody>
+          <a:bodyPr wrap="square" rtlCol="0" anchor="t"/>
+          <a:lstStyle/>
+          <a:p>
+            <a:pPr indent="0" marL="0">
+              <a:buNone/>
+            </a:pPr>
+            <a:r>
+              <a:rPr lang="en-US" sz="1050" b="1" dirty="0">
                 <a:solidFill>
                   <a:srgbClr val="003366"/>
                 </a:solidFill>
@@ -3009,17 +3540,38 @@
                 <a:ea typeface="Aptos" pitchFamily="34" charset="-122"/>
                 <a:cs typeface="Aptos" pitchFamily="34" charset="-120"/>
               </a:rPr>
-              <a:t>Discussion prompt:
-</a:t>
-            </a:r>
-            <a:pPr indent="0" marL="0">
-              <a:lnSpc>
-                <a:spcPct val="130000"/>
-              </a:lnSpc>
-              <a:buNone/>
-            </a:pPr>
-            <a:r>
-              <a:rPr lang="en-US" sz="1100" i="1" dirty="0">
+              <a:t>Discussion prompt:</a:t>
+            </a:r>
+            <a:endParaRPr lang="en-US" sz="1050" dirty="0"/>
+          </a:p>
+        </p:txBody>
+      </p:sp>
+      <p:sp>
+        <p:nvSpPr>
+          <p:cNvPr id="13" name="Text 11"/>
+          <p:cNvSpPr/>
+          <p:nvPr/>
+        </p:nvSpPr>
+        <p:spPr>
+          <a:xfrm>
+            <a:off x="1051560" y="3886200"/>
+            <a:ext cx="7040880" cy="292608"/>
+          </a:xfrm>
+          <a:prstGeom prst="rect">
+            <a:avLst/>
+          </a:prstGeom>
+          <a:noFill/>
+          <a:ln/>
+        </p:spPr>
+        <p:txBody>
+          <a:bodyPr wrap="square" rtlCol="0" anchor="t"/>
+          <a:lstStyle/>
+          <a:p>
+            <a:pPr indent="0" marL="0">
+              <a:buNone/>
+            </a:pPr>
+            <a:r>
+              <a:rPr lang="en-US" sz="1050" i="1" dirty="0">
                 <a:solidFill>
                   <a:srgbClr val="333333"/>
                 </a:solidFill>
@@ -3029,7 +3581,7 @@
               </a:rPr>
               <a:t>What works briefly for clients, then collapses when capacity drops?</a:t>
             </a:r>
-            <a:endParaRPr lang="en-US" sz="1100" dirty="0"/>
+            <a:endParaRPr lang="en-US" sz="1050" dirty="0"/>
           </a:p>
         </p:txBody>
       </p:sp>
@@ -3073,24 +3625,24 @@
         </p:nvSpPr>
         <p:spPr>
           <a:xfrm>
-            <a:off x="548640" y="365760"/>
-            <a:ext cx="8046720" cy="457200"/>
-          </a:xfrm>
-          <a:prstGeom prst="rect">
-            <a:avLst/>
-          </a:prstGeom>
-          <a:noFill/>
-          <a:ln/>
-        </p:spPr>
-        <p:txBody>
-          <a:bodyPr wrap="square" rtlCol="0" anchor="ctr"/>
-          <a:lstStyle/>
-          <a:p>
-            <a:pPr indent="0" marL="0">
-              <a:buNone/>
-            </a:pPr>
-            <a:r>
-              <a:rPr lang="en-US" sz="2400" b="1" dirty="0">
+            <a:off x="914400" y="457200"/>
+            <a:ext cx="7315200" cy="411480"/>
+          </a:xfrm>
+          <a:prstGeom prst="rect">
+            <a:avLst/>
+          </a:prstGeom>
+          <a:noFill/>
+          <a:ln/>
+        </p:spPr>
+        <p:txBody>
+          <a:bodyPr wrap="square" rtlCol="0" anchor="t"/>
+          <a:lstStyle/>
+          <a:p>
+            <a:pPr indent="0" marL="0">
+              <a:buNone/>
+            </a:pPr>
+            <a:r>
+              <a:rPr lang="en-US" sz="2200" b="1" dirty="0">
                 <a:solidFill>
                   <a:srgbClr val="003366"/>
                 </a:solidFill>
@@ -3100,7 +3652,7 @@
               </a:rPr>
               <a:t>Introducing SAFE as a response framework</a:t>
             </a:r>
-            <a:endParaRPr lang="en-US" sz="2400" dirty="0"/>
+            <a:endParaRPr lang="en-US" sz="2200" dirty="0"/>
           </a:p>
         </p:txBody>
       </p:sp>
@@ -3112,81 +3664,141 @@
         </p:nvSpPr>
         <p:spPr>
           <a:xfrm>
-            <a:off x="548640" y="1005840"/>
-            <a:ext cx="8046720" cy="2011680"/>
-          </a:xfrm>
-          <a:prstGeom prst="rect">
-            <a:avLst/>
-          </a:prstGeom>
-          <a:noFill/>
-          <a:ln/>
-        </p:spPr>
-        <p:txBody>
-          <a:bodyPr wrap="square" rtlCol="0" anchor="t"/>
-          <a:lstStyle/>
-          <a:p>
-            <a:pPr indent="0" marL="0">
-              <a:lnSpc>
-                <a:spcPct val="135000"/>
-              </a:lnSpc>
-              <a:buNone/>
-            </a:pPr>
-            <a:r>
-              <a:rPr lang="en-US" sz="1300" dirty="0">
-                <a:solidFill>
-                  <a:srgbClr val="333333"/>
-                </a:solidFill>
-                <a:latin typeface="Aptos" pitchFamily="34" charset="0"/>
-                <a:ea typeface="Aptos" pitchFamily="34" charset="-122"/>
-                <a:cs typeface="Aptos" pitchFamily="34" charset="-120"/>
-              </a:rPr>
-              <a:t>SAFE is how I organise my response when capacity is under pressure.
-</a:t>
-            </a:r>
-            <a:pPr indent="0" marL="0">
-              <a:lnSpc>
-                <a:spcPct val="135000"/>
-              </a:lnSpc>
-              <a:buNone/>
-            </a:pPr>
-            <a:r>
-              <a:rPr lang="en-US" sz="1300" dirty="0">
-                <a:solidFill>
-                  <a:srgbClr val="333333"/>
-                </a:solidFill>
-                <a:latin typeface="Aptos" pitchFamily="34" charset="0"/>
-                <a:ea typeface="Aptos" pitchFamily="34" charset="-122"/>
-                <a:cs typeface="Aptos" pitchFamily="34" charset="-120"/>
-              </a:rPr>
-              <a:t>It is not a diagnostic model.
-</a:t>
-            </a:r>
-            <a:pPr indent="0" marL="0">
-              <a:lnSpc>
-                <a:spcPct val="135000"/>
-              </a:lnSpc>
-              <a:buNone/>
-            </a:pPr>
-            <a:r>
-              <a:rPr lang="en-US" sz="1300" dirty="0">
-                <a:solidFill>
-                  <a:srgbClr val="333333"/>
-                </a:solidFill>
-                <a:latin typeface="Aptos" pitchFamily="34" charset="0"/>
-                <a:ea typeface="Aptos" pitchFamily="34" charset="-122"/>
-                <a:cs typeface="Aptos" pitchFamily="34" charset="-120"/>
-              </a:rPr>
-              <a:t>It is not something I am asking you to adopt.
-</a:t>
-            </a:r>
-            <a:pPr indent="0" marL="0">
-              <a:lnSpc>
-                <a:spcPct val="135000"/>
-              </a:lnSpc>
-              <a:buNone/>
-            </a:pPr>
-            <a:r>
-              <a:rPr lang="en-US" sz="1300" dirty="0">
+            <a:off x="914400" y="1051560"/>
+            <a:ext cx="7315200" cy="292608"/>
+          </a:xfrm>
+          <a:prstGeom prst="rect">
+            <a:avLst/>
+          </a:prstGeom>
+          <a:noFill/>
+          <a:ln/>
+        </p:spPr>
+        <p:txBody>
+          <a:bodyPr wrap="square" rtlCol="0" anchor="t"/>
+          <a:lstStyle/>
+          <a:p>
+            <a:pPr indent="0" marL="0">
+              <a:buNone/>
+            </a:pPr>
+            <a:r>
+              <a:rPr lang="en-US" sz="1250" dirty="0">
+                <a:solidFill>
+                  <a:srgbClr val="333333"/>
+                </a:solidFill>
+                <a:latin typeface="Aptos" pitchFamily="34" charset="0"/>
+                <a:ea typeface="Aptos" pitchFamily="34" charset="-122"/>
+                <a:cs typeface="Aptos" pitchFamily="34" charset="-120"/>
+              </a:rPr>
+              <a:t>SAFE is how I organise my response when capacity is under pressure.</a:t>
+            </a:r>
+            <a:endParaRPr lang="en-US" sz="1250" dirty="0"/>
+          </a:p>
+        </p:txBody>
+      </p:sp>
+      <p:sp>
+        <p:nvSpPr>
+          <p:cNvPr id="4" name="Text 2"/>
+          <p:cNvSpPr/>
+          <p:nvPr/>
+        </p:nvSpPr>
+        <p:spPr>
+          <a:xfrm>
+            <a:off x="914400" y="1490472"/>
+            <a:ext cx="7315200" cy="292608"/>
+          </a:xfrm>
+          <a:prstGeom prst="rect">
+            <a:avLst/>
+          </a:prstGeom>
+          <a:noFill/>
+          <a:ln/>
+        </p:spPr>
+        <p:txBody>
+          <a:bodyPr wrap="square" rtlCol="0" anchor="t"/>
+          <a:lstStyle/>
+          <a:p>
+            <a:pPr indent="0" marL="0">
+              <a:buNone/>
+            </a:pPr>
+            <a:r>
+              <a:rPr lang="en-US" sz="1250" dirty="0">
+                <a:solidFill>
+                  <a:srgbClr val="333333"/>
+                </a:solidFill>
+                <a:latin typeface="Aptos" pitchFamily="34" charset="0"/>
+                <a:ea typeface="Aptos" pitchFamily="34" charset="-122"/>
+                <a:cs typeface="Aptos" pitchFamily="34" charset="-120"/>
+              </a:rPr>
+              <a:t>It is not a diagnostic model.</a:t>
+            </a:r>
+            <a:endParaRPr lang="en-US" sz="1250" dirty="0"/>
+          </a:p>
+        </p:txBody>
+      </p:sp>
+      <p:sp>
+        <p:nvSpPr>
+          <p:cNvPr id="5" name="Text 3"/>
+          <p:cNvSpPr/>
+          <p:nvPr/>
+        </p:nvSpPr>
+        <p:spPr>
+          <a:xfrm>
+            <a:off x="914400" y="1746504"/>
+            <a:ext cx="7315200" cy="292608"/>
+          </a:xfrm>
+          <a:prstGeom prst="rect">
+            <a:avLst/>
+          </a:prstGeom>
+          <a:noFill/>
+          <a:ln/>
+        </p:spPr>
+        <p:txBody>
+          <a:bodyPr wrap="square" rtlCol="0" anchor="t"/>
+          <a:lstStyle/>
+          <a:p>
+            <a:pPr indent="0" marL="0">
+              <a:buNone/>
+            </a:pPr>
+            <a:r>
+              <a:rPr lang="en-US" sz="1250" dirty="0">
+                <a:solidFill>
+                  <a:srgbClr val="333333"/>
+                </a:solidFill>
+                <a:latin typeface="Aptos" pitchFamily="34" charset="0"/>
+                <a:ea typeface="Aptos" pitchFamily="34" charset="-122"/>
+                <a:cs typeface="Aptos" pitchFamily="34" charset="-120"/>
+              </a:rPr>
+              <a:t>It is not something I am asking you to adopt.</a:t>
+            </a:r>
+            <a:endParaRPr lang="en-US" sz="1250" dirty="0"/>
+          </a:p>
+        </p:txBody>
+      </p:sp>
+      <p:sp>
+        <p:nvSpPr>
+          <p:cNvPr id="6" name="Text 4"/>
+          <p:cNvSpPr/>
+          <p:nvPr/>
+        </p:nvSpPr>
+        <p:spPr>
+          <a:xfrm>
+            <a:off x="914400" y="2185416"/>
+            <a:ext cx="7315200" cy="292608"/>
+          </a:xfrm>
+          <a:prstGeom prst="rect">
+            <a:avLst/>
+          </a:prstGeom>
+          <a:noFill/>
+          <a:ln/>
+        </p:spPr>
+        <p:txBody>
+          <a:bodyPr wrap="square" rtlCol="0" anchor="t"/>
+          <a:lstStyle/>
+          <a:p>
+            <a:pPr indent="0" marL="0">
+              <a:buNone/>
+            </a:pPr>
+            <a:r>
+              <a:rPr lang="en-US" sz="1250" dirty="0">
                 <a:solidFill>
                   <a:srgbClr val="333333"/>
                 </a:solidFill>
@@ -3196,17 +3808,36 @@
               </a:rPr>
               <a:t>It is one way to provide structure without restriction</a:t>
             </a:r>
-            <a:endParaRPr lang="en-US" sz="1300" dirty="0"/>
-          </a:p>
-          <a:p>
-            <a:pPr indent="0" marL="0">
-              <a:lnSpc>
-                <a:spcPct val="135000"/>
-              </a:lnSpc>
-              <a:buNone/>
-            </a:pPr>
-            <a:r>
-              <a:rPr lang="en-US" sz="1300" dirty="0">
+            <a:endParaRPr lang="en-US" sz="1250" dirty="0"/>
+          </a:p>
+        </p:txBody>
+      </p:sp>
+      <p:sp>
+        <p:nvSpPr>
+          <p:cNvPr id="7" name="Text 5"/>
+          <p:cNvSpPr/>
+          <p:nvPr/>
+        </p:nvSpPr>
+        <p:spPr>
+          <a:xfrm>
+            <a:off x="914400" y="2441448"/>
+            <a:ext cx="7315200" cy="292608"/>
+          </a:xfrm>
+          <a:prstGeom prst="rect">
+            <a:avLst/>
+          </a:prstGeom>
+          <a:noFill/>
+          <a:ln/>
+        </p:spPr>
+        <p:txBody>
+          <a:bodyPr wrap="square" rtlCol="0" anchor="t"/>
+          <a:lstStyle/>
+          <a:p>
+            <a:pPr indent="0" marL="0">
+              <a:buNone/>
+            </a:pPr>
+            <a:r>
+              <a:rPr lang="en-US" sz="1250" dirty="0">
                 <a:solidFill>
                   <a:srgbClr val="333333"/>
                 </a:solidFill>
@@ -3216,24 +3847,24 @@
               </a:rPr>
               <a:t>and anchoring without pressure.</a:t>
             </a:r>
-            <a:endParaRPr lang="en-US" sz="1300" dirty="0"/>
-          </a:p>
-        </p:txBody>
-      </p:sp>
-      <p:sp>
-        <p:nvSpPr>
-          <p:cNvPr id="4" name="Shape 2"/>
-          <p:cNvSpPr/>
-          <p:nvPr/>
-        </p:nvSpPr>
-        <p:spPr>
-          <a:xfrm>
-            <a:off x="548640" y="3246120"/>
-            <a:ext cx="8046720" cy="685800"/>
+            <a:endParaRPr lang="en-US" sz="1250" dirty="0"/>
+          </a:p>
+        </p:txBody>
+      </p:sp>
+      <p:sp>
+        <p:nvSpPr>
+          <p:cNvPr id="8" name="Shape 6"/>
+          <p:cNvSpPr/>
+          <p:nvPr/>
+        </p:nvSpPr>
+        <p:spPr>
+          <a:xfrm>
+            <a:off x="914400" y="3063240"/>
+            <a:ext cx="7315200" cy="804672"/>
           </a:xfrm>
           <a:prstGeom prst="rect">
             <a:avLst>
-              <a:gd name="adj" fmla="val 6667"/>
+              <a:gd name="adj" fmla="val 4545"/>
             </a:avLst>
           </a:prstGeom>
           <a:solidFill>
@@ -3249,33 +3880,30 @@
       </p:sp>
       <p:sp>
         <p:nvSpPr>
-          <p:cNvPr id="5" name="Text 3"/>
-          <p:cNvSpPr/>
-          <p:nvPr/>
-        </p:nvSpPr>
-        <p:spPr>
-          <a:xfrm>
-            <a:off x="731520" y="3337560"/>
-            <a:ext cx="7680960" cy="502920"/>
-          </a:xfrm>
-          <a:prstGeom prst="rect">
-            <a:avLst/>
-          </a:prstGeom>
-          <a:noFill/>
-          <a:ln/>
-        </p:spPr>
-        <p:txBody>
-          <a:bodyPr wrap="square" rtlCol="0" anchor="t"/>
-          <a:lstStyle/>
-          <a:p>
-            <a:pPr indent="0" marL="0">
-              <a:lnSpc>
-                <a:spcPct val="130000"/>
-              </a:lnSpc>
-              <a:buNone/>
-            </a:pPr>
-            <a:r>
-              <a:rPr lang="en-US" sz="1100" b="1" dirty="0">
+          <p:cNvPr id="9" name="Text 7"/>
+          <p:cNvSpPr/>
+          <p:nvPr/>
+        </p:nvSpPr>
+        <p:spPr>
+          <a:xfrm>
+            <a:off x="1051560" y="3136392"/>
+            <a:ext cx="7040880" cy="182880"/>
+          </a:xfrm>
+          <a:prstGeom prst="rect">
+            <a:avLst/>
+          </a:prstGeom>
+          <a:noFill/>
+          <a:ln/>
+        </p:spPr>
+        <p:txBody>
+          <a:bodyPr wrap="square" rtlCol="0" anchor="t"/>
+          <a:lstStyle/>
+          <a:p>
+            <a:pPr indent="0" marL="0">
+              <a:buNone/>
+            </a:pPr>
+            <a:r>
+              <a:rPr lang="en-US" sz="1050" b="1" dirty="0">
                 <a:solidFill>
                   <a:srgbClr val="003366"/>
                 </a:solidFill>
@@ -3283,27 +3911,65 @@
                 <a:ea typeface="Aptos" pitchFamily="34" charset="-122"/>
                 <a:cs typeface="Aptos" pitchFamily="34" charset="-120"/>
               </a:rPr>
-              <a:t>Reflection before the video:
-</a:t>
-            </a:r>
-            <a:pPr indent="0" marL="0">
-              <a:lnSpc>
-                <a:spcPct val="130000"/>
-              </a:lnSpc>
-              <a:buNone/>
-            </a:pPr>
-            <a:r>
-              <a:rPr lang="en-US" sz="1100" i="1" dirty="0">
-                <a:solidFill>
-                  <a:srgbClr val="333333"/>
-                </a:solidFill>
-                <a:latin typeface="Aptos" pitchFamily="34" charset="0"/>
-                <a:ea typeface="Aptos" pitchFamily="34" charset="-122"/>
-                <a:cs typeface="Aptos" pitchFamily="34" charset="-120"/>
-              </a:rPr>
-              <a:t>What feels useful, what needs care, and what language would make it more neurodivergence-affirming?</a:t>
-            </a:r>
-            <a:endParaRPr lang="en-US" sz="1100" dirty="0"/>
+              <a:t>Reflection before the video:</a:t>
+            </a:r>
+            <a:endParaRPr lang="en-US" sz="1050" dirty="0"/>
+          </a:p>
+        </p:txBody>
+      </p:sp>
+      <p:sp>
+        <p:nvSpPr>
+          <p:cNvPr id="10" name="Text 8"/>
+          <p:cNvSpPr/>
+          <p:nvPr/>
+        </p:nvSpPr>
+        <p:spPr>
+          <a:xfrm>
+            <a:off x="1051560" y="3337560"/>
+            <a:ext cx="7040880" cy="457200"/>
+          </a:xfrm>
+          <a:prstGeom prst="rect">
+            <a:avLst/>
+          </a:prstGeom>
+          <a:noFill/>
+          <a:ln/>
+        </p:spPr>
+        <p:txBody>
+          <a:bodyPr wrap="square" rtlCol="0" anchor="t"/>
+          <a:lstStyle/>
+          <a:p>
+            <a:pPr indent="0" marL="0">
+              <a:buNone/>
+            </a:pPr>
+            <a:r>
+              <a:rPr lang="en-US" sz="1050" i="1" dirty="0">
+                <a:solidFill>
+                  <a:srgbClr val="333333"/>
+                </a:solidFill>
+                <a:latin typeface="Aptos" pitchFamily="34" charset="0"/>
+                <a:ea typeface="Aptos" pitchFamily="34" charset="-122"/>
+                <a:cs typeface="Aptos" pitchFamily="34" charset="-120"/>
+              </a:rPr>
+              <a:t>What feels useful, what needs care, and what language would make it</a:t>
+            </a:r>
+            <a:endParaRPr lang="en-US" sz="1050" dirty="0"/>
+          </a:p>
+          <a:p>
+            <a:pPr indent="0" marL="0">
+              <a:buNone/>
+            </a:pPr>
+            <a:r>
+              <a:rPr lang="en-US" sz="1050" i="1" dirty="0">
+                <a:solidFill>
+                  <a:srgbClr val="333333"/>
+                </a:solidFill>
+                <a:latin typeface="Aptos" pitchFamily="34" charset="0"/>
+                <a:ea typeface="Aptos" pitchFamily="34" charset="-122"/>
+                <a:cs typeface="Aptos" pitchFamily="34" charset="-120"/>
+              </a:rPr>
+              <a:t>more neurodivergence-affirming?</a:t>
+            </a:r>
+            <a:endParaRPr lang="en-US" sz="1050" dirty="0"/>
           </a:p>
         </p:txBody>
       </p:sp>
@@ -3347,24 +4013,24 @@
         </p:nvSpPr>
         <p:spPr>
           <a:xfrm>
-            <a:off x="548640" y="365760"/>
-            <a:ext cx="8046720" cy="457200"/>
-          </a:xfrm>
-          <a:prstGeom prst="rect">
-            <a:avLst/>
-          </a:prstGeom>
-          <a:noFill/>
-          <a:ln/>
-        </p:spPr>
-        <p:txBody>
-          <a:bodyPr wrap="square" rtlCol="0" anchor="ctr"/>
-          <a:lstStyle/>
-          <a:p>
-            <a:pPr indent="0" marL="0">
-              <a:buNone/>
-            </a:pPr>
-            <a:r>
-              <a:rPr lang="en-US" sz="2400" b="1" dirty="0">
+            <a:off x="914400" y="457200"/>
+            <a:ext cx="7315200" cy="411480"/>
+          </a:xfrm>
+          <a:prstGeom prst="rect">
+            <a:avLst/>
+          </a:prstGeom>
+          <a:noFill/>
+          <a:ln/>
+        </p:spPr>
+        <p:txBody>
+          <a:bodyPr wrap="square" rtlCol="0" anchor="t"/>
+          <a:lstStyle/>
+          <a:p>
+            <a:pPr indent="0" marL="0">
+              <a:buNone/>
+            </a:pPr>
+            <a:r>
+              <a:rPr lang="en-US" sz="2200" b="1" dirty="0">
                 <a:solidFill>
                   <a:srgbClr val="003366"/>
                 </a:solidFill>
@@ -3374,7 +4040,7 @@
               </a:rPr>
               <a:t>SAFE video</a:t>
             </a:r>
-            <a:endParaRPr lang="en-US" sz="2400" dirty="0"/>
+            <a:endParaRPr lang="en-US" sz="2200" dirty="0"/>
           </a:p>
         </p:txBody>
       </p:sp>
@@ -3386,24 +4052,24 @@
         </p:nvSpPr>
         <p:spPr>
           <a:xfrm>
-            <a:off x="548640" y="1463040"/>
-            <a:ext cx="8046720" cy="365760"/>
-          </a:xfrm>
-          <a:prstGeom prst="rect">
-            <a:avLst/>
-          </a:prstGeom>
-          <a:noFill/>
-          <a:ln/>
-        </p:spPr>
-        <p:txBody>
-          <a:bodyPr wrap="square" rtlCol="0" anchor="ctr"/>
-          <a:lstStyle/>
-          <a:p>
-            <a:pPr indent="0" marL="0">
-              <a:buNone/>
-            </a:pPr>
-            <a:r>
-              <a:rPr lang="en-US" sz="1300" dirty="0">
+            <a:off x="914400" y="1280160"/>
+            <a:ext cx="7315200" cy="292608"/>
+          </a:xfrm>
+          <a:prstGeom prst="rect">
+            <a:avLst/>
+          </a:prstGeom>
+          <a:noFill/>
+          <a:ln/>
+        </p:spPr>
+        <p:txBody>
+          <a:bodyPr wrap="square" rtlCol="0" anchor="t"/>
+          <a:lstStyle/>
+          <a:p>
+            <a:pPr indent="0" marL="0">
+              <a:buNone/>
+            </a:pPr>
+            <a:r>
+              <a:rPr lang="en-US" sz="1250" dirty="0">
                 <a:solidFill>
                   <a:srgbClr val="333333"/>
                 </a:solidFill>
@@ -3413,7 +4079,7 @@
               </a:rPr>
               <a:t>Play the client video.</a:t>
             </a:r>
-            <a:endParaRPr lang="en-US" sz="1300" dirty="0"/>
+            <a:endParaRPr lang="en-US" sz="1250" dirty="0"/>
           </a:p>
         </p:txBody>
       </p:sp>
@@ -3425,12 +4091,12 @@
         </p:nvSpPr>
         <p:spPr>
           <a:xfrm>
-            <a:off x="548640" y="2377440"/>
-            <a:ext cx="8046720" cy="640080"/>
+            <a:off x="914400" y="2194560"/>
+            <a:ext cx="7315200" cy="640080"/>
           </a:xfrm>
           <a:prstGeom prst="rect">
             <a:avLst>
-              <a:gd name="adj" fmla="val 7143"/>
+              <a:gd name="adj" fmla="val 5714"/>
             </a:avLst>
           </a:prstGeom>
           <a:solidFill>
@@ -3452,27 +4118,24 @@
         </p:nvSpPr>
         <p:spPr>
           <a:xfrm>
-            <a:off x="731520" y="2468880"/>
-            <a:ext cx="7680960" cy="457200"/>
-          </a:xfrm>
-          <a:prstGeom prst="rect">
-            <a:avLst/>
-          </a:prstGeom>
-          <a:noFill/>
-          <a:ln/>
-        </p:spPr>
-        <p:txBody>
-          <a:bodyPr wrap="square" rtlCol="0" anchor="t"/>
-          <a:lstStyle/>
-          <a:p>
-            <a:pPr indent="0" marL="0">
-              <a:lnSpc>
-                <a:spcPct val="130000"/>
-              </a:lnSpc>
-              <a:buNone/>
-            </a:pPr>
-            <a:r>
-              <a:rPr lang="en-US" sz="1100" b="1" dirty="0">
+            <a:off x="1051560" y="2267712"/>
+            <a:ext cx="7040880" cy="182880"/>
+          </a:xfrm>
+          <a:prstGeom prst="rect">
+            <a:avLst/>
+          </a:prstGeom>
+          <a:noFill/>
+          <a:ln/>
+        </p:spPr>
+        <p:txBody>
+          <a:bodyPr wrap="square" rtlCol="0" anchor="t"/>
+          <a:lstStyle/>
+          <a:p>
+            <a:pPr indent="0" marL="0">
+              <a:buNone/>
+            </a:pPr>
+            <a:r>
+              <a:rPr lang="en-US" sz="1050" b="1" dirty="0">
                 <a:solidFill>
                   <a:srgbClr val="003366"/>
                 </a:solidFill>
@@ -3480,17 +4143,38 @@
                 <a:ea typeface="Aptos" pitchFamily="34" charset="-122"/>
                 <a:cs typeface="Aptos" pitchFamily="34" charset="-120"/>
               </a:rPr>
-              <a:t>Reflection question:
-</a:t>
-            </a:r>
-            <a:pPr indent="0" marL="0">
-              <a:lnSpc>
-                <a:spcPct val="130000"/>
-              </a:lnSpc>
-              <a:buNone/>
-            </a:pPr>
-            <a:r>
-              <a:rPr lang="en-US" sz="1100" i="1" dirty="0">
+              <a:t>Reflection question:</a:t>
+            </a:r>
+            <a:endParaRPr lang="en-US" sz="1050" dirty="0"/>
+          </a:p>
+        </p:txBody>
+      </p:sp>
+      <p:sp>
+        <p:nvSpPr>
+          <p:cNvPr id="6" name="Text 4"/>
+          <p:cNvSpPr/>
+          <p:nvPr/>
+        </p:nvSpPr>
+        <p:spPr>
+          <a:xfrm>
+            <a:off x="1051560" y="2468880"/>
+            <a:ext cx="7040880" cy="292608"/>
+          </a:xfrm>
+          <a:prstGeom prst="rect">
+            <a:avLst/>
+          </a:prstGeom>
+          <a:noFill/>
+          <a:ln/>
+        </p:spPr>
+        <p:txBody>
+          <a:bodyPr wrap="square" rtlCol="0" anchor="t"/>
+          <a:lstStyle/>
+          <a:p>
+            <a:pPr indent="0" marL="0">
+              <a:buNone/>
+            </a:pPr>
+            <a:r>
+              <a:rPr lang="en-US" sz="1050" i="1" dirty="0">
                 <a:solidFill>
                   <a:srgbClr val="333333"/>
                 </a:solidFill>
@@ -3500,7 +4184,7 @@
               </a:rPr>
               <a:t>What part of this would help a client feel more oriented this week?</a:t>
             </a:r>
-            <a:endParaRPr lang="en-US" sz="1100" dirty="0"/>
+            <a:endParaRPr lang="en-US" sz="1050" dirty="0"/>
           </a:p>
         </p:txBody>
       </p:sp>
@@ -3544,24 +4228,24 @@
         </p:nvSpPr>
         <p:spPr>
           <a:xfrm>
-            <a:off x="548640" y="365760"/>
-            <a:ext cx="8046720" cy="457200"/>
-          </a:xfrm>
-          <a:prstGeom prst="rect">
-            <a:avLst/>
-          </a:prstGeom>
-          <a:noFill/>
-          <a:ln/>
-        </p:spPr>
-        <p:txBody>
-          <a:bodyPr wrap="square" rtlCol="0" anchor="ctr"/>
-          <a:lstStyle/>
-          <a:p>
-            <a:pPr indent="0" marL="0">
-              <a:buNone/>
-            </a:pPr>
-            <a:r>
-              <a:rPr lang="en-US" sz="2400" b="1" dirty="0">
+            <a:off x="914400" y="457200"/>
+            <a:ext cx="7315200" cy="411480"/>
+          </a:xfrm>
+          <a:prstGeom prst="rect">
+            <a:avLst/>
+          </a:prstGeom>
+          <a:noFill/>
+          <a:ln/>
+        </p:spPr>
+        <p:txBody>
+          <a:bodyPr wrap="square" rtlCol="0" anchor="t"/>
+          <a:lstStyle/>
+          <a:p>
+            <a:pPr indent="0" marL="0">
+              <a:buNone/>
+            </a:pPr>
+            <a:r>
+              <a:rPr lang="en-US" sz="2200" b="1" dirty="0">
                 <a:solidFill>
                   <a:srgbClr val="003366"/>
                 </a:solidFill>
@@ -3571,7 +4255,7 @@
               </a:rPr>
               <a:t>Discussion after the video</a:t>
             </a:r>
-            <a:endParaRPr lang="en-US" sz="2400" dirty="0"/>
+            <a:endParaRPr lang="en-US" sz="2200" dirty="0"/>
           </a:p>
         </p:txBody>
       </p:sp>
@@ -3583,81 +4267,141 @@
         </p:nvSpPr>
         <p:spPr>
           <a:xfrm>
-            <a:off x="548640" y="1097280"/>
-            <a:ext cx="8046720" cy="2560320"/>
-          </a:xfrm>
-          <a:prstGeom prst="rect">
-            <a:avLst/>
-          </a:prstGeom>
-          <a:noFill/>
-          <a:ln/>
-        </p:spPr>
-        <p:txBody>
-          <a:bodyPr wrap="square" rtlCol="0" anchor="t"/>
-          <a:lstStyle/>
-          <a:p>
-            <a:pPr indent="0" marL="0">
-              <a:lnSpc>
-                <a:spcPct val="150000"/>
-              </a:lnSpc>
-              <a:buNone/>
-            </a:pPr>
-            <a:r>
-              <a:rPr lang="en-US" sz="1300" dirty="0">
-                <a:solidFill>
-                  <a:srgbClr val="333333"/>
-                </a:solidFill>
-                <a:latin typeface="Aptos" pitchFamily="34" charset="0"/>
-                <a:ea typeface="Aptos" pitchFamily="34" charset="-122"/>
-                <a:cs typeface="Aptos" pitchFamily="34" charset="-120"/>
-              </a:rPr>
-              <a:t>What matched your experience in practice?
-</a:t>
-            </a:r>
-            <a:pPr indent="0" marL="0">
-              <a:lnSpc>
-                <a:spcPct val="150000"/>
-              </a:lnSpc>
-              <a:buNone/>
-            </a:pPr>
-            <a:r>
-              <a:rPr lang="en-US" sz="1300" dirty="0">
-                <a:solidFill>
-                  <a:srgbClr val="333333"/>
-                </a:solidFill>
-                <a:latin typeface="Aptos" pitchFamily="34" charset="0"/>
-                <a:ea typeface="Aptos" pitchFamily="34" charset="-122"/>
-                <a:cs typeface="Aptos" pitchFamily="34" charset="-120"/>
-              </a:rPr>
-              <a:t>What felt vague or could be misused?
-</a:t>
-            </a:r>
-            <a:pPr indent="0" marL="0">
-              <a:lnSpc>
-                <a:spcPct val="150000"/>
-              </a:lnSpc>
-              <a:buNone/>
-            </a:pPr>
-            <a:r>
-              <a:rPr lang="en-US" sz="1300" dirty="0">
-                <a:solidFill>
-                  <a:srgbClr val="333333"/>
-                </a:solidFill>
-                <a:latin typeface="Aptos" pitchFamily="34" charset="0"/>
-                <a:ea typeface="Aptos" pitchFamily="34" charset="-122"/>
-                <a:cs typeface="Aptos" pitchFamily="34" charset="-120"/>
-              </a:rPr>
-              <a:t>What language would make it more neurodivergence-affirming?
-</a:t>
-            </a:r>
-            <a:pPr indent="0" marL="0">
-              <a:lnSpc>
-                <a:spcPct val="150000"/>
-              </a:lnSpc>
-              <a:buNone/>
-            </a:pPr>
-            <a:r>
-              <a:rPr lang="en-US" sz="1300" dirty="0">
+            <a:off x="914400" y="1188720"/>
+            <a:ext cx="7315200" cy="292608"/>
+          </a:xfrm>
+          <a:prstGeom prst="rect">
+            <a:avLst/>
+          </a:prstGeom>
+          <a:noFill/>
+          <a:ln/>
+        </p:spPr>
+        <p:txBody>
+          <a:bodyPr wrap="square" rtlCol="0" anchor="t"/>
+          <a:lstStyle/>
+          <a:p>
+            <a:pPr indent="0" marL="0">
+              <a:buNone/>
+            </a:pPr>
+            <a:r>
+              <a:rPr lang="en-US" sz="1250" dirty="0">
+                <a:solidFill>
+                  <a:srgbClr val="333333"/>
+                </a:solidFill>
+                <a:latin typeface="Aptos" pitchFamily="34" charset="0"/>
+                <a:ea typeface="Aptos" pitchFamily="34" charset="-122"/>
+                <a:cs typeface="Aptos" pitchFamily="34" charset="-120"/>
+              </a:rPr>
+              <a:t>What matched your experience in practice?</a:t>
+            </a:r>
+            <a:endParaRPr lang="en-US" sz="1250" dirty="0"/>
+          </a:p>
+        </p:txBody>
+      </p:sp>
+      <p:sp>
+        <p:nvSpPr>
+          <p:cNvPr id="4" name="Text 2"/>
+          <p:cNvSpPr/>
+          <p:nvPr/>
+        </p:nvSpPr>
+        <p:spPr>
+          <a:xfrm>
+            <a:off x="914400" y="1600200"/>
+            <a:ext cx="7315200" cy="292608"/>
+          </a:xfrm>
+          <a:prstGeom prst="rect">
+            <a:avLst/>
+          </a:prstGeom>
+          <a:noFill/>
+          <a:ln/>
+        </p:spPr>
+        <p:txBody>
+          <a:bodyPr wrap="square" rtlCol="0" anchor="t"/>
+          <a:lstStyle/>
+          <a:p>
+            <a:pPr indent="0" marL="0">
+              <a:buNone/>
+            </a:pPr>
+            <a:r>
+              <a:rPr lang="en-US" sz="1250" dirty="0">
+                <a:solidFill>
+                  <a:srgbClr val="333333"/>
+                </a:solidFill>
+                <a:latin typeface="Aptos" pitchFamily="34" charset="0"/>
+                <a:ea typeface="Aptos" pitchFamily="34" charset="-122"/>
+                <a:cs typeface="Aptos" pitchFamily="34" charset="-120"/>
+              </a:rPr>
+              <a:t>What felt vague or could be misused?</a:t>
+            </a:r>
+            <a:endParaRPr lang="en-US" sz="1250" dirty="0"/>
+          </a:p>
+        </p:txBody>
+      </p:sp>
+      <p:sp>
+        <p:nvSpPr>
+          <p:cNvPr id="5" name="Text 3"/>
+          <p:cNvSpPr/>
+          <p:nvPr/>
+        </p:nvSpPr>
+        <p:spPr>
+          <a:xfrm>
+            <a:off x="914400" y="2011680"/>
+            <a:ext cx="7315200" cy="292608"/>
+          </a:xfrm>
+          <a:prstGeom prst="rect">
+            <a:avLst/>
+          </a:prstGeom>
+          <a:noFill/>
+          <a:ln/>
+        </p:spPr>
+        <p:txBody>
+          <a:bodyPr wrap="square" rtlCol="0" anchor="t"/>
+          <a:lstStyle/>
+          <a:p>
+            <a:pPr indent="0" marL="0">
+              <a:buNone/>
+            </a:pPr>
+            <a:r>
+              <a:rPr lang="en-US" sz="1250" dirty="0">
+                <a:solidFill>
+                  <a:srgbClr val="333333"/>
+                </a:solidFill>
+                <a:latin typeface="Aptos" pitchFamily="34" charset="0"/>
+                <a:ea typeface="Aptos" pitchFamily="34" charset="-122"/>
+                <a:cs typeface="Aptos" pitchFamily="34" charset="-120"/>
+              </a:rPr>
+              <a:t>What language would make it more neurodivergence-affirming?</a:t>
+            </a:r>
+            <a:endParaRPr lang="en-US" sz="1250" dirty="0"/>
+          </a:p>
+        </p:txBody>
+      </p:sp>
+      <p:sp>
+        <p:nvSpPr>
+          <p:cNvPr id="6" name="Text 4"/>
+          <p:cNvSpPr/>
+          <p:nvPr/>
+        </p:nvSpPr>
+        <p:spPr>
+          <a:xfrm>
+            <a:off x="914400" y="2423160"/>
+            <a:ext cx="7315200" cy="292608"/>
+          </a:xfrm>
+          <a:prstGeom prst="rect">
+            <a:avLst/>
+          </a:prstGeom>
+          <a:noFill/>
+          <a:ln/>
+        </p:spPr>
+        <p:txBody>
+          <a:bodyPr wrap="square" rtlCol="0" anchor="t"/>
+          <a:lstStyle/>
+          <a:p>
+            <a:pPr indent="0" marL="0">
+              <a:buNone/>
+            </a:pPr>
+            <a:r>
+              <a:rPr lang="en-US" sz="1250" dirty="0">
                 <a:solidFill>
                   <a:srgbClr val="333333"/>
                 </a:solidFill>
@@ -3667,7 +4411,7 @@
               </a:rPr>
               <a:t>What might differ across settings and disciplines?</a:t>
             </a:r>
-            <a:endParaRPr lang="en-US" sz="1300" dirty="0"/>
+            <a:endParaRPr lang="en-US" sz="1250" dirty="0"/>
           </a:p>
         </p:txBody>
       </p:sp>
@@ -3711,24 +4455,24 @@
         </p:nvSpPr>
         <p:spPr>
           <a:xfrm>
-            <a:off x="548640" y="365760"/>
-            <a:ext cx="8046720" cy="457200"/>
-          </a:xfrm>
-          <a:prstGeom prst="rect">
-            <a:avLst/>
-          </a:prstGeom>
-          <a:noFill/>
-          <a:ln/>
-        </p:spPr>
-        <p:txBody>
-          <a:bodyPr wrap="square" rtlCol="0" anchor="ctr"/>
-          <a:lstStyle/>
-          <a:p>
-            <a:pPr indent="0" marL="0">
-              <a:buNone/>
-            </a:pPr>
-            <a:r>
-              <a:rPr lang="en-US" sz="2400" b="1" dirty="0">
+            <a:off x="914400" y="457200"/>
+            <a:ext cx="7315200" cy="411480"/>
+          </a:xfrm>
+          <a:prstGeom prst="rect">
+            <a:avLst/>
+          </a:prstGeom>
+          <a:noFill/>
+          <a:ln/>
+        </p:spPr>
+        <p:txBody>
+          <a:bodyPr wrap="square" rtlCol="0" anchor="t"/>
+          <a:lstStyle/>
+          <a:p>
+            <a:pPr indent="0" marL="0">
+              <a:buNone/>
+            </a:pPr>
+            <a:r>
+              <a:rPr lang="en-US" sz="2200" b="1" dirty="0">
                 <a:solidFill>
                   <a:srgbClr val="003366"/>
                 </a:solidFill>
@@ -3738,7 +4482,7 @@
               </a:rPr>
               <a:t>SAFE as four rooms in a house</a:t>
             </a:r>
-            <a:endParaRPr lang="en-US" sz="2400" dirty="0"/>
+            <a:endParaRPr lang="en-US" sz="2200" dirty="0"/>
           </a:p>
         </p:txBody>
       </p:sp>
@@ -3750,81 +4494,141 @@
         </p:nvSpPr>
         <p:spPr>
           <a:xfrm>
-            <a:off x="548640" y="1005840"/>
-            <a:ext cx="8046720" cy="1828800"/>
-          </a:xfrm>
-          <a:prstGeom prst="rect">
-            <a:avLst/>
-          </a:prstGeom>
-          <a:noFill/>
-          <a:ln/>
-        </p:spPr>
-        <p:txBody>
-          <a:bodyPr wrap="square" rtlCol="0" anchor="t"/>
-          <a:lstStyle/>
-          <a:p>
-            <a:pPr indent="0" marL="0">
-              <a:lnSpc>
-                <a:spcPct val="135000"/>
-              </a:lnSpc>
-              <a:buNone/>
-            </a:pPr>
-            <a:r>
-              <a:rPr lang="en-US" sz="1300" dirty="0">
-                <a:solidFill>
-                  <a:srgbClr val="333333"/>
-                </a:solidFill>
-                <a:latin typeface="Aptos" pitchFamily="34" charset="0"/>
-                <a:ea typeface="Aptos" pitchFamily="34" charset="-122"/>
-                <a:cs typeface="Aptos" pitchFamily="34" charset="-120"/>
-              </a:rPr>
-              <a:t>Think of SAFE as four rooms, not a sequence.
-</a:t>
-            </a:r>
-            <a:pPr indent="0" marL="0">
-              <a:lnSpc>
-                <a:spcPct val="135000"/>
-              </a:lnSpc>
-              <a:buNone/>
-            </a:pPr>
-            <a:r>
-              <a:rPr lang="en-US" sz="1300" dirty="0">
-                <a:solidFill>
-                  <a:srgbClr val="333333"/>
-                </a:solidFill>
-                <a:latin typeface="Aptos" pitchFamily="34" charset="0"/>
-                <a:ea typeface="Aptos" pitchFamily="34" charset="-122"/>
-                <a:cs typeface="Aptos" pitchFamily="34" charset="-120"/>
-              </a:rPr>
-              <a:t>There is no fixed order.
-</a:t>
-            </a:r>
-            <a:pPr indent="0" marL="0">
-              <a:lnSpc>
-                <a:spcPct val="135000"/>
-              </a:lnSpc>
-              <a:buNone/>
-            </a:pPr>
-            <a:r>
-              <a:rPr lang="en-US" sz="1300" dirty="0">
-                <a:solidFill>
-                  <a:srgbClr val="333333"/>
-                </a:solidFill>
-                <a:latin typeface="Aptos" pitchFamily="34" charset="0"/>
-                <a:ea typeface="Aptos" pitchFamily="34" charset="-122"/>
-                <a:cs typeface="Aptos" pitchFamily="34" charset="-120"/>
-              </a:rPr>
-              <a:t>Stabilising one room can reduce load across the whole system.
-</a:t>
-            </a:r>
-            <a:pPr indent="0" marL="0">
-              <a:lnSpc>
-                <a:spcPct val="135000"/>
-              </a:lnSpc>
-              <a:buNone/>
-            </a:pPr>
-            <a:r>
-              <a:rPr lang="en-US" sz="1300" dirty="0">
+            <a:off x="914400" y="1051560"/>
+            <a:ext cx="7315200" cy="292608"/>
+          </a:xfrm>
+          <a:prstGeom prst="rect">
+            <a:avLst/>
+          </a:prstGeom>
+          <a:noFill/>
+          <a:ln/>
+        </p:spPr>
+        <p:txBody>
+          <a:bodyPr wrap="square" rtlCol="0" anchor="t"/>
+          <a:lstStyle/>
+          <a:p>
+            <a:pPr indent="0" marL="0">
+              <a:buNone/>
+            </a:pPr>
+            <a:r>
+              <a:rPr lang="en-US" sz="1250" dirty="0">
+                <a:solidFill>
+                  <a:srgbClr val="333333"/>
+                </a:solidFill>
+                <a:latin typeface="Aptos" pitchFamily="34" charset="0"/>
+                <a:ea typeface="Aptos" pitchFamily="34" charset="-122"/>
+                <a:cs typeface="Aptos" pitchFamily="34" charset="-120"/>
+              </a:rPr>
+              <a:t>Think of SAFE as four rooms, not a sequence.</a:t>
+            </a:r>
+            <a:endParaRPr lang="en-US" sz="1250" dirty="0"/>
+          </a:p>
+        </p:txBody>
+      </p:sp>
+      <p:sp>
+        <p:nvSpPr>
+          <p:cNvPr id="4" name="Text 2"/>
+          <p:cNvSpPr/>
+          <p:nvPr/>
+        </p:nvSpPr>
+        <p:spPr>
+          <a:xfrm>
+            <a:off x="914400" y="1344168"/>
+            <a:ext cx="7315200" cy="292608"/>
+          </a:xfrm>
+          <a:prstGeom prst="rect">
+            <a:avLst/>
+          </a:prstGeom>
+          <a:noFill/>
+          <a:ln/>
+        </p:spPr>
+        <p:txBody>
+          <a:bodyPr wrap="square" rtlCol="0" anchor="t"/>
+          <a:lstStyle/>
+          <a:p>
+            <a:pPr indent="0" marL="0">
+              <a:buNone/>
+            </a:pPr>
+            <a:r>
+              <a:rPr lang="en-US" sz="1250" dirty="0">
+                <a:solidFill>
+                  <a:srgbClr val="333333"/>
+                </a:solidFill>
+                <a:latin typeface="Aptos" pitchFamily="34" charset="0"/>
+                <a:ea typeface="Aptos" pitchFamily="34" charset="-122"/>
+                <a:cs typeface="Aptos" pitchFamily="34" charset="-120"/>
+              </a:rPr>
+              <a:t>There is no fixed order.</a:t>
+            </a:r>
+            <a:endParaRPr lang="en-US" sz="1250" dirty="0"/>
+          </a:p>
+        </p:txBody>
+      </p:sp>
+      <p:sp>
+        <p:nvSpPr>
+          <p:cNvPr id="5" name="Text 3"/>
+          <p:cNvSpPr/>
+          <p:nvPr/>
+        </p:nvSpPr>
+        <p:spPr>
+          <a:xfrm>
+            <a:off x="914400" y="1783080"/>
+            <a:ext cx="7315200" cy="292608"/>
+          </a:xfrm>
+          <a:prstGeom prst="rect">
+            <a:avLst/>
+          </a:prstGeom>
+          <a:noFill/>
+          <a:ln/>
+        </p:spPr>
+        <p:txBody>
+          <a:bodyPr wrap="square" rtlCol="0" anchor="t"/>
+          <a:lstStyle/>
+          <a:p>
+            <a:pPr indent="0" marL="0">
+              <a:buNone/>
+            </a:pPr>
+            <a:r>
+              <a:rPr lang="en-US" sz="1250" dirty="0">
+                <a:solidFill>
+                  <a:srgbClr val="333333"/>
+                </a:solidFill>
+                <a:latin typeface="Aptos" pitchFamily="34" charset="0"/>
+                <a:ea typeface="Aptos" pitchFamily="34" charset="-122"/>
+                <a:cs typeface="Aptos" pitchFamily="34" charset="-120"/>
+              </a:rPr>
+              <a:t>Stabilising one room can reduce load across the whole system.</a:t>
+            </a:r>
+            <a:endParaRPr lang="en-US" sz="1250" dirty="0"/>
+          </a:p>
+        </p:txBody>
+      </p:sp>
+      <p:sp>
+        <p:nvSpPr>
+          <p:cNvPr id="6" name="Text 4"/>
+          <p:cNvSpPr/>
+          <p:nvPr/>
+        </p:nvSpPr>
+        <p:spPr>
+          <a:xfrm>
+            <a:off x="914400" y="2221992"/>
+            <a:ext cx="7315200" cy="292608"/>
+          </a:xfrm>
+          <a:prstGeom prst="rect">
+            <a:avLst/>
+          </a:prstGeom>
+          <a:noFill/>
+          <a:ln/>
+        </p:spPr>
+        <p:txBody>
+          <a:bodyPr wrap="square" rtlCol="0" anchor="t"/>
+          <a:lstStyle/>
+          <a:p>
+            <a:pPr indent="0" marL="0">
+              <a:buNone/>
+            </a:pPr>
+            <a:r>
+              <a:rPr lang="en-US" sz="1250" dirty="0">
                 <a:solidFill>
                   <a:srgbClr val="333333"/>
                 </a:solidFill>
@@ -3834,24 +4638,24 @@
               </a:rPr>
               <a:t>Some weeks, one room functioning better is a genuine win.</a:t>
             </a:r>
-            <a:endParaRPr lang="en-US" sz="1300" dirty="0"/>
-          </a:p>
-        </p:txBody>
-      </p:sp>
-      <p:sp>
-        <p:nvSpPr>
-          <p:cNvPr id="4" name="Shape 2"/>
-          <p:cNvSpPr/>
-          <p:nvPr/>
-        </p:nvSpPr>
-        <p:spPr>
-          <a:xfrm>
-            <a:off x="548640" y="3063240"/>
-            <a:ext cx="8046720" cy="777240"/>
+            <a:endParaRPr lang="en-US" sz="1250" dirty="0"/>
+          </a:p>
+        </p:txBody>
+      </p:sp>
+      <p:sp>
+        <p:nvSpPr>
+          <p:cNvPr id="7" name="Shape 5"/>
+          <p:cNvSpPr/>
+          <p:nvPr/>
+        </p:nvSpPr>
+        <p:spPr>
+          <a:xfrm>
+            <a:off x="914400" y="2880360"/>
+            <a:ext cx="7315200" cy="804672"/>
           </a:xfrm>
           <a:prstGeom prst="rect">
             <a:avLst>
-              <a:gd name="adj" fmla="val 5882"/>
+              <a:gd name="adj" fmla="val 4545"/>
             </a:avLst>
           </a:prstGeom>
           <a:solidFill>
@@ -3867,33 +4671,30 @@
       </p:sp>
       <p:sp>
         <p:nvSpPr>
-          <p:cNvPr id="5" name="Text 3"/>
-          <p:cNvSpPr/>
-          <p:nvPr/>
-        </p:nvSpPr>
-        <p:spPr>
-          <a:xfrm>
-            <a:off x="731520" y="3154680"/>
-            <a:ext cx="7680960" cy="594360"/>
-          </a:xfrm>
-          <a:prstGeom prst="rect">
-            <a:avLst/>
-          </a:prstGeom>
-          <a:noFill/>
-          <a:ln/>
-        </p:spPr>
-        <p:txBody>
-          <a:bodyPr wrap="square" rtlCol="0" anchor="t"/>
-          <a:lstStyle/>
-          <a:p>
-            <a:pPr indent="0" marL="0">
-              <a:lnSpc>
-                <a:spcPct val="130000"/>
-              </a:lnSpc>
-              <a:buNone/>
-            </a:pPr>
-            <a:r>
-              <a:rPr lang="en-US" sz="1100" b="1" dirty="0">
+          <p:cNvPr id="8" name="Text 6"/>
+          <p:cNvSpPr/>
+          <p:nvPr/>
+        </p:nvSpPr>
+        <p:spPr>
+          <a:xfrm>
+            <a:off x="1051560" y="2953512"/>
+            <a:ext cx="7040880" cy="182880"/>
+          </a:xfrm>
+          <a:prstGeom prst="rect">
+            <a:avLst/>
+          </a:prstGeom>
+          <a:noFill/>
+          <a:ln/>
+        </p:spPr>
+        <p:txBody>
+          <a:bodyPr wrap="square" rtlCol="0" anchor="t"/>
+          <a:lstStyle/>
+          <a:p>
+            <a:pPr indent="0" marL="0">
+              <a:buNone/>
+            </a:pPr>
+            <a:r>
+              <a:rPr lang="en-US" sz="1050" b="1" dirty="0">
                 <a:solidFill>
                   <a:srgbClr val="003366"/>
                 </a:solidFill>
@@ -3901,17 +4702,38 @@
                 <a:ea typeface="Aptos" pitchFamily="34" charset="-122"/>
                 <a:cs typeface="Aptos" pitchFamily="34" charset="-120"/>
               </a:rPr>
-              <a:t>Practice reflection:
-</a:t>
-            </a:r>
-            <a:pPr indent="0" marL="0">
-              <a:lnSpc>
-                <a:spcPct val="130000"/>
-              </a:lnSpc>
-              <a:buNone/>
-            </a:pPr>
-            <a:r>
-              <a:rPr lang="en-US" sz="1100" i="1" dirty="0">
+              <a:t>Practice reflection:</a:t>
+            </a:r>
+            <a:endParaRPr lang="en-US" sz="1050" dirty="0"/>
+          </a:p>
+        </p:txBody>
+      </p:sp>
+      <p:sp>
+        <p:nvSpPr>
+          <p:cNvPr id="9" name="Text 7"/>
+          <p:cNvSpPr/>
+          <p:nvPr/>
+        </p:nvSpPr>
+        <p:spPr>
+          <a:xfrm>
+            <a:off x="1051560" y="3154680"/>
+            <a:ext cx="7040880" cy="457200"/>
+          </a:xfrm>
+          <a:prstGeom prst="rect">
+            <a:avLst/>
+          </a:prstGeom>
+          <a:noFill/>
+          <a:ln/>
+        </p:spPr>
+        <p:txBody>
+          <a:bodyPr wrap="square" rtlCol="0" anchor="t"/>
+          <a:lstStyle/>
+          <a:p>
+            <a:pPr indent="0" marL="0">
+              <a:buNone/>
+            </a:pPr>
+            <a:r>
+              <a:rPr lang="en-US" sz="1050" i="1" dirty="0">
                 <a:solidFill>
                   <a:srgbClr val="333333"/>
                 </a:solidFill>
@@ -3921,17 +4743,14 @@
               </a:rPr>
               <a:t>Using a de-identified vignette, which room is under strain first?</a:t>
             </a:r>
-            <a:endParaRPr lang="en-US" sz="1100" dirty="0"/>
-          </a:p>
-          <a:p>
-            <a:pPr indent="0" marL="0">
-              <a:lnSpc>
-                <a:spcPct val="130000"/>
-              </a:lnSpc>
-              <a:buNone/>
-            </a:pPr>
-            <a:r>
-              <a:rPr lang="en-US" sz="1100" i="1" dirty="0">
+            <a:endParaRPr lang="en-US" sz="1050" dirty="0"/>
+          </a:p>
+          <a:p>
+            <a:pPr indent="0" marL="0">
+              <a:buNone/>
+            </a:pPr>
+            <a:r>
+              <a:rPr lang="en-US" sz="1050" i="1" dirty="0">
                 <a:solidFill>
                   <a:srgbClr val="333333"/>
                 </a:solidFill>
@@ -3941,7 +4760,7 @@
               </a:rPr>
               <a:t>What helps without adding pressure?</a:t>
             </a:r>
-            <a:endParaRPr lang="en-US" sz="1100" dirty="0"/>
+            <a:endParaRPr lang="en-US" sz="1050" dirty="0"/>
           </a:p>
         </p:txBody>
       </p:sp>
@@ -3985,24 +4804,24 @@
         </p:nvSpPr>
         <p:spPr>
           <a:xfrm>
-            <a:off x="548640" y="365760"/>
-            <a:ext cx="8046720" cy="457200"/>
-          </a:xfrm>
-          <a:prstGeom prst="rect">
-            <a:avLst/>
-          </a:prstGeom>
-          <a:noFill/>
-          <a:ln/>
-        </p:spPr>
-        <p:txBody>
-          <a:bodyPr wrap="square" rtlCol="0" anchor="ctr"/>
-          <a:lstStyle/>
-          <a:p>
-            <a:pPr indent="0" marL="0">
-              <a:buNone/>
-            </a:pPr>
-            <a:r>
-              <a:rPr lang="en-US" sz="2400" b="1" dirty="0">
+            <a:off x="914400" y="457200"/>
+            <a:ext cx="7315200" cy="411480"/>
+          </a:xfrm>
+          <a:prstGeom prst="rect">
+            <a:avLst/>
+          </a:prstGeom>
+          <a:noFill/>
+          <a:ln/>
+        </p:spPr>
+        <p:txBody>
+          <a:bodyPr wrap="square" rtlCol="0" anchor="t"/>
+          <a:lstStyle/>
+          <a:p>
+            <a:pPr indent="0" marL="0">
+              <a:buNone/>
+            </a:pPr>
+            <a:r>
+              <a:rPr lang="en-US" sz="2200" b="1" dirty="0">
                 <a:solidFill>
                   <a:srgbClr val="003366"/>
                 </a:solidFill>
@@ -4012,7 +4831,7 @@
               </a:rPr>
               <a:t>How the SAFE tool works, in practice</a:t>
             </a:r>
-            <a:endParaRPr lang="en-US" sz="2400" dirty="0"/>
+            <a:endParaRPr lang="en-US" sz="2200" dirty="0"/>
           </a:p>
         </p:txBody>
       </p:sp>
@@ -4024,171 +4843,336 @@
         </p:nvSpPr>
         <p:spPr>
           <a:xfrm>
-            <a:off x="548640" y="1005840"/>
-            <a:ext cx="8046720" cy="3108960"/>
-          </a:xfrm>
-          <a:prstGeom prst="rect">
-            <a:avLst/>
-          </a:prstGeom>
-          <a:noFill/>
-          <a:ln/>
-        </p:spPr>
-        <p:txBody>
-          <a:bodyPr wrap="square" rtlCol="0" anchor="t"/>
-          <a:lstStyle/>
-          <a:p>
-            <a:pPr indent="0" marL="0">
-              <a:lnSpc>
-                <a:spcPct val="135000"/>
-              </a:lnSpc>
-              <a:buNone/>
-            </a:pPr>
-            <a:r>
-              <a:rPr lang="en-US" sz="1300" dirty="0">
-                <a:solidFill>
-                  <a:srgbClr val="333333"/>
-                </a:solidFill>
-                <a:latin typeface="Aptos" pitchFamily="34" charset="0"/>
-                <a:ea typeface="Aptos" pitchFamily="34" charset="-122"/>
-                <a:cs typeface="Aptos" pitchFamily="34" charset="-120"/>
-              </a:rPr>
-              <a:t>A weekly check-in with 20 short statements.
-</a:t>
-            </a:r>
-            <a:pPr indent="0" marL="0">
-              <a:lnSpc>
-                <a:spcPct val="135000"/>
-              </a:lnSpc>
-              <a:buNone/>
-            </a:pPr>
-            <a:r>
-              <a:rPr lang="en-US" sz="1300" dirty="0">
-                <a:solidFill>
-                  <a:srgbClr val="333333"/>
-                </a:solidFill>
-                <a:latin typeface="Aptos" pitchFamily="34" charset="0"/>
-                <a:ea typeface="Aptos" pitchFamily="34" charset="-122"/>
-                <a:cs typeface="Aptos" pitchFamily="34" charset="-120"/>
-              </a:rPr>
-              <a:t>Responses use a simple scale from never to always.
-</a:t>
-            </a:r>
-            <a:pPr indent="0" marL="0">
-              <a:lnSpc>
-                <a:spcPct val="135000"/>
-              </a:lnSpc>
-              <a:buNone/>
-            </a:pPr>
-            <a:r>
-              <a:rPr lang="en-US" sz="1300" dirty="0">
-                <a:solidFill>
-                  <a:srgbClr val="333333"/>
-                </a:solidFill>
-                <a:latin typeface="Aptos" pitchFamily="34" charset="0"/>
-                <a:ea typeface="Aptos" pitchFamily="34" charset="-122"/>
-                <a:cs typeface="Aptos" pitchFamily="34" charset="-120"/>
-              </a:rPr>
-              <a:t>It is a reflection tool, not a test or clinical assessment.
-</a:t>
-            </a:r>
-            <a:pPr indent="0" marL="0">
-              <a:lnSpc>
-                <a:spcPct val="135000"/>
-              </a:lnSpc>
-              <a:buNone/>
-            </a:pPr>
-            <a:r>
-              <a:rPr lang="en-US" sz="1300" b="1" dirty="0">
-                <a:solidFill>
-                  <a:srgbClr val="333333"/>
-                </a:solidFill>
-                <a:latin typeface="Aptos" pitchFamily="34" charset="0"/>
-                <a:ea typeface="Aptos" pitchFamily="34" charset="-122"/>
-                <a:cs typeface="Aptos" pitchFamily="34" charset="-120"/>
-              </a:rPr>
-              <a:t>The four domains are:
-</a:t>
-            </a:r>
-            <a:pPr indent="0" marL="0">
-              <a:lnSpc>
-                <a:spcPct val="135000"/>
-              </a:lnSpc>
-              <a:buNone/>
-            </a:pPr>
-            <a:r>
-              <a:rPr lang="en-US" sz="1300" dirty="0">
-                <a:solidFill>
-                  <a:srgbClr val="333333"/>
-                </a:solidFill>
-                <a:latin typeface="Aptos" pitchFamily="34" charset="0"/>
-                <a:ea typeface="Aptos" pitchFamily="34" charset="-122"/>
-                <a:cs typeface="Aptos" pitchFamily="34" charset="-120"/>
-              </a:rPr>
-              <a:t>Self Awareness
-</a:t>
-            </a:r>
-            <a:pPr indent="0" marL="0">
-              <a:lnSpc>
-                <a:spcPct val="135000"/>
-              </a:lnSpc>
-              <a:buNone/>
-            </a:pPr>
-            <a:r>
-              <a:rPr lang="en-US" sz="1300" dirty="0">
-                <a:solidFill>
-                  <a:srgbClr val="333333"/>
-                </a:solidFill>
-                <a:latin typeface="Aptos" pitchFamily="34" charset="0"/>
-                <a:ea typeface="Aptos" pitchFamily="34" charset="-122"/>
-                <a:cs typeface="Aptos" pitchFamily="34" charset="-120"/>
-              </a:rPr>
-              <a:t>Action
-</a:t>
-            </a:r>
-            <a:pPr indent="0" marL="0">
-              <a:lnSpc>
-                <a:spcPct val="135000"/>
-              </a:lnSpc>
-              <a:buNone/>
-            </a:pPr>
-            <a:r>
-              <a:rPr lang="en-US" sz="1300" dirty="0">
-                <a:solidFill>
-                  <a:srgbClr val="333333"/>
-                </a:solidFill>
-                <a:latin typeface="Aptos" pitchFamily="34" charset="0"/>
-                <a:ea typeface="Aptos" pitchFamily="34" charset="-122"/>
-                <a:cs typeface="Aptos" pitchFamily="34" charset="-120"/>
-              </a:rPr>
-              <a:t>Foundation
-</a:t>
-            </a:r>
-            <a:pPr indent="0" marL="0">
-              <a:lnSpc>
-                <a:spcPct val="135000"/>
-              </a:lnSpc>
-              <a:buNone/>
-            </a:pPr>
-            <a:r>
-              <a:rPr lang="en-US" sz="1300" dirty="0">
-                <a:solidFill>
-                  <a:srgbClr val="333333"/>
-                </a:solidFill>
-                <a:latin typeface="Aptos" pitchFamily="34" charset="0"/>
-                <a:ea typeface="Aptos" pitchFamily="34" charset="-122"/>
-                <a:cs typeface="Aptos" pitchFamily="34" charset="-120"/>
-              </a:rPr>
-              <a:t>Emotion
-</a:t>
-            </a:r>
-            <a:pPr indent="0" marL="0">
-              <a:lnSpc>
-                <a:spcPct val="135000"/>
-              </a:lnSpc>
-              <a:buNone/>
-            </a:pPr>
-            <a:r>
-              <a:rPr lang="en-US" sz="1300" dirty="0">
+            <a:off x="914400" y="1051560"/>
+            <a:ext cx="7315200" cy="292608"/>
+          </a:xfrm>
+          <a:prstGeom prst="rect">
+            <a:avLst/>
+          </a:prstGeom>
+          <a:noFill/>
+          <a:ln/>
+        </p:spPr>
+        <p:txBody>
+          <a:bodyPr wrap="square" rtlCol="0" anchor="t"/>
+          <a:lstStyle/>
+          <a:p>
+            <a:pPr indent="0" marL="0">
+              <a:buNone/>
+            </a:pPr>
+            <a:r>
+              <a:rPr lang="en-US" sz="1250" dirty="0">
+                <a:solidFill>
+                  <a:srgbClr val="333333"/>
+                </a:solidFill>
+                <a:latin typeface="Aptos" pitchFamily="34" charset="0"/>
+                <a:ea typeface="Aptos" pitchFamily="34" charset="-122"/>
+                <a:cs typeface="Aptos" pitchFamily="34" charset="-120"/>
+              </a:rPr>
+              <a:t>A weekly check-in with 20 short statements.</a:t>
+            </a:r>
+            <a:endParaRPr lang="en-US" sz="1250" dirty="0"/>
+          </a:p>
+        </p:txBody>
+      </p:sp>
+      <p:sp>
+        <p:nvSpPr>
+          <p:cNvPr id="4" name="Text 2"/>
+          <p:cNvSpPr/>
+          <p:nvPr/>
+        </p:nvSpPr>
+        <p:spPr>
+          <a:xfrm>
+            <a:off x="914400" y="1307592"/>
+            <a:ext cx="7315200" cy="292608"/>
+          </a:xfrm>
+          <a:prstGeom prst="rect">
+            <a:avLst/>
+          </a:prstGeom>
+          <a:noFill/>
+          <a:ln/>
+        </p:spPr>
+        <p:txBody>
+          <a:bodyPr wrap="square" rtlCol="0" anchor="t"/>
+          <a:lstStyle/>
+          <a:p>
+            <a:pPr indent="0" marL="0">
+              <a:buNone/>
+            </a:pPr>
+            <a:r>
+              <a:rPr lang="en-US" sz="1250" dirty="0">
+                <a:solidFill>
+                  <a:srgbClr val="333333"/>
+                </a:solidFill>
+                <a:latin typeface="Aptos" pitchFamily="34" charset="0"/>
+                <a:ea typeface="Aptos" pitchFamily="34" charset="-122"/>
+                <a:cs typeface="Aptos" pitchFamily="34" charset="-120"/>
+              </a:rPr>
+              <a:t>Responses use a simple scale from never to always.</a:t>
+            </a:r>
+            <a:endParaRPr lang="en-US" sz="1250" dirty="0"/>
+          </a:p>
+        </p:txBody>
+      </p:sp>
+      <p:sp>
+        <p:nvSpPr>
+          <p:cNvPr id="5" name="Text 3"/>
+          <p:cNvSpPr/>
+          <p:nvPr/>
+        </p:nvSpPr>
+        <p:spPr>
+          <a:xfrm>
+            <a:off x="914400" y="1563624"/>
+            <a:ext cx="7315200" cy="292608"/>
+          </a:xfrm>
+          <a:prstGeom prst="rect">
+            <a:avLst/>
+          </a:prstGeom>
+          <a:noFill/>
+          <a:ln/>
+        </p:spPr>
+        <p:txBody>
+          <a:bodyPr wrap="square" rtlCol="0" anchor="t"/>
+          <a:lstStyle/>
+          <a:p>
+            <a:pPr indent="0" marL="0">
+              <a:buNone/>
+            </a:pPr>
+            <a:r>
+              <a:rPr lang="en-US" sz="1250" dirty="0">
+                <a:solidFill>
+                  <a:srgbClr val="333333"/>
+                </a:solidFill>
+                <a:latin typeface="Aptos" pitchFamily="34" charset="0"/>
+                <a:ea typeface="Aptos" pitchFamily="34" charset="-122"/>
+                <a:cs typeface="Aptos" pitchFamily="34" charset="-120"/>
+              </a:rPr>
+              <a:t>It is a reflection tool, not a test or clinical assessment.</a:t>
+            </a:r>
+            <a:endParaRPr lang="en-US" sz="1250" dirty="0"/>
+          </a:p>
+        </p:txBody>
+      </p:sp>
+      <p:sp>
+        <p:nvSpPr>
+          <p:cNvPr id="6" name="Text 4"/>
+          <p:cNvSpPr/>
+          <p:nvPr/>
+        </p:nvSpPr>
+        <p:spPr>
+          <a:xfrm>
+            <a:off x="914400" y="2002536"/>
+            <a:ext cx="7315200" cy="292608"/>
+          </a:xfrm>
+          <a:prstGeom prst="rect">
+            <a:avLst/>
+          </a:prstGeom>
+          <a:noFill/>
+          <a:ln/>
+        </p:spPr>
+        <p:txBody>
+          <a:bodyPr wrap="square" rtlCol="0" anchor="t"/>
+          <a:lstStyle/>
+          <a:p>
+            <a:pPr indent="0" marL="0">
+              <a:buNone/>
+            </a:pPr>
+            <a:r>
+              <a:rPr lang="en-US" sz="1250" b="1" dirty="0">
+                <a:solidFill>
+                  <a:srgbClr val="333333"/>
+                </a:solidFill>
+                <a:latin typeface="Aptos" pitchFamily="34" charset="0"/>
+                <a:ea typeface="Aptos" pitchFamily="34" charset="-122"/>
+                <a:cs typeface="Aptos" pitchFamily="34" charset="-120"/>
+              </a:rPr>
+              <a:t>The four domains are:</a:t>
+            </a:r>
+            <a:endParaRPr lang="en-US" sz="1250" dirty="0"/>
+          </a:p>
+        </p:txBody>
+      </p:sp>
+      <p:sp>
+        <p:nvSpPr>
+          <p:cNvPr id="7" name="Text 5"/>
+          <p:cNvSpPr/>
+          <p:nvPr/>
+        </p:nvSpPr>
+        <p:spPr>
+          <a:xfrm>
+            <a:off x="914400" y="2258568"/>
+            <a:ext cx="7315200" cy="292608"/>
+          </a:xfrm>
+          <a:prstGeom prst="rect">
+            <a:avLst/>
+          </a:prstGeom>
+          <a:noFill/>
+          <a:ln/>
+        </p:spPr>
+        <p:txBody>
+          <a:bodyPr wrap="square" rtlCol="0" anchor="t"/>
+          <a:lstStyle/>
+          <a:p>
+            <a:pPr indent="0" marL="0">
+              <a:buNone/>
+            </a:pPr>
+            <a:r>
+              <a:rPr lang="en-US" sz="1250" dirty="0">
+                <a:solidFill>
+                  <a:srgbClr val="333333"/>
+                </a:solidFill>
+                <a:latin typeface="Aptos" pitchFamily="34" charset="0"/>
+                <a:ea typeface="Aptos" pitchFamily="34" charset="-122"/>
+                <a:cs typeface="Aptos" pitchFamily="34" charset="-120"/>
+              </a:rPr>
+              <a:t>Self Awareness</a:t>
+            </a:r>
+            <a:endParaRPr lang="en-US" sz="1250" dirty="0"/>
+          </a:p>
+        </p:txBody>
+      </p:sp>
+      <p:sp>
+        <p:nvSpPr>
+          <p:cNvPr id="8" name="Text 6"/>
+          <p:cNvSpPr/>
+          <p:nvPr/>
+        </p:nvSpPr>
+        <p:spPr>
+          <a:xfrm>
+            <a:off x="914400" y="2487168"/>
+            <a:ext cx="7315200" cy="292608"/>
+          </a:xfrm>
+          <a:prstGeom prst="rect">
+            <a:avLst/>
+          </a:prstGeom>
+          <a:noFill/>
+          <a:ln/>
+        </p:spPr>
+        <p:txBody>
+          <a:bodyPr wrap="square" rtlCol="0" anchor="t"/>
+          <a:lstStyle/>
+          <a:p>
+            <a:pPr indent="0" marL="0">
+              <a:buNone/>
+            </a:pPr>
+            <a:r>
+              <a:rPr lang="en-US" sz="1250" dirty="0">
+                <a:solidFill>
+                  <a:srgbClr val="333333"/>
+                </a:solidFill>
+                <a:latin typeface="Aptos" pitchFamily="34" charset="0"/>
+                <a:ea typeface="Aptos" pitchFamily="34" charset="-122"/>
+                <a:cs typeface="Aptos" pitchFamily="34" charset="-120"/>
+              </a:rPr>
+              <a:t>Action</a:t>
+            </a:r>
+            <a:endParaRPr lang="en-US" sz="1250" dirty="0"/>
+          </a:p>
+        </p:txBody>
+      </p:sp>
+      <p:sp>
+        <p:nvSpPr>
+          <p:cNvPr id="9" name="Text 7"/>
+          <p:cNvSpPr/>
+          <p:nvPr/>
+        </p:nvSpPr>
+        <p:spPr>
+          <a:xfrm>
+            <a:off x="914400" y="2715768"/>
+            <a:ext cx="7315200" cy="292608"/>
+          </a:xfrm>
+          <a:prstGeom prst="rect">
+            <a:avLst/>
+          </a:prstGeom>
+          <a:noFill/>
+          <a:ln/>
+        </p:spPr>
+        <p:txBody>
+          <a:bodyPr wrap="square" rtlCol="0" anchor="t"/>
+          <a:lstStyle/>
+          <a:p>
+            <a:pPr indent="0" marL="0">
+              <a:buNone/>
+            </a:pPr>
+            <a:r>
+              <a:rPr lang="en-US" sz="1250" dirty="0">
+                <a:solidFill>
+                  <a:srgbClr val="333333"/>
+                </a:solidFill>
+                <a:latin typeface="Aptos" pitchFamily="34" charset="0"/>
+                <a:ea typeface="Aptos" pitchFamily="34" charset="-122"/>
+                <a:cs typeface="Aptos" pitchFamily="34" charset="-120"/>
+              </a:rPr>
+              <a:t>Foundation</a:t>
+            </a:r>
+            <a:endParaRPr lang="en-US" sz="1250" dirty="0"/>
+          </a:p>
+        </p:txBody>
+      </p:sp>
+      <p:sp>
+        <p:nvSpPr>
+          <p:cNvPr id="10" name="Text 8"/>
+          <p:cNvSpPr/>
+          <p:nvPr/>
+        </p:nvSpPr>
+        <p:spPr>
+          <a:xfrm>
+            <a:off x="914400" y="2944368"/>
+            <a:ext cx="7315200" cy="292608"/>
+          </a:xfrm>
+          <a:prstGeom prst="rect">
+            <a:avLst/>
+          </a:prstGeom>
+          <a:noFill/>
+          <a:ln/>
+        </p:spPr>
+        <p:txBody>
+          <a:bodyPr wrap="square" rtlCol="0" anchor="t"/>
+          <a:lstStyle/>
+          <a:p>
+            <a:pPr indent="0" marL="0">
+              <a:buNone/>
+            </a:pPr>
+            <a:r>
+              <a:rPr lang="en-US" sz="1250" dirty="0">
+                <a:solidFill>
+                  <a:srgbClr val="333333"/>
+                </a:solidFill>
+                <a:latin typeface="Aptos" pitchFamily="34" charset="0"/>
+                <a:ea typeface="Aptos" pitchFamily="34" charset="-122"/>
+                <a:cs typeface="Aptos" pitchFamily="34" charset="-120"/>
+              </a:rPr>
+              <a:t>Emotion</a:t>
+            </a:r>
+            <a:endParaRPr lang="en-US" sz="1250" dirty="0"/>
+          </a:p>
+        </p:txBody>
+      </p:sp>
+      <p:sp>
+        <p:nvSpPr>
+          <p:cNvPr id="11" name="Text 9"/>
+          <p:cNvSpPr/>
+          <p:nvPr/>
+        </p:nvSpPr>
+        <p:spPr>
+          <a:xfrm>
+            <a:off x="914400" y="3337560"/>
+            <a:ext cx="7315200" cy="292608"/>
+          </a:xfrm>
+          <a:prstGeom prst="rect">
+            <a:avLst/>
+          </a:prstGeom>
+          <a:noFill/>
+          <a:ln/>
+        </p:spPr>
+        <p:txBody>
+          <a:bodyPr wrap="square" rtlCol="0" anchor="t"/>
+          <a:lstStyle/>
+          <a:p>
+            <a:pPr indent="0" marL="0">
+              <a:buNone/>
+            </a:pPr>
+            <a:r>
+              <a:rPr lang="en-US" sz="1250" dirty="0">
                 <a:solidFill>
                   <a:srgbClr val="333333"/>
                 </a:solidFill>
@@ -4198,17 +5182,36 @@
               </a:rPr>
               <a:t>It also shows capacity patterns over time,</a:t>
             </a:r>
-            <a:endParaRPr lang="en-US" sz="1300" dirty="0"/>
-          </a:p>
-          <a:p>
-            <a:pPr indent="0" marL="0">
-              <a:lnSpc>
-                <a:spcPct val="135000"/>
-              </a:lnSpc>
-              <a:buNone/>
-            </a:pPr>
-            <a:r>
-              <a:rPr lang="en-US" sz="1300" dirty="0">
+            <a:endParaRPr lang="en-US" sz="1250" dirty="0"/>
+          </a:p>
+        </p:txBody>
+      </p:sp>
+      <p:sp>
+        <p:nvSpPr>
+          <p:cNvPr id="12" name="Text 10"/>
+          <p:cNvSpPr/>
+          <p:nvPr/>
+        </p:nvSpPr>
+        <p:spPr>
+          <a:xfrm>
+            <a:off x="914400" y="3593592"/>
+            <a:ext cx="7315200" cy="292608"/>
+          </a:xfrm>
+          <a:prstGeom prst="rect">
+            <a:avLst/>
+          </a:prstGeom>
+          <a:noFill/>
+          <a:ln/>
+        </p:spPr>
+        <p:txBody>
+          <a:bodyPr wrap="square" rtlCol="0" anchor="t"/>
+          <a:lstStyle/>
+          <a:p>
+            <a:pPr indent="0" marL="0">
+              <a:buNone/>
+            </a:pPr>
+            <a:r>
+              <a:rPr lang="en-US" sz="1250" dirty="0">
                 <a:solidFill>
                   <a:srgbClr val="333333"/>
                 </a:solidFill>
@@ -4218,7 +5221,7 @@
               </a:rPr>
               <a:t>moving from chaos toward calm.</a:t>
             </a:r>
-            <a:endParaRPr lang="en-US" sz="1300" dirty="0"/>
+            <a:endParaRPr lang="en-US" sz="1250" dirty="0"/>
           </a:p>
         </p:txBody>
       </p:sp>

</xml_diff>